<commit_message>
aggiunte slide a presentazione pp
</commit_message>
<xml_diff>
--- a/Documenti/Relazione Finale/PP relazione.pptx
+++ b/Documenti/Relazione Finale/PP relazione.pptx
@@ -5,24 +5,27 @@
     <p:sldMasterId id="2147483659" r:id="rId1"/>
   </p:sldMasterIdLst>
   <p:notesMasterIdLst>
-    <p:notesMasterId r:id="rId8"/>
+    <p:notesMasterId r:id="rId11"/>
   </p:notesMasterIdLst>
   <p:sldIdLst>
     <p:sldId id="256" r:id="rId2"/>
     <p:sldId id="257" r:id="rId3"/>
-    <p:sldId id="258" r:id="rId4"/>
-    <p:sldId id="259" r:id="rId5"/>
-    <p:sldId id="262" r:id="rId6"/>
-    <p:sldId id="260" r:id="rId7"/>
+    <p:sldId id="263" r:id="rId4"/>
+    <p:sldId id="264" r:id="rId5"/>
+    <p:sldId id="259" r:id="rId6"/>
+    <p:sldId id="262" r:id="rId7"/>
+    <p:sldId id="265" r:id="rId8"/>
+    <p:sldId id="266" r:id="rId9"/>
+    <p:sldId id="260" r:id="rId10"/>
   </p:sldIdLst>
   <p:sldSz cx="9144000" cy="5143500" type="screen16x9"/>
   <p:notesSz cx="6858000" cy="9144000"/>
   <p:embeddedFontLst>
     <p:embeddedFont>
       <p:font typeface="Old Standard TT" panose="020B0604020202020204" charset="0"/>
-      <p:regular r:id="rId9"/>
-      <p:bold r:id="rId10"/>
-      <p:italic r:id="rId11"/>
+      <p:regular r:id="rId12"/>
+      <p:bold r:id="rId13"/>
+      <p:italic r:id="rId14"/>
     </p:embeddedFont>
   </p:embeddedFontLst>
   <p:defaultTextStyle>
@@ -927,110 +930,6 @@
   <p:cSld>
     <p:spTree>
       <p:nvGrpSpPr>
-        <p:cNvPr id="1" name="Shape 66"/>
-        <p:cNvGrpSpPr/>
-        <p:nvPr/>
-      </p:nvGrpSpPr>
-      <p:grpSpPr>
-        <a:xfrm>
-          <a:off x="0" y="0"/>
-          <a:ext cx="0" cy="0"/>
-          <a:chOff x="0" y="0"/>
-          <a:chExt cx="0" cy="0"/>
-        </a:xfrm>
-      </p:grpSpPr>
-      <p:sp>
-        <p:nvSpPr>
-          <p:cNvPr id="67" name="Google Shape;67;gc6f90357f_0_13:notes"/>
-          <p:cNvSpPr>
-            <a:spLocks noGrp="1" noRot="1" noChangeAspect="1"/>
-          </p:cNvSpPr>
-          <p:nvPr>
-            <p:ph type="sldImg" idx="2"/>
-          </p:nvPr>
-        </p:nvSpPr>
-        <p:spPr>
-          <a:xfrm>
-            <a:off x="381188" y="685800"/>
-            <a:ext cx="6096300" cy="3429000"/>
-          </a:xfrm>
-          <a:custGeom>
-            <a:avLst/>
-            <a:gdLst/>
-            <a:ahLst/>
-            <a:cxnLst/>
-            <a:rect l="l" t="t" r="r" b="b"/>
-            <a:pathLst>
-              <a:path w="120000" h="120000" extrusionOk="0">
-                <a:moveTo>
-                  <a:pt x="0" y="0"/>
-                </a:moveTo>
-                <a:lnTo>
-                  <a:pt x="120000" y="0"/>
-                </a:lnTo>
-                <a:lnTo>
-                  <a:pt x="120000" y="120000"/>
-                </a:lnTo>
-                <a:lnTo>
-                  <a:pt x="0" y="120000"/>
-                </a:lnTo>
-                <a:close/>
-              </a:path>
-            </a:pathLst>
-          </a:custGeom>
-        </p:spPr>
-      </p:sp>
-      <p:sp>
-        <p:nvSpPr>
-          <p:cNvPr id="68" name="Google Shape;68;gc6f90357f_0_13:notes"/>
-          <p:cNvSpPr txBox="1">
-            <a:spLocks noGrp="1"/>
-          </p:cNvSpPr>
-          <p:nvPr>
-            <p:ph type="body" idx="1"/>
-          </p:nvPr>
-        </p:nvSpPr>
-        <p:spPr>
-          <a:xfrm>
-            <a:off x="685800" y="4343400"/>
-            <a:ext cx="5486400" cy="4114800"/>
-          </a:xfrm>
-          <a:prstGeom prst="rect">
-            <a:avLst/>
-          </a:prstGeom>
-        </p:spPr>
-        <p:txBody>
-          <a:bodyPr spcFirstLastPara="1" wrap="square" lIns="91425" tIns="91425" rIns="91425" bIns="91425" anchor="t" anchorCtr="0">
-            <a:noAutofit/>
-          </a:bodyPr>
-          <a:lstStyle/>
-          <a:p>
-            <a:pPr marL="0" lvl="0" indent="0" algn="l" rtl="0">
-              <a:spcBef>
-                <a:spcPts val="0"/>
-              </a:spcBef>
-              <a:spcAft>
-                <a:spcPts val="0"/>
-              </a:spcAft>
-              <a:buNone/>
-            </a:pPr>
-            <a:endParaRPr/>
-          </a:p>
-        </p:txBody>
-      </p:sp>
-    </p:spTree>
-  </p:cSld>
-  <p:clrMapOvr>
-    <a:masterClrMapping/>
-  </p:clrMapOvr>
-</p:notes>
-</file>
-
-<file path=ppt/notesSlides/notesSlide4.xml><?xml version="1.0" encoding="utf-8"?>
-<p:notes xmlns:a="http://schemas.openxmlformats.org/drawingml/2006/main" xmlns:r="http://schemas.openxmlformats.org/officeDocument/2006/relationships" xmlns:p="http://schemas.openxmlformats.org/presentationml/2006/main" showMasterSp="0" showMasterPhAnim="0">
-  <p:cSld>
-    <p:spTree>
-      <p:nvGrpSpPr>
         <p:cNvPr id="1" name="Shape 74"/>
         <p:cNvGrpSpPr/>
         <p:nvPr/>
@@ -1130,7 +1029,7 @@
 </p:notes>
 </file>
 
-<file path=ppt/notesSlides/notesSlide5.xml><?xml version="1.0" encoding="utf-8"?>
+<file path=ppt/notesSlides/notesSlide4.xml><?xml version="1.0" encoding="utf-8"?>
 <p:notes xmlns:a="http://schemas.openxmlformats.org/drawingml/2006/main" xmlns:r="http://schemas.openxmlformats.org/officeDocument/2006/relationships" xmlns:p="http://schemas.openxmlformats.org/presentationml/2006/main" showMasterSp="0" showMasterPhAnim="0">
   <p:cSld>
     <p:spTree>
@@ -1257,7 +1156,7 @@
 </p:notes>
 </file>
 
-<file path=ppt/notesSlides/notesSlide6.xml><?xml version="1.0" encoding="utf-8"?>
+<file path=ppt/notesSlides/notesSlide5.xml><?xml version="1.0" encoding="utf-8"?>
 <p:notes xmlns:a="http://schemas.openxmlformats.org/drawingml/2006/main" xmlns:r="http://schemas.openxmlformats.org/officeDocument/2006/relationships" xmlns:p="http://schemas.openxmlformats.org/presentationml/2006/main" showMasterSp="0" showMasterPhAnim="0">
   <p:cSld>
     <p:spTree>
@@ -7121,7 +7020,7 @@
   <p:cSld>
     <p:spTree>
       <p:nvGrpSpPr>
-        <p:cNvPr id="1" name="Shape 69"/>
+        <p:cNvPr id="1" name=""/>
         <p:cNvGrpSpPr/>
         <p:nvPr/>
       </p:nvGrpSpPr>
@@ -7135,337 +7034,114 @@
       </p:grpSpPr>
       <p:sp>
         <p:nvSpPr>
-          <p:cNvPr id="70" name="Google Shape;70;p15"/>
-          <p:cNvSpPr txBox="1">
+          <p:cNvPr id="2" name="Titolo 1">
+            <a:extLst>
+              <a:ext uri="{FF2B5EF4-FFF2-40B4-BE49-F238E27FC236}">
+                <a16:creationId xmlns:a16="http://schemas.microsoft.com/office/drawing/2014/main" id="{6FE27422-26B7-28E8-E9AA-27C21C249C9D}"/>
+              </a:ext>
+            </a:extLst>
+          </p:cNvPr>
+          <p:cNvSpPr>
             <a:spLocks noGrp="1"/>
           </p:cNvSpPr>
           <p:nvPr>
             <p:ph type="title"/>
           </p:nvPr>
         </p:nvSpPr>
-        <p:spPr>
-          <a:xfrm>
-            <a:off x="93775" y="219175"/>
-            <a:ext cx="4373100" cy="1333200"/>
-          </a:xfrm>
-          <a:prstGeom prst="rect">
-            <a:avLst/>
-          </a:prstGeom>
-        </p:spPr>
+        <p:spPr/>
         <p:txBody>
-          <a:bodyPr spcFirstLastPara="1" wrap="square" lIns="91425" tIns="91425" rIns="91425" bIns="91425" anchor="t" anchorCtr="0">
-            <a:noAutofit/>
-          </a:bodyPr>
+          <a:bodyPr/>
           <a:lstStyle/>
           <a:p>
-            <a:pPr marL="0" lvl="0" indent="0" algn="ctr" rtl="0">
-              <a:spcBef>
-                <a:spcPts val="0"/>
-              </a:spcBef>
-              <a:spcAft>
-                <a:spcPts val="0"/>
-              </a:spcAft>
-              <a:buNone/>
-            </a:pPr>
             <a:r>
-              <a:rPr lang="it"/>
-              <a:t>I programmi </a:t>
+              <a:rPr lang="it-IT" dirty="0"/>
+              <a:t>CRIKLE – L’APP PER GESTIRE IL TUO PET</a:t>
             </a:r>
-            <a:endParaRPr/>
           </a:p>
         </p:txBody>
       </p:sp>
       <p:sp>
         <p:nvSpPr>
-          <p:cNvPr id="71" name="Google Shape;71;p15"/>
-          <p:cNvSpPr txBox="1">
+          <p:cNvPr id="3" name="Segnaposto testo 2">
+            <a:extLst>
+              <a:ext uri="{FF2B5EF4-FFF2-40B4-BE49-F238E27FC236}">
+                <a16:creationId xmlns:a16="http://schemas.microsoft.com/office/drawing/2014/main" id="{4E61A087-3BF6-C228-0496-FCA0DD5ADD35}"/>
+              </a:ext>
+            </a:extLst>
+          </p:cNvPr>
+          <p:cNvSpPr>
             <a:spLocks noGrp="1"/>
           </p:cNvSpPr>
           <p:nvPr>
-            <p:ph type="body" idx="2"/>
+            <p:ph type="body" idx="1"/>
           </p:nvPr>
         </p:nvSpPr>
-        <p:spPr>
-          <a:xfrm>
-            <a:off x="4931700" y="1314675"/>
-            <a:ext cx="3837000" cy="3695100"/>
-          </a:xfrm>
-          <a:prstGeom prst="rect">
-            <a:avLst/>
-          </a:prstGeom>
-        </p:spPr>
+        <p:spPr/>
         <p:txBody>
-          <a:bodyPr spcFirstLastPara="1" wrap="square" lIns="91425" tIns="91425" rIns="91425" bIns="91425" anchor="ctr" anchorCtr="0">
-            <a:noAutofit/>
-          </a:bodyPr>
+          <a:bodyPr/>
           <a:lstStyle/>
           <a:p>
-            <a:pPr marL="457200" lvl="0" indent="-387350" algn="l" rtl="0">
-              <a:spcBef>
-                <a:spcPts val="0"/>
-              </a:spcBef>
-              <a:spcAft>
-                <a:spcPts val="0"/>
-              </a:spcAft>
-              <a:buSzPts val="2500"/>
-              <a:buChar char="●"/>
+            <a:pPr marL="114300" indent="0">
+              <a:buNone/>
             </a:pPr>
             <a:r>
-              <a:rPr lang="it" sz="2500"/>
-              <a:t>Java</a:t>
+              <a:rPr lang="it-IT" dirty="0"/>
+              <a:t>SCOPO DI APPLICAZIONE MOBILE:</a:t>
             </a:r>
-            <a:endParaRPr sz="2500"/>
           </a:p>
           <a:p>
-            <a:pPr marL="457200" lvl="0" indent="-387350" algn="l" rtl="0">
-              <a:spcBef>
-                <a:spcPts val="0"/>
-              </a:spcBef>
-              <a:spcAft>
-                <a:spcPts val="0"/>
-              </a:spcAft>
-              <a:buSzPts val="2500"/>
-              <a:buChar char="●"/>
-            </a:pPr>
             <a:r>
-              <a:rPr lang="it" sz="2500"/>
-              <a:t>Python</a:t>
+              <a:rPr lang="it-IT" dirty="0"/>
+              <a:t>Registrazione Utente</a:t>
             </a:r>
-            <a:endParaRPr sz="2500"/>
           </a:p>
           <a:p>
-            <a:pPr marL="457200" lvl="0" indent="-387350" algn="l" rtl="0">
-              <a:spcBef>
-                <a:spcPts val="0"/>
-              </a:spcBef>
-              <a:spcAft>
-                <a:spcPts val="0"/>
-              </a:spcAft>
-              <a:buSzPts val="2500"/>
-              <a:buChar char="●"/>
-            </a:pPr>
             <a:r>
-              <a:rPr lang="it" sz="2500"/>
-              <a:t>HTML</a:t>
+              <a:rPr lang="it-IT" dirty="0"/>
+              <a:t>Registrazione animali utente</a:t>
             </a:r>
-            <a:endParaRPr sz="2500"/>
           </a:p>
           <a:p>
-            <a:pPr marL="457200" lvl="0" indent="-387350" algn="l" rtl="0">
-              <a:spcBef>
-                <a:spcPts val="0"/>
-              </a:spcBef>
-              <a:spcAft>
-                <a:spcPts val="0"/>
-              </a:spcAft>
-              <a:buSzPts val="2500"/>
-              <a:buChar char="●"/>
-            </a:pPr>
             <a:r>
-              <a:rPr lang="it" sz="2500"/>
-              <a:t>XML</a:t>
+              <a:rPr lang="it-IT" dirty="0"/>
+              <a:t>Agenda delle attività da svolgere con e per il/i proprio/i animale/i</a:t>
             </a:r>
-            <a:endParaRPr sz="2500"/>
           </a:p>
           <a:p>
-            <a:pPr marL="457200" lvl="0" indent="-387350" algn="l" rtl="0">
-              <a:spcBef>
-                <a:spcPts val="0"/>
-              </a:spcBef>
-              <a:spcAft>
-                <a:spcPts val="0"/>
-              </a:spcAft>
-              <a:buSzPts val="2500"/>
-              <a:buChar char="●"/>
-            </a:pPr>
             <a:r>
-              <a:rPr lang="it" sz="2500"/>
-              <a:t>CSS</a:t>
+              <a:rPr lang="it-IT" dirty="0"/>
+              <a:t>Cartella Clinica per monitorare salute dell’animale</a:t>
             </a:r>
-            <a:endParaRPr sz="2500"/>
-          </a:p>
-        </p:txBody>
-      </p:sp>
-      <p:sp>
-        <p:nvSpPr>
-          <p:cNvPr id="72" name="Google Shape;72;p15"/>
-          <p:cNvSpPr txBox="1"/>
-          <p:nvPr/>
-        </p:nvSpPr>
-        <p:spPr>
-          <a:xfrm>
-            <a:off x="442825" y="1552375"/>
-            <a:ext cx="3675000" cy="3022500"/>
-          </a:xfrm>
-          <a:prstGeom prst="rect">
-            <a:avLst/>
-          </a:prstGeom>
-          <a:noFill/>
-          <a:ln>
-            <a:noFill/>
-          </a:ln>
-        </p:spPr>
-        <p:txBody>
-          <a:bodyPr spcFirstLastPara="1" wrap="square" lIns="91425" tIns="91425" rIns="91425" bIns="91425" anchor="ctr" anchorCtr="0">
-            <a:noAutofit/>
-          </a:bodyPr>
-          <a:lstStyle/>
-          <a:p>
-            <a:pPr marL="457200" lvl="0" indent="-387350" algn="l" rtl="0">
-              <a:spcBef>
-                <a:spcPts val="0"/>
-              </a:spcBef>
-              <a:spcAft>
-                <a:spcPts val="0"/>
-              </a:spcAft>
-              <a:buClr>
-                <a:schemeClr val="dk1"/>
-              </a:buClr>
-              <a:buSzPts val="2500"/>
-              <a:buFont typeface="Old Standard TT"/>
-              <a:buChar char="●"/>
-            </a:pPr>
-            <a:r>
-              <a:rPr lang="it" sz="2500" dirty="0">
-                <a:solidFill>
-                  <a:schemeClr val="dk1"/>
-                </a:solidFill>
-                <a:latin typeface="Old Standard TT"/>
-                <a:ea typeface="Old Standard TT"/>
-                <a:cs typeface="Old Standard TT"/>
-                <a:sym typeface="Old Standard TT"/>
-              </a:rPr>
-              <a:t>VS code</a:t>
-            </a:r>
-            <a:endParaRPr sz="2500" dirty="0">
-              <a:solidFill>
-                <a:schemeClr val="dk1"/>
-              </a:solidFill>
-              <a:latin typeface="Old Standard TT"/>
-              <a:ea typeface="Old Standard TT"/>
-              <a:cs typeface="Old Standard TT"/>
-              <a:sym typeface="Old Standard TT"/>
-            </a:endParaRPr>
           </a:p>
           <a:p>
-            <a:pPr marL="457200" lvl="0" indent="-387350" algn="l" rtl="0">
-              <a:spcBef>
-                <a:spcPts val="0"/>
-              </a:spcBef>
-              <a:spcAft>
-                <a:spcPts val="0"/>
-              </a:spcAft>
-              <a:buClr>
-                <a:schemeClr val="dk1"/>
-              </a:buClr>
-              <a:buSzPts val="2500"/>
-              <a:buFont typeface="Old Standard TT"/>
-              <a:buChar char="●"/>
-            </a:pPr>
             <a:r>
-              <a:rPr lang="it" sz="2500" dirty="0">
-                <a:solidFill>
-                  <a:schemeClr val="dk1"/>
-                </a:solidFill>
-                <a:latin typeface="Old Standard TT"/>
-                <a:ea typeface="Old Standard TT"/>
-                <a:cs typeface="Old Standard TT"/>
-                <a:sym typeface="Old Standard TT"/>
-              </a:rPr>
-              <a:t>Android Studio</a:t>
+              <a:rPr lang="it-IT" dirty="0"/>
+              <a:t>Registrazione dati emotivi, per seguire l’umore del proprio animale</a:t>
             </a:r>
-            <a:endParaRPr sz="2500" dirty="0">
-              <a:solidFill>
-                <a:schemeClr val="dk1"/>
-              </a:solidFill>
-              <a:latin typeface="Old Standard TT"/>
-              <a:ea typeface="Old Standard TT"/>
-              <a:cs typeface="Old Standard TT"/>
-              <a:sym typeface="Old Standard TT"/>
-            </a:endParaRPr>
           </a:p>
           <a:p>
-            <a:pPr marL="457200" lvl="0" indent="-387350" algn="l" rtl="0">
-              <a:spcBef>
-                <a:spcPts val="0"/>
-              </a:spcBef>
-              <a:spcAft>
-                <a:spcPts val="0"/>
-              </a:spcAft>
-              <a:buClr>
-                <a:schemeClr val="dk1"/>
-              </a:buClr>
-              <a:buSzPts val="2500"/>
-              <a:buFont typeface="Old Standard TT"/>
-              <a:buChar char="●"/>
-            </a:pPr>
             <a:r>
-              <a:rPr lang="it" sz="2500" dirty="0">
-                <a:solidFill>
-                  <a:schemeClr val="dk1"/>
-                </a:solidFill>
-                <a:latin typeface="Old Standard TT"/>
-                <a:ea typeface="Old Standard TT"/>
-                <a:cs typeface="Old Standard TT"/>
-                <a:sym typeface="Old Standard TT"/>
-              </a:rPr>
-              <a:t>MySQL Workbench</a:t>
+              <a:rPr lang="it-IT" dirty="0"/>
+              <a:t>Ricerca di servizi vari per la cura e il benessere dell’animale (da implementare in futuro)</a:t>
             </a:r>
-            <a:endParaRPr sz="2500" dirty="0">
-              <a:solidFill>
-                <a:schemeClr val="dk1"/>
-              </a:solidFill>
-              <a:latin typeface="Old Standard TT"/>
-              <a:ea typeface="Old Standard TT"/>
-              <a:cs typeface="Old Standard TT"/>
-              <a:sym typeface="Old Standard TT"/>
-            </a:endParaRPr>
           </a:p>
-        </p:txBody>
-      </p:sp>
-      <p:sp>
-        <p:nvSpPr>
-          <p:cNvPr id="73" name="Google Shape;73;p15"/>
-          <p:cNvSpPr txBox="1">
-            <a:spLocks noGrp="1"/>
-          </p:cNvSpPr>
-          <p:nvPr>
-            <p:ph type="title"/>
-          </p:nvPr>
-        </p:nvSpPr>
-        <p:spPr>
-          <a:xfrm>
-            <a:off x="4663650" y="219175"/>
-            <a:ext cx="4373100" cy="1333200"/>
-          </a:xfrm>
-          <a:prstGeom prst="rect">
-            <a:avLst/>
-          </a:prstGeom>
-        </p:spPr>
-        <p:txBody>
-          <a:bodyPr spcFirstLastPara="1" wrap="square" lIns="91425" tIns="91425" rIns="91425" bIns="91425" anchor="t" anchorCtr="0">
-            <a:noAutofit/>
-          </a:bodyPr>
-          <a:lstStyle/>
           <a:p>
-            <a:pPr marL="0" lvl="0" indent="0" algn="ctr" rtl="0">
-              <a:spcBef>
-                <a:spcPts val="0"/>
-              </a:spcBef>
-              <a:spcAft>
-                <a:spcPts val="0"/>
-              </a:spcAft>
-              <a:buNone/>
-            </a:pPr>
             <a:r>
-              <a:rPr lang="it"/>
-              <a:t>I linguaggi</a:t>
+              <a:rPr lang="it-IT" dirty="0"/>
+              <a:t>Possibilità di prenotare servizi dedicati e lasciare recensioni (prossimo sviluppo)</a:t>
             </a:r>
-            <a:endParaRPr/>
+          </a:p>
+          <a:p>
+            <a:endParaRPr lang="it-IT" dirty="0"/>
           </a:p>
         </p:txBody>
       </p:sp>
     </p:spTree>
+    <p:extLst>
+      <p:ext uri="{BB962C8B-B14F-4D97-AF65-F5344CB8AC3E}">
+        <p14:creationId xmlns:p14="http://schemas.microsoft.com/office/powerpoint/2010/main" val="2830026645"/>
+      </p:ext>
+    </p:extLst>
   </p:cSld>
   <p:clrMapOvr>
     <a:masterClrMapping/>
@@ -7474,6 +7150,125 @@
 </file>
 
 <file path=ppt/slides/slide4.xml><?xml version="1.0" encoding="utf-8"?>
+<p:sld xmlns:a="http://schemas.openxmlformats.org/drawingml/2006/main" xmlns:r="http://schemas.openxmlformats.org/officeDocument/2006/relationships" xmlns:p="http://schemas.openxmlformats.org/presentationml/2006/main">
+  <p:cSld>
+    <p:spTree>
+      <p:nvGrpSpPr>
+        <p:cNvPr id="1" name=""/>
+        <p:cNvGrpSpPr/>
+        <p:nvPr/>
+      </p:nvGrpSpPr>
+      <p:grpSpPr>
+        <a:xfrm>
+          <a:off x="0" y="0"/>
+          <a:ext cx="0" cy="0"/>
+          <a:chOff x="0" y="0"/>
+          <a:chExt cx="0" cy="0"/>
+        </a:xfrm>
+      </p:grpSpPr>
+      <p:sp>
+        <p:nvSpPr>
+          <p:cNvPr id="2" name="Titolo 1">
+            <a:extLst>
+              <a:ext uri="{FF2B5EF4-FFF2-40B4-BE49-F238E27FC236}">
+                <a16:creationId xmlns:a16="http://schemas.microsoft.com/office/drawing/2014/main" id="{ADA6BFEA-FEB4-E750-F79B-118B292191CD}"/>
+              </a:ext>
+            </a:extLst>
+          </p:cNvPr>
+          <p:cNvSpPr>
+            <a:spLocks noGrp="1"/>
+          </p:cNvSpPr>
+          <p:nvPr>
+            <p:ph type="title"/>
+          </p:nvPr>
+        </p:nvSpPr>
+        <p:spPr/>
+        <p:txBody>
+          <a:bodyPr/>
+          <a:lstStyle/>
+          <a:p>
+            <a:r>
+              <a:rPr lang="it-IT" dirty="0"/>
+              <a:t>CRIKLE – PORTALE WEB</a:t>
+            </a:r>
+          </a:p>
+        </p:txBody>
+      </p:sp>
+      <p:sp>
+        <p:nvSpPr>
+          <p:cNvPr id="3" name="Segnaposto testo 2">
+            <a:extLst>
+              <a:ext uri="{FF2B5EF4-FFF2-40B4-BE49-F238E27FC236}">
+                <a16:creationId xmlns:a16="http://schemas.microsoft.com/office/drawing/2014/main" id="{351F22DC-5A65-CBE9-E143-A08A6752C6DD}"/>
+              </a:ext>
+            </a:extLst>
+          </p:cNvPr>
+          <p:cNvSpPr>
+            <a:spLocks noGrp="1"/>
+          </p:cNvSpPr>
+          <p:nvPr>
+            <p:ph type="body" idx="1"/>
+          </p:nvPr>
+        </p:nvSpPr>
+        <p:spPr/>
+        <p:txBody>
+          <a:bodyPr/>
+          <a:lstStyle/>
+          <a:p>
+            <a:pPr marL="114300" indent="0">
+              <a:buNone/>
+            </a:pPr>
+            <a:r>
+              <a:rPr lang="it-IT" dirty="0"/>
+              <a:t>SCOPO E UTILITA’ PORTALE WEB:</a:t>
+            </a:r>
+          </a:p>
+          <a:p>
+            <a:r>
+              <a:rPr lang="it-IT" dirty="0"/>
+              <a:t>Registrazione Fornitore</a:t>
+            </a:r>
+          </a:p>
+          <a:p>
+            <a:r>
+              <a:rPr lang="it-IT" dirty="0"/>
+              <a:t>Registrazione Attività/Servizio fornito</a:t>
+            </a:r>
+          </a:p>
+          <a:p>
+            <a:r>
+              <a:rPr lang="it-IT" dirty="0"/>
+              <a:t>Visibilità della propria attività/servizio da parte degli utenti dell’app</a:t>
+            </a:r>
+          </a:p>
+          <a:p>
+            <a:r>
+              <a:rPr lang="it-IT" dirty="0"/>
+              <a:t>Gestione agenda appuntamenti </a:t>
+            </a:r>
+          </a:p>
+          <a:p>
+            <a:r>
+              <a:rPr lang="it-IT" dirty="0"/>
+              <a:t>Gestione prenotazioni dei clienti</a:t>
+            </a:r>
+          </a:p>
+        </p:txBody>
+      </p:sp>
+    </p:spTree>
+    <p:extLst>
+      <p:ext uri="{BB962C8B-B14F-4D97-AF65-F5344CB8AC3E}">
+        <p14:creationId xmlns:p14="http://schemas.microsoft.com/office/powerpoint/2010/main" val="2965883541"/>
+      </p:ext>
+    </p:extLst>
+  </p:cSld>
+  <p:clrMapOvr>
+    <a:masterClrMapping/>
+  </p:clrMapOvr>
+</p:sld>
+</file>
+
+<file path=ppt/slides/slide5.xml><?xml version="1.0" encoding="utf-8"?>
 <p:sld xmlns:a="http://schemas.openxmlformats.org/drawingml/2006/main" xmlns:r="http://schemas.openxmlformats.org/officeDocument/2006/relationships" xmlns:p="http://schemas.openxmlformats.org/presentationml/2006/main">
   <p:cSld>
     <p:spTree>
@@ -7540,7 +7335,7 @@
 </p:sld>
 </file>
 
-<file path=ppt/slides/slide5.xml><?xml version="1.0" encoding="utf-8"?>
+<file path=ppt/slides/slide6.xml><?xml version="1.0" encoding="utf-8"?>
 <p:sld xmlns:a="http://schemas.openxmlformats.org/drawingml/2006/main" xmlns:r="http://schemas.openxmlformats.org/officeDocument/2006/relationships" xmlns:p="http://schemas.openxmlformats.org/presentationml/2006/main">
   <p:cSld>
     <p:spTree>
@@ -7932,7 +7727,1816 @@
 </p:sld>
 </file>
 
-<file path=ppt/slides/slide6.xml><?xml version="1.0" encoding="utf-8"?>
+<file path=ppt/slides/slide7.xml><?xml version="1.0" encoding="utf-8"?>
+<p:sld xmlns:a="http://schemas.openxmlformats.org/drawingml/2006/main" xmlns:r="http://schemas.openxmlformats.org/officeDocument/2006/relationships" xmlns:p="http://schemas.openxmlformats.org/presentationml/2006/main">
+  <p:cSld>
+    <p:spTree>
+      <p:nvGrpSpPr>
+        <p:cNvPr id="1" name=""/>
+        <p:cNvGrpSpPr/>
+        <p:nvPr/>
+      </p:nvGrpSpPr>
+      <p:grpSpPr>
+        <a:xfrm>
+          <a:off x="0" y="0"/>
+          <a:ext cx="0" cy="0"/>
+          <a:chOff x="0" y="0"/>
+          <a:chExt cx="0" cy="0"/>
+        </a:xfrm>
+      </p:grpSpPr>
+      <p:sp>
+        <p:nvSpPr>
+          <p:cNvPr id="2" name="Titolo 1">
+            <a:extLst>
+              <a:ext uri="{FF2B5EF4-FFF2-40B4-BE49-F238E27FC236}">
+                <a16:creationId xmlns:a16="http://schemas.microsoft.com/office/drawing/2014/main" id="{CDA77C0F-428A-8B4D-B18A-BC19217C36C7}"/>
+              </a:ext>
+            </a:extLst>
+          </p:cNvPr>
+          <p:cNvSpPr>
+            <a:spLocks noGrp="1"/>
+          </p:cNvSpPr>
+          <p:nvPr>
+            <p:ph type="title"/>
+          </p:nvPr>
+        </p:nvSpPr>
+        <p:spPr/>
+        <p:txBody>
+          <a:bodyPr/>
+          <a:lstStyle/>
+          <a:p>
+            <a:pPr algn="ctr"/>
+            <a:r>
+              <a:rPr lang="it-IT" dirty="0"/>
+              <a:t>WIREFRAME DELL’APP</a:t>
+            </a:r>
+          </a:p>
+        </p:txBody>
+      </p:sp>
+      <p:pic>
+        <p:nvPicPr>
+          <p:cNvPr id="4" name="Immagine 3" descr="Immagine che contiene testo, schermata, cerchio, logo&#10;&#10;Il contenuto generato dall'IA potrebbe non essere corretto.">
+            <a:extLst>
+              <a:ext uri="{FF2B5EF4-FFF2-40B4-BE49-F238E27FC236}">
+                <a16:creationId xmlns:a16="http://schemas.microsoft.com/office/drawing/2014/main" id="{217FE4B0-D712-635C-F1D1-D43A9F7986FC}"/>
+              </a:ext>
+            </a:extLst>
+          </p:cNvPr>
+          <p:cNvPicPr>
+            <a:picLocks noChangeAspect="1"/>
+          </p:cNvPicPr>
+          <p:nvPr/>
+        </p:nvPicPr>
+        <p:blipFill>
+          <a:blip r:embed="rId2"/>
+          <a:stretch>
+            <a:fillRect/>
+          </a:stretch>
+        </p:blipFill>
+        <p:spPr>
+          <a:xfrm>
+            <a:off x="442200" y="1019785"/>
+            <a:ext cx="830804" cy="1849143"/>
+          </a:xfrm>
+          <a:prstGeom prst="rect">
+            <a:avLst/>
+          </a:prstGeom>
+        </p:spPr>
+      </p:pic>
+      <p:pic>
+        <p:nvPicPr>
+          <p:cNvPr id="26" name="Immagine 25" descr="Immagine che contiene testo, schermata, Carattere, design&#10;&#10;Il contenuto generato dall'IA potrebbe non essere corretto.">
+            <a:extLst>
+              <a:ext uri="{FF2B5EF4-FFF2-40B4-BE49-F238E27FC236}">
+                <a16:creationId xmlns:a16="http://schemas.microsoft.com/office/drawing/2014/main" id="{EB8A02DE-DEB9-3CE5-085A-AEC786AC52A0}"/>
+              </a:ext>
+            </a:extLst>
+          </p:cNvPr>
+          <p:cNvPicPr>
+            <a:picLocks noChangeAspect="1"/>
+          </p:cNvPicPr>
+          <p:nvPr/>
+        </p:nvPicPr>
+        <p:blipFill>
+          <a:blip r:embed="rId3"/>
+          <a:stretch>
+            <a:fillRect/>
+          </a:stretch>
+        </p:blipFill>
+        <p:spPr>
+          <a:xfrm flipH="1">
+            <a:off x="2628991" y="3044883"/>
+            <a:ext cx="830802" cy="1849140"/>
+          </a:xfrm>
+          <a:prstGeom prst="rect">
+            <a:avLst/>
+          </a:prstGeom>
+        </p:spPr>
+      </p:pic>
+      <p:pic>
+        <p:nvPicPr>
+          <p:cNvPr id="28" name="Immagine 27" descr="Immagine che contiene testo, schermata, Carattere, design&#10;&#10;Il contenuto generato dall'IA potrebbe non essere corretto.">
+            <a:extLst>
+              <a:ext uri="{FF2B5EF4-FFF2-40B4-BE49-F238E27FC236}">
+                <a16:creationId xmlns:a16="http://schemas.microsoft.com/office/drawing/2014/main" id="{5A62DBC2-49C9-4D2B-5B8A-40074EE76EC3}"/>
+              </a:ext>
+            </a:extLst>
+          </p:cNvPr>
+          <p:cNvPicPr>
+            <a:picLocks noChangeAspect="1"/>
+          </p:cNvPicPr>
+          <p:nvPr/>
+        </p:nvPicPr>
+        <p:blipFill>
+          <a:blip r:embed="rId4"/>
+          <a:stretch>
+            <a:fillRect/>
+          </a:stretch>
+        </p:blipFill>
+        <p:spPr>
+          <a:xfrm>
+            <a:off x="5642708" y="1067394"/>
+            <a:ext cx="864552" cy="1924258"/>
+          </a:xfrm>
+          <a:prstGeom prst="rect">
+            <a:avLst/>
+          </a:prstGeom>
+        </p:spPr>
+      </p:pic>
+      <p:pic>
+        <p:nvPicPr>
+          <p:cNvPr id="30" name="Immagine 29" descr="Immagine che contiene testo, schermata, biglietto da visita, design&#10;&#10;Il contenuto generato dall'IA potrebbe non essere corretto.">
+            <a:extLst>
+              <a:ext uri="{FF2B5EF4-FFF2-40B4-BE49-F238E27FC236}">
+                <a16:creationId xmlns:a16="http://schemas.microsoft.com/office/drawing/2014/main" id="{030715D4-13A2-9A99-BC46-49964438FCE4}"/>
+              </a:ext>
+            </a:extLst>
+          </p:cNvPr>
+          <p:cNvPicPr>
+            <a:picLocks noChangeAspect="1"/>
+          </p:cNvPicPr>
+          <p:nvPr/>
+        </p:nvPicPr>
+        <p:blipFill>
+          <a:blip r:embed="rId5"/>
+          <a:stretch>
+            <a:fillRect/>
+          </a:stretch>
+        </p:blipFill>
+        <p:spPr>
+          <a:xfrm>
+            <a:off x="6749986" y="1057344"/>
+            <a:ext cx="864552" cy="1924259"/>
+          </a:xfrm>
+          <a:prstGeom prst="rect">
+            <a:avLst/>
+          </a:prstGeom>
+        </p:spPr>
+      </p:pic>
+      <p:pic>
+        <p:nvPicPr>
+          <p:cNvPr id="32" name="Immagine 31" descr="Immagine che contiene testo, schermata, Carattere, design&#10;&#10;Il contenuto generato dall'IA potrebbe non essere corretto.">
+            <a:extLst>
+              <a:ext uri="{FF2B5EF4-FFF2-40B4-BE49-F238E27FC236}">
+                <a16:creationId xmlns:a16="http://schemas.microsoft.com/office/drawing/2014/main" id="{B7D876EF-870A-461F-D6E3-AF266C3C95B9}"/>
+              </a:ext>
+            </a:extLst>
+          </p:cNvPr>
+          <p:cNvPicPr>
+            <a:picLocks noChangeAspect="1"/>
+          </p:cNvPicPr>
+          <p:nvPr/>
+        </p:nvPicPr>
+        <p:blipFill>
+          <a:blip r:embed="rId6"/>
+          <a:stretch>
+            <a:fillRect/>
+          </a:stretch>
+        </p:blipFill>
+        <p:spPr>
+          <a:xfrm>
+            <a:off x="4845331" y="3073459"/>
+            <a:ext cx="864553" cy="1924259"/>
+          </a:xfrm>
+          <a:prstGeom prst="rect">
+            <a:avLst/>
+          </a:prstGeom>
+        </p:spPr>
+      </p:pic>
+      <p:pic>
+        <p:nvPicPr>
+          <p:cNvPr id="34" name="Immagine 33" descr="Immagine che contiene testo, schermata, logo, design&#10;&#10;Il contenuto generato dall'IA potrebbe non essere corretto.">
+            <a:extLst>
+              <a:ext uri="{FF2B5EF4-FFF2-40B4-BE49-F238E27FC236}">
+                <a16:creationId xmlns:a16="http://schemas.microsoft.com/office/drawing/2014/main" id="{C5AF193D-71B0-A3F6-0501-C0D09EAB8DF2}"/>
+              </a:ext>
+            </a:extLst>
+          </p:cNvPr>
+          <p:cNvPicPr>
+            <a:picLocks noChangeAspect="1"/>
+          </p:cNvPicPr>
+          <p:nvPr/>
+        </p:nvPicPr>
+        <p:blipFill>
+          <a:blip r:embed="rId7"/>
+          <a:stretch>
+            <a:fillRect/>
+          </a:stretch>
+        </p:blipFill>
+        <p:spPr>
+          <a:xfrm>
+            <a:off x="2459002" y="1058737"/>
+            <a:ext cx="838875" cy="1867109"/>
+          </a:xfrm>
+          <a:prstGeom prst="rect">
+            <a:avLst/>
+          </a:prstGeom>
+        </p:spPr>
+      </p:pic>
+      <p:pic>
+        <p:nvPicPr>
+          <p:cNvPr id="36" name="Immagine 35" descr="Immagine che contiene testo, schermata, numero, Carattere&#10;&#10;Il contenuto generato dall'IA potrebbe non essere corretto.">
+            <a:extLst>
+              <a:ext uri="{FF2B5EF4-FFF2-40B4-BE49-F238E27FC236}">
+                <a16:creationId xmlns:a16="http://schemas.microsoft.com/office/drawing/2014/main" id="{9F8718C3-4DCB-1ED3-E28B-E299F8ED67A2}"/>
+              </a:ext>
+            </a:extLst>
+          </p:cNvPr>
+          <p:cNvPicPr>
+            <a:picLocks noChangeAspect="1"/>
+          </p:cNvPicPr>
+          <p:nvPr/>
+        </p:nvPicPr>
+        <p:blipFill>
+          <a:blip r:embed="rId8"/>
+          <a:stretch>
+            <a:fillRect/>
+          </a:stretch>
+        </p:blipFill>
+        <p:spPr>
+          <a:xfrm>
+            <a:off x="3733124" y="3073459"/>
+            <a:ext cx="838876" cy="1867109"/>
+          </a:xfrm>
+          <a:prstGeom prst="rect">
+            <a:avLst/>
+          </a:prstGeom>
+        </p:spPr>
+      </p:pic>
+      <p:pic>
+        <p:nvPicPr>
+          <p:cNvPr id="38" name="Immagine 37" descr="Immagine che contiene testo, schermata, cerchio, Carattere&#10;&#10;Il contenuto generato dall'IA potrebbe non essere corretto.">
+            <a:extLst>
+              <a:ext uri="{FF2B5EF4-FFF2-40B4-BE49-F238E27FC236}">
+                <a16:creationId xmlns:a16="http://schemas.microsoft.com/office/drawing/2014/main" id="{81F0ABAE-28AE-C04C-9E3D-B61298F422DF}"/>
+              </a:ext>
+            </a:extLst>
+          </p:cNvPr>
+          <p:cNvPicPr>
+            <a:picLocks noChangeAspect="1"/>
+          </p:cNvPicPr>
+          <p:nvPr/>
+        </p:nvPicPr>
+        <p:blipFill>
+          <a:blip r:embed="rId9"/>
+          <a:stretch>
+            <a:fillRect/>
+          </a:stretch>
+        </p:blipFill>
+        <p:spPr>
+          <a:xfrm>
+            <a:off x="4542344" y="1048800"/>
+            <a:ext cx="838876" cy="1867109"/>
+          </a:xfrm>
+          <a:prstGeom prst="rect">
+            <a:avLst/>
+          </a:prstGeom>
+        </p:spPr>
+      </p:pic>
+      <p:pic>
+        <p:nvPicPr>
+          <p:cNvPr id="40" name="Immagine 39" descr="Immagine che contiene testo, schermata, grafica, logo&#10;&#10;Il contenuto generato dall'IA potrebbe non essere corretto.">
+            <a:extLst>
+              <a:ext uri="{FF2B5EF4-FFF2-40B4-BE49-F238E27FC236}">
+                <a16:creationId xmlns:a16="http://schemas.microsoft.com/office/drawing/2014/main" id="{5938B6A7-133E-B8E0-A180-2A475E9BADA9}"/>
+              </a:ext>
+            </a:extLst>
+          </p:cNvPr>
+          <p:cNvPicPr>
+            <a:picLocks noChangeAspect="1"/>
+          </p:cNvPicPr>
+          <p:nvPr/>
+        </p:nvPicPr>
+        <p:blipFill>
+          <a:blip r:embed="rId10"/>
+          <a:stretch>
+            <a:fillRect/>
+          </a:stretch>
+        </p:blipFill>
+        <p:spPr>
+          <a:xfrm>
+            <a:off x="7851095" y="1057344"/>
+            <a:ext cx="830803" cy="1849140"/>
+          </a:xfrm>
+          <a:prstGeom prst="rect">
+            <a:avLst/>
+          </a:prstGeom>
+        </p:spPr>
+      </p:pic>
+      <p:pic>
+        <p:nvPicPr>
+          <p:cNvPr id="42" name="Immagine 41" descr="Immagine che contiene testo, schermata, cerchio, Elementi grafici&#10;&#10;Il contenuto generato dall'IA potrebbe non essere corretto.">
+            <a:extLst>
+              <a:ext uri="{FF2B5EF4-FFF2-40B4-BE49-F238E27FC236}">
+                <a16:creationId xmlns:a16="http://schemas.microsoft.com/office/drawing/2014/main" id="{AC90764F-519C-F11F-4791-3F7545F71713}"/>
+              </a:ext>
+            </a:extLst>
+          </p:cNvPr>
+          <p:cNvPicPr>
+            <a:picLocks noChangeAspect="1"/>
+          </p:cNvPicPr>
+          <p:nvPr/>
+        </p:nvPicPr>
+        <p:blipFill>
+          <a:blip r:embed="rId11"/>
+          <a:stretch>
+            <a:fillRect/>
+          </a:stretch>
+        </p:blipFill>
+        <p:spPr>
+          <a:xfrm>
+            <a:off x="3436779" y="1039005"/>
+            <a:ext cx="890062" cy="1981036"/>
+          </a:xfrm>
+          <a:prstGeom prst="rect">
+            <a:avLst/>
+          </a:prstGeom>
+        </p:spPr>
+      </p:pic>
+      <p:pic>
+        <p:nvPicPr>
+          <p:cNvPr id="44" name="Immagine 43" descr="Immagine che contiene testo, schermata, Carattere, design&#10;&#10;Il contenuto generato dall'IA potrebbe non essere corretto.">
+            <a:extLst>
+              <a:ext uri="{FF2B5EF4-FFF2-40B4-BE49-F238E27FC236}">
+                <a16:creationId xmlns:a16="http://schemas.microsoft.com/office/drawing/2014/main" id="{D54A1AA3-F9D8-A2C5-A901-76D1109BB44B}"/>
+              </a:ext>
+            </a:extLst>
+          </p:cNvPr>
+          <p:cNvPicPr>
+            <a:picLocks noChangeAspect="1"/>
+          </p:cNvPicPr>
+          <p:nvPr/>
+        </p:nvPicPr>
+        <p:blipFill>
+          <a:blip r:embed="rId12"/>
+          <a:stretch>
+            <a:fillRect/>
+          </a:stretch>
+        </p:blipFill>
+        <p:spPr>
+          <a:xfrm>
+            <a:off x="6008393" y="3073460"/>
+            <a:ext cx="864552" cy="1924258"/>
+          </a:xfrm>
+          <a:prstGeom prst="rect">
+            <a:avLst/>
+          </a:prstGeom>
+        </p:spPr>
+      </p:pic>
+      <p:pic>
+        <p:nvPicPr>
+          <p:cNvPr id="46" name="Immagine 45" descr="Immagine che contiene testo, schermata, cerchio, design&#10;&#10;Il contenuto generato dall'IA potrebbe non essere corretto.">
+            <a:extLst>
+              <a:ext uri="{FF2B5EF4-FFF2-40B4-BE49-F238E27FC236}">
+                <a16:creationId xmlns:a16="http://schemas.microsoft.com/office/drawing/2014/main" id="{0BC4043E-2ACA-8C92-2EA6-1753C6C170A0}"/>
+              </a:ext>
+            </a:extLst>
+          </p:cNvPr>
+          <p:cNvPicPr>
+            <a:picLocks noChangeAspect="1"/>
+          </p:cNvPicPr>
+          <p:nvPr/>
+        </p:nvPicPr>
+        <p:blipFill>
+          <a:blip r:embed="rId13"/>
+          <a:stretch>
+            <a:fillRect/>
+          </a:stretch>
+        </p:blipFill>
+        <p:spPr>
+          <a:xfrm>
+            <a:off x="1433726" y="1035021"/>
+            <a:ext cx="864553" cy="1924261"/>
+          </a:xfrm>
+          <a:prstGeom prst="rect">
+            <a:avLst/>
+          </a:prstGeom>
+        </p:spPr>
+      </p:pic>
+    </p:spTree>
+    <p:extLst>
+      <p:ext uri="{BB962C8B-B14F-4D97-AF65-F5344CB8AC3E}">
+        <p14:creationId xmlns:p14="http://schemas.microsoft.com/office/powerpoint/2010/main" val="2210377371"/>
+      </p:ext>
+    </p:extLst>
+  </p:cSld>
+  <p:clrMapOvr>
+    <a:masterClrMapping/>
+  </p:clrMapOvr>
+  <p:timing>
+    <p:tnLst>
+      <p:par>
+        <p:cTn id="1" dur="indefinite" restart="never" nodeType="tmRoot">
+          <p:childTnLst>
+            <p:seq concurrent="1" nextAc="seek">
+              <p:cTn id="2" dur="indefinite" nodeType="mainSeq">
+                <p:childTnLst>
+                  <p:par>
+                    <p:cTn id="3" fill="hold">
+                      <p:stCondLst>
+                        <p:cond delay="indefinite"/>
+                      </p:stCondLst>
+                      <p:childTnLst>
+                        <p:par>
+                          <p:cTn id="4" fill="hold">
+                            <p:stCondLst>
+                              <p:cond delay="0"/>
+                            </p:stCondLst>
+                            <p:childTnLst>
+                              <p:par>
+                                <p:cTn id="5" presetID="42" presetClass="entr" presetSubtype="0" fill="hold" nodeType="clickEffect">
+                                  <p:stCondLst>
+                                    <p:cond delay="0"/>
+                                  </p:stCondLst>
+                                  <p:childTnLst>
+                                    <p:set>
+                                      <p:cBhvr>
+                                        <p:cTn id="6" dur="1" fill="hold">
+                                          <p:stCondLst>
+                                            <p:cond delay="0"/>
+                                          </p:stCondLst>
+                                        </p:cTn>
+                                        <p:tgtEl>
+                                          <p:spTgt spid="4"/>
+                                        </p:tgtEl>
+                                        <p:attrNameLst>
+                                          <p:attrName>style.visibility</p:attrName>
+                                        </p:attrNameLst>
+                                      </p:cBhvr>
+                                      <p:to>
+                                        <p:strVal val="visible"/>
+                                      </p:to>
+                                    </p:set>
+                                    <p:animEffect transition="in" filter="fade">
+                                      <p:cBhvr>
+                                        <p:cTn id="7" dur="1000"/>
+                                        <p:tgtEl>
+                                          <p:spTgt spid="4"/>
+                                        </p:tgtEl>
+                                      </p:cBhvr>
+                                    </p:animEffect>
+                                    <p:anim calcmode="lin" valueType="num">
+                                      <p:cBhvr>
+                                        <p:cTn id="8" dur="1000" fill="hold"/>
+                                        <p:tgtEl>
+                                          <p:spTgt spid="4"/>
+                                        </p:tgtEl>
+                                        <p:attrNameLst>
+                                          <p:attrName>ppt_x</p:attrName>
+                                        </p:attrNameLst>
+                                      </p:cBhvr>
+                                      <p:tavLst>
+                                        <p:tav tm="0">
+                                          <p:val>
+                                            <p:strVal val="#ppt_x"/>
+                                          </p:val>
+                                        </p:tav>
+                                        <p:tav tm="100000">
+                                          <p:val>
+                                            <p:strVal val="#ppt_x"/>
+                                          </p:val>
+                                        </p:tav>
+                                      </p:tavLst>
+                                    </p:anim>
+                                    <p:anim calcmode="lin" valueType="num">
+                                      <p:cBhvr>
+                                        <p:cTn id="9" dur="1000" fill="hold"/>
+                                        <p:tgtEl>
+                                          <p:spTgt spid="4"/>
+                                        </p:tgtEl>
+                                        <p:attrNameLst>
+                                          <p:attrName>ppt_y</p:attrName>
+                                        </p:attrNameLst>
+                                      </p:cBhvr>
+                                      <p:tavLst>
+                                        <p:tav tm="0">
+                                          <p:val>
+                                            <p:strVal val="#ppt_y+.1"/>
+                                          </p:val>
+                                        </p:tav>
+                                        <p:tav tm="100000">
+                                          <p:val>
+                                            <p:strVal val="#ppt_y"/>
+                                          </p:val>
+                                        </p:tav>
+                                      </p:tavLst>
+                                    </p:anim>
+                                  </p:childTnLst>
+                                </p:cTn>
+                              </p:par>
+                            </p:childTnLst>
+                          </p:cTn>
+                        </p:par>
+                      </p:childTnLst>
+                    </p:cTn>
+                  </p:par>
+                  <p:par>
+                    <p:cTn id="10" fill="hold">
+                      <p:stCondLst>
+                        <p:cond delay="indefinite"/>
+                      </p:stCondLst>
+                      <p:childTnLst>
+                        <p:par>
+                          <p:cTn id="11" fill="hold">
+                            <p:stCondLst>
+                              <p:cond delay="0"/>
+                            </p:stCondLst>
+                            <p:childTnLst>
+                              <p:par>
+                                <p:cTn id="12" presetID="42" presetClass="entr" presetSubtype="0" fill="hold" nodeType="clickEffect">
+                                  <p:stCondLst>
+                                    <p:cond delay="0"/>
+                                  </p:stCondLst>
+                                  <p:childTnLst>
+                                    <p:set>
+                                      <p:cBhvr>
+                                        <p:cTn id="13" dur="1" fill="hold">
+                                          <p:stCondLst>
+                                            <p:cond delay="0"/>
+                                          </p:stCondLst>
+                                        </p:cTn>
+                                        <p:tgtEl>
+                                          <p:spTgt spid="46"/>
+                                        </p:tgtEl>
+                                        <p:attrNameLst>
+                                          <p:attrName>style.visibility</p:attrName>
+                                        </p:attrNameLst>
+                                      </p:cBhvr>
+                                      <p:to>
+                                        <p:strVal val="visible"/>
+                                      </p:to>
+                                    </p:set>
+                                    <p:animEffect transition="in" filter="fade">
+                                      <p:cBhvr>
+                                        <p:cTn id="14" dur="1000"/>
+                                        <p:tgtEl>
+                                          <p:spTgt spid="46"/>
+                                        </p:tgtEl>
+                                      </p:cBhvr>
+                                    </p:animEffect>
+                                    <p:anim calcmode="lin" valueType="num">
+                                      <p:cBhvr>
+                                        <p:cTn id="15" dur="1000" fill="hold"/>
+                                        <p:tgtEl>
+                                          <p:spTgt spid="46"/>
+                                        </p:tgtEl>
+                                        <p:attrNameLst>
+                                          <p:attrName>ppt_x</p:attrName>
+                                        </p:attrNameLst>
+                                      </p:cBhvr>
+                                      <p:tavLst>
+                                        <p:tav tm="0">
+                                          <p:val>
+                                            <p:strVal val="#ppt_x"/>
+                                          </p:val>
+                                        </p:tav>
+                                        <p:tav tm="100000">
+                                          <p:val>
+                                            <p:strVal val="#ppt_x"/>
+                                          </p:val>
+                                        </p:tav>
+                                      </p:tavLst>
+                                    </p:anim>
+                                    <p:anim calcmode="lin" valueType="num">
+                                      <p:cBhvr>
+                                        <p:cTn id="16" dur="1000" fill="hold"/>
+                                        <p:tgtEl>
+                                          <p:spTgt spid="46"/>
+                                        </p:tgtEl>
+                                        <p:attrNameLst>
+                                          <p:attrName>ppt_y</p:attrName>
+                                        </p:attrNameLst>
+                                      </p:cBhvr>
+                                      <p:tavLst>
+                                        <p:tav tm="0">
+                                          <p:val>
+                                            <p:strVal val="#ppt_y+.1"/>
+                                          </p:val>
+                                        </p:tav>
+                                        <p:tav tm="100000">
+                                          <p:val>
+                                            <p:strVal val="#ppt_y"/>
+                                          </p:val>
+                                        </p:tav>
+                                      </p:tavLst>
+                                    </p:anim>
+                                  </p:childTnLst>
+                                </p:cTn>
+                              </p:par>
+                            </p:childTnLst>
+                          </p:cTn>
+                        </p:par>
+                      </p:childTnLst>
+                    </p:cTn>
+                  </p:par>
+                  <p:par>
+                    <p:cTn id="17" fill="hold">
+                      <p:stCondLst>
+                        <p:cond delay="indefinite"/>
+                      </p:stCondLst>
+                      <p:childTnLst>
+                        <p:par>
+                          <p:cTn id="18" fill="hold">
+                            <p:stCondLst>
+                              <p:cond delay="0"/>
+                            </p:stCondLst>
+                            <p:childTnLst>
+                              <p:par>
+                                <p:cTn id="19" presetID="42" presetClass="entr" presetSubtype="0" fill="hold" nodeType="clickEffect">
+                                  <p:stCondLst>
+                                    <p:cond delay="0"/>
+                                  </p:stCondLst>
+                                  <p:childTnLst>
+                                    <p:set>
+                                      <p:cBhvr>
+                                        <p:cTn id="20" dur="1" fill="hold">
+                                          <p:stCondLst>
+                                            <p:cond delay="0"/>
+                                          </p:stCondLst>
+                                        </p:cTn>
+                                        <p:tgtEl>
+                                          <p:spTgt spid="34"/>
+                                        </p:tgtEl>
+                                        <p:attrNameLst>
+                                          <p:attrName>style.visibility</p:attrName>
+                                        </p:attrNameLst>
+                                      </p:cBhvr>
+                                      <p:to>
+                                        <p:strVal val="visible"/>
+                                      </p:to>
+                                    </p:set>
+                                    <p:animEffect transition="in" filter="fade">
+                                      <p:cBhvr>
+                                        <p:cTn id="21" dur="1000"/>
+                                        <p:tgtEl>
+                                          <p:spTgt spid="34"/>
+                                        </p:tgtEl>
+                                      </p:cBhvr>
+                                    </p:animEffect>
+                                    <p:anim calcmode="lin" valueType="num">
+                                      <p:cBhvr>
+                                        <p:cTn id="22" dur="1000" fill="hold"/>
+                                        <p:tgtEl>
+                                          <p:spTgt spid="34"/>
+                                        </p:tgtEl>
+                                        <p:attrNameLst>
+                                          <p:attrName>ppt_x</p:attrName>
+                                        </p:attrNameLst>
+                                      </p:cBhvr>
+                                      <p:tavLst>
+                                        <p:tav tm="0">
+                                          <p:val>
+                                            <p:strVal val="#ppt_x"/>
+                                          </p:val>
+                                        </p:tav>
+                                        <p:tav tm="100000">
+                                          <p:val>
+                                            <p:strVal val="#ppt_x"/>
+                                          </p:val>
+                                        </p:tav>
+                                      </p:tavLst>
+                                    </p:anim>
+                                    <p:anim calcmode="lin" valueType="num">
+                                      <p:cBhvr>
+                                        <p:cTn id="23" dur="1000" fill="hold"/>
+                                        <p:tgtEl>
+                                          <p:spTgt spid="34"/>
+                                        </p:tgtEl>
+                                        <p:attrNameLst>
+                                          <p:attrName>ppt_y</p:attrName>
+                                        </p:attrNameLst>
+                                      </p:cBhvr>
+                                      <p:tavLst>
+                                        <p:tav tm="0">
+                                          <p:val>
+                                            <p:strVal val="#ppt_y+.1"/>
+                                          </p:val>
+                                        </p:tav>
+                                        <p:tav tm="100000">
+                                          <p:val>
+                                            <p:strVal val="#ppt_y"/>
+                                          </p:val>
+                                        </p:tav>
+                                      </p:tavLst>
+                                    </p:anim>
+                                  </p:childTnLst>
+                                </p:cTn>
+                              </p:par>
+                            </p:childTnLst>
+                          </p:cTn>
+                        </p:par>
+                      </p:childTnLst>
+                    </p:cTn>
+                  </p:par>
+                  <p:par>
+                    <p:cTn id="24" fill="hold">
+                      <p:stCondLst>
+                        <p:cond delay="indefinite"/>
+                      </p:stCondLst>
+                      <p:childTnLst>
+                        <p:par>
+                          <p:cTn id="25" fill="hold">
+                            <p:stCondLst>
+                              <p:cond delay="0"/>
+                            </p:stCondLst>
+                            <p:childTnLst>
+                              <p:par>
+                                <p:cTn id="26" presetID="42" presetClass="entr" presetSubtype="0" fill="hold" nodeType="clickEffect">
+                                  <p:stCondLst>
+                                    <p:cond delay="0"/>
+                                  </p:stCondLst>
+                                  <p:childTnLst>
+                                    <p:set>
+                                      <p:cBhvr>
+                                        <p:cTn id="27" dur="1" fill="hold">
+                                          <p:stCondLst>
+                                            <p:cond delay="0"/>
+                                          </p:stCondLst>
+                                        </p:cTn>
+                                        <p:tgtEl>
+                                          <p:spTgt spid="42"/>
+                                        </p:tgtEl>
+                                        <p:attrNameLst>
+                                          <p:attrName>style.visibility</p:attrName>
+                                        </p:attrNameLst>
+                                      </p:cBhvr>
+                                      <p:to>
+                                        <p:strVal val="visible"/>
+                                      </p:to>
+                                    </p:set>
+                                    <p:animEffect transition="in" filter="fade">
+                                      <p:cBhvr>
+                                        <p:cTn id="28" dur="1000"/>
+                                        <p:tgtEl>
+                                          <p:spTgt spid="42"/>
+                                        </p:tgtEl>
+                                      </p:cBhvr>
+                                    </p:animEffect>
+                                    <p:anim calcmode="lin" valueType="num">
+                                      <p:cBhvr>
+                                        <p:cTn id="29" dur="1000" fill="hold"/>
+                                        <p:tgtEl>
+                                          <p:spTgt spid="42"/>
+                                        </p:tgtEl>
+                                        <p:attrNameLst>
+                                          <p:attrName>ppt_x</p:attrName>
+                                        </p:attrNameLst>
+                                      </p:cBhvr>
+                                      <p:tavLst>
+                                        <p:tav tm="0">
+                                          <p:val>
+                                            <p:strVal val="#ppt_x"/>
+                                          </p:val>
+                                        </p:tav>
+                                        <p:tav tm="100000">
+                                          <p:val>
+                                            <p:strVal val="#ppt_x"/>
+                                          </p:val>
+                                        </p:tav>
+                                      </p:tavLst>
+                                    </p:anim>
+                                    <p:anim calcmode="lin" valueType="num">
+                                      <p:cBhvr>
+                                        <p:cTn id="30" dur="1000" fill="hold"/>
+                                        <p:tgtEl>
+                                          <p:spTgt spid="42"/>
+                                        </p:tgtEl>
+                                        <p:attrNameLst>
+                                          <p:attrName>ppt_y</p:attrName>
+                                        </p:attrNameLst>
+                                      </p:cBhvr>
+                                      <p:tavLst>
+                                        <p:tav tm="0">
+                                          <p:val>
+                                            <p:strVal val="#ppt_y+.1"/>
+                                          </p:val>
+                                        </p:tav>
+                                        <p:tav tm="100000">
+                                          <p:val>
+                                            <p:strVal val="#ppt_y"/>
+                                          </p:val>
+                                        </p:tav>
+                                      </p:tavLst>
+                                    </p:anim>
+                                  </p:childTnLst>
+                                </p:cTn>
+                              </p:par>
+                            </p:childTnLst>
+                          </p:cTn>
+                        </p:par>
+                      </p:childTnLst>
+                    </p:cTn>
+                  </p:par>
+                  <p:par>
+                    <p:cTn id="31" fill="hold">
+                      <p:stCondLst>
+                        <p:cond delay="indefinite"/>
+                      </p:stCondLst>
+                      <p:childTnLst>
+                        <p:par>
+                          <p:cTn id="32" fill="hold">
+                            <p:stCondLst>
+                              <p:cond delay="0"/>
+                            </p:stCondLst>
+                            <p:childTnLst>
+                              <p:par>
+                                <p:cTn id="33" presetID="42" presetClass="entr" presetSubtype="0" fill="hold" nodeType="clickEffect">
+                                  <p:stCondLst>
+                                    <p:cond delay="0"/>
+                                  </p:stCondLst>
+                                  <p:childTnLst>
+                                    <p:set>
+                                      <p:cBhvr>
+                                        <p:cTn id="34" dur="1" fill="hold">
+                                          <p:stCondLst>
+                                            <p:cond delay="0"/>
+                                          </p:stCondLst>
+                                        </p:cTn>
+                                        <p:tgtEl>
+                                          <p:spTgt spid="38"/>
+                                        </p:tgtEl>
+                                        <p:attrNameLst>
+                                          <p:attrName>style.visibility</p:attrName>
+                                        </p:attrNameLst>
+                                      </p:cBhvr>
+                                      <p:to>
+                                        <p:strVal val="visible"/>
+                                      </p:to>
+                                    </p:set>
+                                    <p:animEffect transition="in" filter="fade">
+                                      <p:cBhvr>
+                                        <p:cTn id="35" dur="1000"/>
+                                        <p:tgtEl>
+                                          <p:spTgt spid="38"/>
+                                        </p:tgtEl>
+                                      </p:cBhvr>
+                                    </p:animEffect>
+                                    <p:anim calcmode="lin" valueType="num">
+                                      <p:cBhvr>
+                                        <p:cTn id="36" dur="1000" fill="hold"/>
+                                        <p:tgtEl>
+                                          <p:spTgt spid="38"/>
+                                        </p:tgtEl>
+                                        <p:attrNameLst>
+                                          <p:attrName>ppt_x</p:attrName>
+                                        </p:attrNameLst>
+                                      </p:cBhvr>
+                                      <p:tavLst>
+                                        <p:tav tm="0">
+                                          <p:val>
+                                            <p:strVal val="#ppt_x"/>
+                                          </p:val>
+                                        </p:tav>
+                                        <p:tav tm="100000">
+                                          <p:val>
+                                            <p:strVal val="#ppt_x"/>
+                                          </p:val>
+                                        </p:tav>
+                                      </p:tavLst>
+                                    </p:anim>
+                                    <p:anim calcmode="lin" valueType="num">
+                                      <p:cBhvr>
+                                        <p:cTn id="37" dur="1000" fill="hold"/>
+                                        <p:tgtEl>
+                                          <p:spTgt spid="38"/>
+                                        </p:tgtEl>
+                                        <p:attrNameLst>
+                                          <p:attrName>ppt_y</p:attrName>
+                                        </p:attrNameLst>
+                                      </p:cBhvr>
+                                      <p:tavLst>
+                                        <p:tav tm="0">
+                                          <p:val>
+                                            <p:strVal val="#ppt_y+.1"/>
+                                          </p:val>
+                                        </p:tav>
+                                        <p:tav tm="100000">
+                                          <p:val>
+                                            <p:strVal val="#ppt_y"/>
+                                          </p:val>
+                                        </p:tav>
+                                      </p:tavLst>
+                                    </p:anim>
+                                  </p:childTnLst>
+                                </p:cTn>
+                              </p:par>
+                            </p:childTnLst>
+                          </p:cTn>
+                        </p:par>
+                      </p:childTnLst>
+                    </p:cTn>
+                  </p:par>
+                  <p:par>
+                    <p:cTn id="38" fill="hold">
+                      <p:stCondLst>
+                        <p:cond delay="indefinite"/>
+                      </p:stCondLst>
+                      <p:childTnLst>
+                        <p:par>
+                          <p:cTn id="39" fill="hold">
+                            <p:stCondLst>
+                              <p:cond delay="0"/>
+                            </p:stCondLst>
+                            <p:childTnLst>
+                              <p:par>
+                                <p:cTn id="40" presetID="42" presetClass="entr" presetSubtype="0" fill="hold" nodeType="clickEffect">
+                                  <p:stCondLst>
+                                    <p:cond delay="0"/>
+                                  </p:stCondLst>
+                                  <p:childTnLst>
+                                    <p:set>
+                                      <p:cBhvr>
+                                        <p:cTn id="41" dur="1" fill="hold">
+                                          <p:stCondLst>
+                                            <p:cond delay="0"/>
+                                          </p:stCondLst>
+                                        </p:cTn>
+                                        <p:tgtEl>
+                                          <p:spTgt spid="28"/>
+                                        </p:tgtEl>
+                                        <p:attrNameLst>
+                                          <p:attrName>style.visibility</p:attrName>
+                                        </p:attrNameLst>
+                                      </p:cBhvr>
+                                      <p:to>
+                                        <p:strVal val="visible"/>
+                                      </p:to>
+                                    </p:set>
+                                    <p:animEffect transition="in" filter="fade">
+                                      <p:cBhvr>
+                                        <p:cTn id="42" dur="1000"/>
+                                        <p:tgtEl>
+                                          <p:spTgt spid="28"/>
+                                        </p:tgtEl>
+                                      </p:cBhvr>
+                                    </p:animEffect>
+                                    <p:anim calcmode="lin" valueType="num">
+                                      <p:cBhvr>
+                                        <p:cTn id="43" dur="1000" fill="hold"/>
+                                        <p:tgtEl>
+                                          <p:spTgt spid="28"/>
+                                        </p:tgtEl>
+                                        <p:attrNameLst>
+                                          <p:attrName>ppt_x</p:attrName>
+                                        </p:attrNameLst>
+                                      </p:cBhvr>
+                                      <p:tavLst>
+                                        <p:tav tm="0">
+                                          <p:val>
+                                            <p:strVal val="#ppt_x"/>
+                                          </p:val>
+                                        </p:tav>
+                                        <p:tav tm="100000">
+                                          <p:val>
+                                            <p:strVal val="#ppt_x"/>
+                                          </p:val>
+                                        </p:tav>
+                                      </p:tavLst>
+                                    </p:anim>
+                                    <p:anim calcmode="lin" valueType="num">
+                                      <p:cBhvr>
+                                        <p:cTn id="44" dur="1000" fill="hold"/>
+                                        <p:tgtEl>
+                                          <p:spTgt spid="28"/>
+                                        </p:tgtEl>
+                                        <p:attrNameLst>
+                                          <p:attrName>ppt_y</p:attrName>
+                                        </p:attrNameLst>
+                                      </p:cBhvr>
+                                      <p:tavLst>
+                                        <p:tav tm="0">
+                                          <p:val>
+                                            <p:strVal val="#ppt_y+.1"/>
+                                          </p:val>
+                                        </p:tav>
+                                        <p:tav tm="100000">
+                                          <p:val>
+                                            <p:strVal val="#ppt_y"/>
+                                          </p:val>
+                                        </p:tav>
+                                      </p:tavLst>
+                                    </p:anim>
+                                  </p:childTnLst>
+                                </p:cTn>
+                              </p:par>
+                            </p:childTnLst>
+                          </p:cTn>
+                        </p:par>
+                      </p:childTnLst>
+                    </p:cTn>
+                  </p:par>
+                  <p:par>
+                    <p:cTn id="45" fill="hold">
+                      <p:stCondLst>
+                        <p:cond delay="indefinite"/>
+                      </p:stCondLst>
+                      <p:childTnLst>
+                        <p:par>
+                          <p:cTn id="46" fill="hold">
+                            <p:stCondLst>
+                              <p:cond delay="0"/>
+                            </p:stCondLst>
+                            <p:childTnLst>
+                              <p:par>
+                                <p:cTn id="47" presetID="42" presetClass="entr" presetSubtype="0" fill="hold" nodeType="clickEffect">
+                                  <p:stCondLst>
+                                    <p:cond delay="0"/>
+                                  </p:stCondLst>
+                                  <p:childTnLst>
+                                    <p:set>
+                                      <p:cBhvr>
+                                        <p:cTn id="48" dur="1" fill="hold">
+                                          <p:stCondLst>
+                                            <p:cond delay="0"/>
+                                          </p:stCondLst>
+                                        </p:cTn>
+                                        <p:tgtEl>
+                                          <p:spTgt spid="30"/>
+                                        </p:tgtEl>
+                                        <p:attrNameLst>
+                                          <p:attrName>style.visibility</p:attrName>
+                                        </p:attrNameLst>
+                                      </p:cBhvr>
+                                      <p:to>
+                                        <p:strVal val="visible"/>
+                                      </p:to>
+                                    </p:set>
+                                    <p:animEffect transition="in" filter="fade">
+                                      <p:cBhvr>
+                                        <p:cTn id="49" dur="1000"/>
+                                        <p:tgtEl>
+                                          <p:spTgt spid="30"/>
+                                        </p:tgtEl>
+                                      </p:cBhvr>
+                                    </p:animEffect>
+                                    <p:anim calcmode="lin" valueType="num">
+                                      <p:cBhvr>
+                                        <p:cTn id="50" dur="1000" fill="hold"/>
+                                        <p:tgtEl>
+                                          <p:spTgt spid="30"/>
+                                        </p:tgtEl>
+                                        <p:attrNameLst>
+                                          <p:attrName>ppt_x</p:attrName>
+                                        </p:attrNameLst>
+                                      </p:cBhvr>
+                                      <p:tavLst>
+                                        <p:tav tm="0">
+                                          <p:val>
+                                            <p:strVal val="#ppt_x"/>
+                                          </p:val>
+                                        </p:tav>
+                                        <p:tav tm="100000">
+                                          <p:val>
+                                            <p:strVal val="#ppt_x"/>
+                                          </p:val>
+                                        </p:tav>
+                                      </p:tavLst>
+                                    </p:anim>
+                                    <p:anim calcmode="lin" valueType="num">
+                                      <p:cBhvr>
+                                        <p:cTn id="51" dur="1000" fill="hold"/>
+                                        <p:tgtEl>
+                                          <p:spTgt spid="30"/>
+                                        </p:tgtEl>
+                                        <p:attrNameLst>
+                                          <p:attrName>ppt_y</p:attrName>
+                                        </p:attrNameLst>
+                                      </p:cBhvr>
+                                      <p:tavLst>
+                                        <p:tav tm="0">
+                                          <p:val>
+                                            <p:strVal val="#ppt_y+.1"/>
+                                          </p:val>
+                                        </p:tav>
+                                        <p:tav tm="100000">
+                                          <p:val>
+                                            <p:strVal val="#ppt_y"/>
+                                          </p:val>
+                                        </p:tav>
+                                      </p:tavLst>
+                                    </p:anim>
+                                  </p:childTnLst>
+                                </p:cTn>
+                              </p:par>
+                            </p:childTnLst>
+                          </p:cTn>
+                        </p:par>
+                      </p:childTnLst>
+                    </p:cTn>
+                  </p:par>
+                  <p:par>
+                    <p:cTn id="52" fill="hold">
+                      <p:stCondLst>
+                        <p:cond delay="indefinite"/>
+                      </p:stCondLst>
+                      <p:childTnLst>
+                        <p:par>
+                          <p:cTn id="53" fill="hold">
+                            <p:stCondLst>
+                              <p:cond delay="0"/>
+                            </p:stCondLst>
+                            <p:childTnLst>
+                              <p:par>
+                                <p:cTn id="54" presetID="42" presetClass="entr" presetSubtype="0" fill="hold" nodeType="clickEffect">
+                                  <p:stCondLst>
+                                    <p:cond delay="0"/>
+                                  </p:stCondLst>
+                                  <p:childTnLst>
+                                    <p:set>
+                                      <p:cBhvr>
+                                        <p:cTn id="55" dur="1" fill="hold">
+                                          <p:stCondLst>
+                                            <p:cond delay="0"/>
+                                          </p:stCondLst>
+                                        </p:cTn>
+                                        <p:tgtEl>
+                                          <p:spTgt spid="40"/>
+                                        </p:tgtEl>
+                                        <p:attrNameLst>
+                                          <p:attrName>style.visibility</p:attrName>
+                                        </p:attrNameLst>
+                                      </p:cBhvr>
+                                      <p:to>
+                                        <p:strVal val="visible"/>
+                                      </p:to>
+                                    </p:set>
+                                    <p:animEffect transition="in" filter="fade">
+                                      <p:cBhvr>
+                                        <p:cTn id="56" dur="1000"/>
+                                        <p:tgtEl>
+                                          <p:spTgt spid="40"/>
+                                        </p:tgtEl>
+                                      </p:cBhvr>
+                                    </p:animEffect>
+                                    <p:anim calcmode="lin" valueType="num">
+                                      <p:cBhvr>
+                                        <p:cTn id="57" dur="1000" fill="hold"/>
+                                        <p:tgtEl>
+                                          <p:spTgt spid="40"/>
+                                        </p:tgtEl>
+                                        <p:attrNameLst>
+                                          <p:attrName>ppt_x</p:attrName>
+                                        </p:attrNameLst>
+                                      </p:cBhvr>
+                                      <p:tavLst>
+                                        <p:tav tm="0">
+                                          <p:val>
+                                            <p:strVal val="#ppt_x"/>
+                                          </p:val>
+                                        </p:tav>
+                                        <p:tav tm="100000">
+                                          <p:val>
+                                            <p:strVal val="#ppt_x"/>
+                                          </p:val>
+                                        </p:tav>
+                                      </p:tavLst>
+                                    </p:anim>
+                                    <p:anim calcmode="lin" valueType="num">
+                                      <p:cBhvr>
+                                        <p:cTn id="58" dur="1000" fill="hold"/>
+                                        <p:tgtEl>
+                                          <p:spTgt spid="40"/>
+                                        </p:tgtEl>
+                                        <p:attrNameLst>
+                                          <p:attrName>ppt_y</p:attrName>
+                                        </p:attrNameLst>
+                                      </p:cBhvr>
+                                      <p:tavLst>
+                                        <p:tav tm="0">
+                                          <p:val>
+                                            <p:strVal val="#ppt_y+.1"/>
+                                          </p:val>
+                                        </p:tav>
+                                        <p:tav tm="100000">
+                                          <p:val>
+                                            <p:strVal val="#ppt_y"/>
+                                          </p:val>
+                                        </p:tav>
+                                      </p:tavLst>
+                                    </p:anim>
+                                  </p:childTnLst>
+                                </p:cTn>
+                              </p:par>
+                            </p:childTnLst>
+                          </p:cTn>
+                        </p:par>
+                      </p:childTnLst>
+                    </p:cTn>
+                  </p:par>
+                  <p:par>
+                    <p:cTn id="59" fill="hold">
+                      <p:stCondLst>
+                        <p:cond delay="indefinite"/>
+                      </p:stCondLst>
+                      <p:childTnLst>
+                        <p:par>
+                          <p:cTn id="60" fill="hold">
+                            <p:stCondLst>
+                              <p:cond delay="0"/>
+                            </p:stCondLst>
+                            <p:childTnLst>
+                              <p:par>
+                                <p:cTn id="61" presetID="42" presetClass="entr" presetSubtype="0" fill="hold" nodeType="clickEffect">
+                                  <p:stCondLst>
+                                    <p:cond delay="0"/>
+                                  </p:stCondLst>
+                                  <p:childTnLst>
+                                    <p:set>
+                                      <p:cBhvr>
+                                        <p:cTn id="62" dur="1" fill="hold">
+                                          <p:stCondLst>
+                                            <p:cond delay="0"/>
+                                          </p:stCondLst>
+                                        </p:cTn>
+                                        <p:tgtEl>
+                                          <p:spTgt spid="26"/>
+                                        </p:tgtEl>
+                                        <p:attrNameLst>
+                                          <p:attrName>style.visibility</p:attrName>
+                                        </p:attrNameLst>
+                                      </p:cBhvr>
+                                      <p:to>
+                                        <p:strVal val="visible"/>
+                                      </p:to>
+                                    </p:set>
+                                    <p:animEffect transition="in" filter="fade">
+                                      <p:cBhvr>
+                                        <p:cTn id="63" dur="1000"/>
+                                        <p:tgtEl>
+                                          <p:spTgt spid="26"/>
+                                        </p:tgtEl>
+                                      </p:cBhvr>
+                                    </p:animEffect>
+                                    <p:anim calcmode="lin" valueType="num">
+                                      <p:cBhvr>
+                                        <p:cTn id="64" dur="1000" fill="hold"/>
+                                        <p:tgtEl>
+                                          <p:spTgt spid="26"/>
+                                        </p:tgtEl>
+                                        <p:attrNameLst>
+                                          <p:attrName>ppt_x</p:attrName>
+                                        </p:attrNameLst>
+                                      </p:cBhvr>
+                                      <p:tavLst>
+                                        <p:tav tm="0">
+                                          <p:val>
+                                            <p:strVal val="#ppt_x"/>
+                                          </p:val>
+                                        </p:tav>
+                                        <p:tav tm="100000">
+                                          <p:val>
+                                            <p:strVal val="#ppt_x"/>
+                                          </p:val>
+                                        </p:tav>
+                                      </p:tavLst>
+                                    </p:anim>
+                                    <p:anim calcmode="lin" valueType="num">
+                                      <p:cBhvr>
+                                        <p:cTn id="65" dur="1000" fill="hold"/>
+                                        <p:tgtEl>
+                                          <p:spTgt spid="26"/>
+                                        </p:tgtEl>
+                                        <p:attrNameLst>
+                                          <p:attrName>ppt_y</p:attrName>
+                                        </p:attrNameLst>
+                                      </p:cBhvr>
+                                      <p:tavLst>
+                                        <p:tav tm="0">
+                                          <p:val>
+                                            <p:strVal val="#ppt_y+.1"/>
+                                          </p:val>
+                                        </p:tav>
+                                        <p:tav tm="100000">
+                                          <p:val>
+                                            <p:strVal val="#ppt_y"/>
+                                          </p:val>
+                                        </p:tav>
+                                      </p:tavLst>
+                                    </p:anim>
+                                  </p:childTnLst>
+                                </p:cTn>
+                              </p:par>
+                            </p:childTnLst>
+                          </p:cTn>
+                        </p:par>
+                      </p:childTnLst>
+                    </p:cTn>
+                  </p:par>
+                  <p:par>
+                    <p:cTn id="66" fill="hold">
+                      <p:stCondLst>
+                        <p:cond delay="indefinite"/>
+                      </p:stCondLst>
+                      <p:childTnLst>
+                        <p:par>
+                          <p:cTn id="67" fill="hold">
+                            <p:stCondLst>
+                              <p:cond delay="0"/>
+                            </p:stCondLst>
+                            <p:childTnLst>
+                              <p:par>
+                                <p:cTn id="68" presetID="42" presetClass="entr" presetSubtype="0" fill="hold" nodeType="clickEffect">
+                                  <p:stCondLst>
+                                    <p:cond delay="0"/>
+                                  </p:stCondLst>
+                                  <p:childTnLst>
+                                    <p:set>
+                                      <p:cBhvr>
+                                        <p:cTn id="69" dur="1" fill="hold">
+                                          <p:stCondLst>
+                                            <p:cond delay="0"/>
+                                          </p:stCondLst>
+                                        </p:cTn>
+                                        <p:tgtEl>
+                                          <p:spTgt spid="36"/>
+                                        </p:tgtEl>
+                                        <p:attrNameLst>
+                                          <p:attrName>style.visibility</p:attrName>
+                                        </p:attrNameLst>
+                                      </p:cBhvr>
+                                      <p:to>
+                                        <p:strVal val="visible"/>
+                                      </p:to>
+                                    </p:set>
+                                    <p:animEffect transition="in" filter="fade">
+                                      <p:cBhvr>
+                                        <p:cTn id="70" dur="1000"/>
+                                        <p:tgtEl>
+                                          <p:spTgt spid="36"/>
+                                        </p:tgtEl>
+                                      </p:cBhvr>
+                                    </p:animEffect>
+                                    <p:anim calcmode="lin" valueType="num">
+                                      <p:cBhvr>
+                                        <p:cTn id="71" dur="1000" fill="hold"/>
+                                        <p:tgtEl>
+                                          <p:spTgt spid="36"/>
+                                        </p:tgtEl>
+                                        <p:attrNameLst>
+                                          <p:attrName>ppt_x</p:attrName>
+                                        </p:attrNameLst>
+                                      </p:cBhvr>
+                                      <p:tavLst>
+                                        <p:tav tm="0">
+                                          <p:val>
+                                            <p:strVal val="#ppt_x"/>
+                                          </p:val>
+                                        </p:tav>
+                                        <p:tav tm="100000">
+                                          <p:val>
+                                            <p:strVal val="#ppt_x"/>
+                                          </p:val>
+                                        </p:tav>
+                                      </p:tavLst>
+                                    </p:anim>
+                                    <p:anim calcmode="lin" valueType="num">
+                                      <p:cBhvr>
+                                        <p:cTn id="72" dur="1000" fill="hold"/>
+                                        <p:tgtEl>
+                                          <p:spTgt spid="36"/>
+                                        </p:tgtEl>
+                                        <p:attrNameLst>
+                                          <p:attrName>ppt_y</p:attrName>
+                                        </p:attrNameLst>
+                                      </p:cBhvr>
+                                      <p:tavLst>
+                                        <p:tav tm="0">
+                                          <p:val>
+                                            <p:strVal val="#ppt_y+.1"/>
+                                          </p:val>
+                                        </p:tav>
+                                        <p:tav tm="100000">
+                                          <p:val>
+                                            <p:strVal val="#ppt_y"/>
+                                          </p:val>
+                                        </p:tav>
+                                      </p:tavLst>
+                                    </p:anim>
+                                  </p:childTnLst>
+                                </p:cTn>
+                              </p:par>
+                            </p:childTnLst>
+                          </p:cTn>
+                        </p:par>
+                      </p:childTnLst>
+                    </p:cTn>
+                  </p:par>
+                  <p:par>
+                    <p:cTn id="73" fill="hold">
+                      <p:stCondLst>
+                        <p:cond delay="indefinite"/>
+                      </p:stCondLst>
+                      <p:childTnLst>
+                        <p:par>
+                          <p:cTn id="74" fill="hold">
+                            <p:stCondLst>
+                              <p:cond delay="0"/>
+                            </p:stCondLst>
+                            <p:childTnLst>
+                              <p:par>
+                                <p:cTn id="75" presetID="42" presetClass="entr" presetSubtype="0" fill="hold" nodeType="clickEffect">
+                                  <p:stCondLst>
+                                    <p:cond delay="0"/>
+                                  </p:stCondLst>
+                                  <p:childTnLst>
+                                    <p:set>
+                                      <p:cBhvr>
+                                        <p:cTn id="76" dur="1" fill="hold">
+                                          <p:stCondLst>
+                                            <p:cond delay="0"/>
+                                          </p:stCondLst>
+                                        </p:cTn>
+                                        <p:tgtEl>
+                                          <p:spTgt spid="32"/>
+                                        </p:tgtEl>
+                                        <p:attrNameLst>
+                                          <p:attrName>style.visibility</p:attrName>
+                                        </p:attrNameLst>
+                                      </p:cBhvr>
+                                      <p:to>
+                                        <p:strVal val="visible"/>
+                                      </p:to>
+                                    </p:set>
+                                    <p:animEffect transition="in" filter="fade">
+                                      <p:cBhvr>
+                                        <p:cTn id="77" dur="1000"/>
+                                        <p:tgtEl>
+                                          <p:spTgt spid="32"/>
+                                        </p:tgtEl>
+                                      </p:cBhvr>
+                                    </p:animEffect>
+                                    <p:anim calcmode="lin" valueType="num">
+                                      <p:cBhvr>
+                                        <p:cTn id="78" dur="1000" fill="hold"/>
+                                        <p:tgtEl>
+                                          <p:spTgt spid="32"/>
+                                        </p:tgtEl>
+                                        <p:attrNameLst>
+                                          <p:attrName>ppt_x</p:attrName>
+                                        </p:attrNameLst>
+                                      </p:cBhvr>
+                                      <p:tavLst>
+                                        <p:tav tm="0">
+                                          <p:val>
+                                            <p:strVal val="#ppt_x"/>
+                                          </p:val>
+                                        </p:tav>
+                                        <p:tav tm="100000">
+                                          <p:val>
+                                            <p:strVal val="#ppt_x"/>
+                                          </p:val>
+                                        </p:tav>
+                                      </p:tavLst>
+                                    </p:anim>
+                                    <p:anim calcmode="lin" valueType="num">
+                                      <p:cBhvr>
+                                        <p:cTn id="79" dur="1000" fill="hold"/>
+                                        <p:tgtEl>
+                                          <p:spTgt spid="32"/>
+                                        </p:tgtEl>
+                                        <p:attrNameLst>
+                                          <p:attrName>ppt_y</p:attrName>
+                                        </p:attrNameLst>
+                                      </p:cBhvr>
+                                      <p:tavLst>
+                                        <p:tav tm="0">
+                                          <p:val>
+                                            <p:strVal val="#ppt_y+.1"/>
+                                          </p:val>
+                                        </p:tav>
+                                        <p:tav tm="100000">
+                                          <p:val>
+                                            <p:strVal val="#ppt_y"/>
+                                          </p:val>
+                                        </p:tav>
+                                      </p:tavLst>
+                                    </p:anim>
+                                  </p:childTnLst>
+                                </p:cTn>
+                              </p:par>
+                            </p:childTnLst>
+                          </p:cTn>
+                        </p:par>
+                      </p:childTnLst>
+                    </p:cTn>
+                  </p:par>
+                  <p:par>
+                    <p:cTn id="80" fill="hold">
+                      <p:stCondLst>
+                        <p:cond delay="indefinite"/>
+                      </p:stCondLst>
+                      <p:childTnLst>
+                        <p:par>
+                          <p:cTn id="81" fill="hold">
+                            <p:stCondLst>
+                              <p:cond delay="0"/>
+                            </p:stCondLst>
+                            <p:childTnLst>
+                              <p:par>
+                                <p:cTn id="82" presetID="42" presetClass="entr" presetSubtype="0" fill="hold" nodeType="clickEffect">
+                                  <p:stCondLst>
+                                    <p:cond delay="0"/>
+                                  </p:stCondLst>
+                                  <p:childTnLst>
+                                    <p:set>
+                                      <p:cBhvr>
+                                        <p:cTn id="83" dur="1" fill="hold">
+                                          <p:stCondLst>
+                                            <p:cond delay="0"/>
+                                          </p:stCondLst>
+                                        </p:cTn>
+                                        <p:tgtEl>
+                                          <p:spTgt spid="44"/>
+                                        </p:tgtEl>
+                                        <p:attrNameLst>
+                                          <p:attrName>style.visibility</p:attrName>
+                                        </p:attrNameLst>
+                                      </p:cBhvr>
+                                      <p:to>
+                                        <p:strVal val="visible"/>
+                                      </p:to>
+                                    </p:set>
+                                    <p:animEffect transition="in" filter="fade">
+                                      <p:cBhvr>
+                                        <p:cTn id="84" dur="1000"/>
+                                        <p:tgtEl>
+                                          <p:spTgt spid="44"/>
+                                        </p:tgtEl>
+                                      </p:cBhvr>
+                                    </p:animEffect>
+                                    <p:anim calcmode="lin" valueType="num">
+                                      <p:cBhvr>
+                                        <p:cTn id="85" dur="1000" fill="hold"/>
+                                        <p:tgtEl>
+                                          <p:spTgt spid="44"/>
+                                        </p:tgtEl>
+                                        <p:attrNameLst>
+                                          <p:attrName>ppt_x</p:attrName>
+                                        </p:attrNameLst>
+                                      </p:cBhvr>
+                                      <p:tavLst>
+                                        <p:tav tm="0">
+                                          <p:val>
+                                            <p:strVal val="#ppt_x"/>
+                                          </p:val>
+                                        </p:tav>
+                                        <p:tav tm="100000">
+                                          <p:val>
+                                            <p:strVal val="#ppt_x"/>
+                                          </p:val>
+                                        </p:tav>
+                                      </p:tavLst>
+                                    </p:anim>
+                                    <p:anim calcmode="lin" valueType="num">
+                                      <p:cBhvr>
+                                        <p:cTn id="86" dur="1000" fill="hold"/>
+                                        <p:tgtEl>
+                                          <p:spTgt spid="44"/>
+                                        </p:tgtEl>
+                                        <p:attrNameLst>
+                                          <p:attrName>ppt_y</p:attrName>
+                                        </p:attrNameLst>
+                                      </p:cBhvr>
+                                      <p:tavLst>
+                                        <p:tav tm="0">
+                                          <p:val>
+                                            <p:strVal val="#ppt_y+.1"/>
+                                          </p:val>
+                                        </p:tav>
+                                        <p:tav tm="100000">
+                                          <p:val>
+                                            <p:strVal val="#ppt_y"/>
+                                          </p:val>
+                                        </p:tav>
+                                      </p:tavLst>
+                                    </p:anim>
+                                  </p:childTnLst>
+                                </p:cTn>
+                              </p:par>
+                            </p:childTnLst>
+                          </p:cTn>
+                        </p:par>
+                      </p:childTnLst>
+                    </p:cTn>
+                  </p:par>
+                </p:childTnLst>
+              </p:cTn>
+              <p:prevCondLst>
+                <p:cond evt="onPrev" delay="0">
+                  <p:tgtEl>
+                    <p:sldTgt/>
+                  </p:tgtEl>
+                </p:cond>
+              </p:prevCondLst>
+              <p:nextCondLst>
+                <p:cond evt="onNext" delay="0">
+                  <p:tgtEl>
+                    <p:sldTgt/>
+                  </p:tgtEl>
+                </p:cond>
+              </p:nextCondLst>
+            </p:seq>
+          </p:childTnLst>
+        </p:cTn>
+      </p:par>
+    </p:tnLst>
+  </p:timing>
+</p:sld>
+</file>
+
+<file path=ppt/slides/slide8.xml><?xml version="1.0" encoding="utf-8"?>
+<p:sld xmlns:a="http://schemas.openxmlformats.org/drawingml/2006/main" xmlns:r="http://schemas.openxmlformats.org/officeDocument/2006/relationships" xmlns:p="http://schemas.openxmlformats.org/presentationml/2006/main">
+  <p:cSld>
+    <p:spTree>
+      <p:nvGrpSpPr>
+        <p:cNvPr id="1" name=""/>
+        <p:cNvGrpSpPr/>
+        <p:nvPr/>
+      </p:nvGrpSpPr>
+      <p:grpSpPr>
+        <a:xfrm>
+          <a:off x="0" y="0"/>
+          <a:ext cx="0" cy="0"/>
+          <a:chOff x="0" y="0"/>
+          <a:chExt cx="0" cy="0"/>
+        </a:xfrm>
+      </p:grpSpPr>
+      <p:sp>
+        <p:nvSpPr>
+          <p:cNvPr id="2" name="Titolo 1">
+            <a:extLst>
+              <a:ext uri="{FF2B5EF4-FFF2-40B4-BE49-F238E27FC236}">
+                <a16:creationId xmlns:a16="http://schemas.microsoft.com/office/drawing/2014/main" id="{F5A6D474-D27D-69CB-795C-6991DFE04FCF}"/>
+              </a:ext>
+            </a:extLst>
+          </p:cNvPr>
+          <p:cNvSpPr>
+            <a:spLocks noGrp="1"/>
+          </p:cNvSpPr>
+          <p:nvPr>
+            <p:ph type="title"/>
+          </p:nvPr>
+        </p:nvSpPr>
+        <p:spPr/>
+        <p:txBody>
+          <a:bodyPr/>
+          <a:lstStyle/>
+          <a:p>
+            <a:pPr algn="ctr"/>
+            <a:r>
+              <a:rPr lang="it-IT" dirty="0"/>
+              <a:t>SCHEMA ER</a:t>
+            </a:r>
+          </a:p>
+        </p:txBody>
+      </p:sp>
+      <p:pic>
+        <p:nvPicPr>
+          <p:cNvPr id="4" name="Immagine 3" descr="Immagine che contiene diagramma, linea, Policromia, design&#10;&#10;Il contenuto generato dall'IA potrebbe non essere corretto.">
+            <a:extLst>
+              <a:ext uri="{FF2B5EF4-FFF2-40B4-BE49-F238E27FC236}">
+                <a16:creationId xmlns:a16="http://schemas.microsoft.com/office/drawing/2014/main" id="{BE05FA8C-E45B-A594-DA54-61D463F2B37A}"/>
+              </a:ext>
+            </a:extLst>
+          </p:cNvPr>
+          <p:cNvPicPr>
+            <a:picLocks noChangeAspect="1"/>
+          </p:cNvPicPr>
+          <p:nvPr/>
+        </p:nvPicPr>
+        <p:blipFill>
+          <a:blip r:embed="rId2"/>
+          <a:stretch>
+            <a:fillRect/>
+          </a:stretch>
+        </p:blipFill>
+        <p:spPr>
+          <a:xfrm>
+            <a:off x="1455514" y="948326"/>
+            <a:ext cx="6610455" cy="3984806"/>
+          </a:xfrm>
+          <a:prstGeom prst="rect">
+            <a:avLst/>
+          </a:prstGeom>
+        </p:spPr>
+      </p:pic>
+    </p:spTree>
+    <p:extLst>
+      <p:ext uri="{BB962C8B-B14F-4D97-AF65-F5344CB8AC3E}">
+        <p14:creationId xmlns:p14="http://schemas.microsoft.com/office/powerpoint/2010/main" val="4170710722"/>
+      </p:ext>
+    </p:extLst>
+  </p:cSld>
+  <p:clrMapOvr>
+    <a:masterClrMapping/>
+  </p:clrMapOvr>
+  <p:timing>
+    <p:tnLst>
+      <p:par>
+        <p:cTn id="1" dur="indefinite" restart="never" nodeType="tmRoot">
+          <p:childTnLst>
+            <p:seq concurrent="1" nextAc="seek">
+              <p:cTn id="2" dur="indefinite" nodeType="mainSeq">
+                <p:childTnLst>
+                  <p:par>
+                    <p:cTn id="3" fill="hold">
+                      <p:stCondLst>
+                        <p:cond delay="indefinite"/>
+                      </p:stCondLst>
+                      <p:childTnLst>
+                        <p:par>
+                          <p:cTn id="4" fill="hold">
+                            <p:stCondLst>
+                              <p:cond delay="0"/>
+                            </p:stCondLst>
+                            <p:childTnLst>
+                              <p:par>
+                                <p:cTn id="5" presetID="22" presetClass="entr" presetSubtype="4" fill="hold" nodeType="clickEffect">
+                                  <p:stCondLst>
+                                    <p:cond delay="0"/>
+                                  </p:stCondLst>
+                                  <p:childTnLst>
+                                    <p:set>
+                                      <p:cBhvr>
+                                        <p:cTn id="6" dur="1" fill="hold">
+                                          <p:stCondLst>
+                                            <p:cond delay="0"/>
+                                          </p:stCondLst>
+                                        </p:cTn>
+                                        <p:tgtEl>
+                                          <p:spTgt spid="4"/>
+                                        </p:tgtEl>
+                                        <p:attrNameLst>
+                                          <p:attrName>style.visibility</p:attrName>
+                                        </p:attrNameLst>
+                                      </p:cBhvr>
+                                      <p:to>
+                                        <p:strVal val="visible"/>
+                                      </p:to>
+                                    </p:set>
+                                    <p:animEffect transition="in" filter="wipe(down)">
+                                      <p:cBhvr>
+                                        <p:cTn id="7" dur="500"/>
+                                        <p:tgtEl>
+                                          <p:spTgt spid="4"/>
+                                        </p:tgtEl>
+                                      </p:cBhvr>
+                                    </p:animEffect>
+                                  </p:childTnLst>
+                                </p:cTn>
+                              </p:par>
+                            </p:childTnLst>
+                          </p:cTn>
+                        </p:par>
+                      </p:childTnLst>
+                    </p:cTn>
+                  </p:par>
+                </p:childTnLst>
+              </p:cTn>
+              <p:prevCondLst>
+                <p:cond evt="onPrev" delay="0">
+                  <p:tgtEl>
+                    <p:sldTgt/>
+                  </p:tgtEl>
+                </p:cond>
+              </p:prevCondLst>
+              <p:nextCondLst>
+                <p:cond evt="onNext" delay="0">
+                  <p:tgtEl>
+                    <p:sldTgt/>
+                  </p:tgtEl>
+                </p:cond>
+              </p:nextCondLst>
+            </p:seq>
+          </p:childTnLst>
+        </p:cTn>
+      </p:par>
+    </p:tnLst>
+  </p:timing>
+</p:sld>
+</file>
+
+<file path=ppt/slides/slide9.xml><?xml version="1.0" encoding="utf-8"?>
 <p:sld xmlns:a="http://schemas.openxmlformats.org/drawingml/2006/main" xmlns:r="http://schemas.openxmlformats.org/officeDocument/2006/relationships" xmlns:p="http://schemas.openxmlformats.org/presentationml/2006/main">
   <p:cSld>
     <p:spTree>

</xml_diff>

<commit_message>
aggiunto wireframe wab a pp
</commit_message>
<xml_diff>
--- a/Documenti/Relazione Finale/PP relazione.pptx
+++ b/Documenti/Relazione Finale/PP relazione.pptx
@@ -5,7 +5,7 @@
     <p:sldMasterId id="2147483659" r:id="rId1"/>
   </p:sldMasterIdLst>
   <p:notesMasterIdLst>
-    <p:notesMasterId r:id="rId23"/>
+    <p:notesMasterId r:id="rId24"/>
   </p:notesMasterIdLst>
   <p:sldIdLst>
     <p:sldId id="256" r:id="rId2"/>
@@ -18,33 +18,34 @@
     <p:sldId id="262" r:id="rId9"/>
     <p:sldId id="265" r:id="rId10"/>
     <p:sldId id="260" r:id="rId11"/>
-    <p:sldId id="267" r:id="rId12"/>
-    <p:sldId id="269" r:id="rId13"/>
-    <p:sldId id="270" r:id="rId14"/>
-    <p:sldId id="271" r:id="rId15"/>
-    <p:sldId id="272" r:id="rId16"/>
-    <p:sldId id="273" r:id="rId17"/>
-    <p:sldId id="274" r:id="rId18"/>
-    <p:sldId id="275" r:id="rId19"/>
-    <p:sldId id="277" r:id="rId20"/>
-    <p:sldId id="278" r:id="rId21"/>
-    <p:sldId id="276" r:id="rId22"/>
+    <p:sldId id="279" r:id="rId12"/>
+    <p:sldId id="267" r:id="rId13"/>
+    <p:sldId id="269" r:id="rId14"/>
+    <p:sldId id="270" r:id="rId15"/>
+    <p:sldId id="271" r:id="rId16"/>
+    <p:sldId id="272" r:id="rId17"/>
+    <p:sldId id="273" r:id="rId18"/>
+    <p:sldId id="274" r:id="rId19"/>
+    <p:sldId id="275" r:id="rId20"/>
+    <p:sldId id="277" r:id="rId21"/>
+    <p:sldId id="278" r:id="rId22"/>
+    <p:sldId id="276" r:id="rId23"/>
   </p:sldIdLst>
   <p:sldSz cx="9144000" cy="5143500" type="screen16x9"/>
   <p:notesSz cx="6858000" cy="9144000"/>
   <p:embeddedFontLst>
     <p:embeddedFont>
       <p:font typeface="Amasis MT Pro" panose="02040504050005020304" pitchFamily="18" charset="0"/>
-      <p:regular r:id="rId24"/>
-      <p:bold r:id="rId25"/>
-      <p:italic r:id="rId26"/>
-      <p:boldItalic r:id="rId27"/>
+      <p:regular r:id="rId25"/>
+      <p:bold r:id="rId26"/>
+      <p:italic r:id="rId27"/>
+      <p:boldItalic r:id="rId28"/>
     </p:embeddedFont>
     <p:embeddedFont>
       <p:font typeface="Old Standard TT" panose="020B0604020202020204" charset="0"/>
-      <p:regular r:id="rId28"/>
-      <p:bold r:id="rId29"/>
-      <p:italic r:id="rId30"/>
+      <p:regular r:id="rId29"/>
+      <p:bold r:id="rId30"/>
+      <p:italic r:id="rId31"/>
     </p:embeddedFont>
   </p:embeddedFontLst>
   <p:defaultTextStyle>
@@ -7461,6 +7462,525 @@
           <p:cNvPr id="2" name="Titolo 1">
             <a:extLst>
               <a:ext uri="{FF2B5EF4-FFF2-40B4-BE49-F238E27FC236}">
+                <a16:creationId xmlns:a16="http://schemas.microsoft.com/office/drawing/2014/main" id="{D7801592-9091-B6BB-BCF7-AC7640166F9F}"/>
+              </a:ext>
+            </a:extLst>
+          </p:cNvPr>
+          <p:cNvSpPr>
+            <a:spLocks noGrp="1"/>
+          </p:cNvSpPr>
+          <p:nvPr>
+            <p:ph type="title"/>
+          </p:nvPr>
+        </p:nvSpPr>
+        <p:spPr/>
+        <p:txBody>
+          <a:bodyPr/>
+          <a:lstStyle/>
+          <a:p>
+            <a:pPr algn="ctr"/>
+            <a:r>
+              <a:rPr lang="it-IT" dirty="0" err="1"/>
+              <a:t>WireFrame</a:t>
+            </a:r>
+            <a:r>
+              <a:rPr lang="it-IT" dirty="0"/>
+              <a:t> Sito Web</a:t>
+            </a:r>
+          </a:p>
+        </p:txBody>
+      </p:sp>
+      <p:pic>
+        <p:nvPicPr>
+          <p:cNvPr id="4" name="Immagine 3" descr="Immagine che contiene schermata, testo, logo, design&#10;&#10;Il contenuto generato dall'IA potrebbe non essere corretto.">
+            <a:extLst>
+              <a:ext uri="{FF2B5EF4-FFF2-40B4-BE49-F238E27FC236}">
+                <a16:creationId xmlns:a16="http://schemas.microsoft.com/office/drawing/2014/main" id="{C21A3941-3879-616F-57A1-40E55E67E071}"/>
+              </a:ext>
+            </a:extLst>
+          </p:cNvPr>
+          <p:cNvPicPr>
+            <a:picLocks noChangeAspect="1"/>
+          </p:cNvPicPr>
+          <p:nvPr/>
+        </p:nvPicPr>
+        <p:blipFill>
+          <a:blip r:embed="rId2"/>
+          <a:stretch>
+            <a:fillRect/>
+          </a:stretch>
+        </p:blipFill>
+        <p:spPr>
+          <a:xfrm>
+            <a:off x="311700" y="1078110"/>
+            <a:ext cx="2128393" cy="1513524"/>
+          </a:xfrm>
+          <a:prstGeom prst="rect">
+            <a:avLst/>
+          </a:prstGeom>
+        </p:spPr>
+      </p:pic>
+      <p:pic>
+        <p:nvPicPr>
+          <p:cNvPr id="6" name="Immagine 5" descr="Immagine che contiene testo, schermata, cerchio, diagramma&#10;&#10;Il contenuto generato dall'IA potrebbe non essere corretto.">
+            <a:extLst>
+              <a:ext uri="{FF2B5EF4-FFF2-40B4-BE49-F238E27FC236}">
+                <a16:creationId xmlns:a16="http://schemas.microsoft.com/office/drawing/2014/main" id="{777AEA47-1166-EF02-2650-BCA802532B41}"/>
+              </a:ext>
+            </a:extLst>
+          </p:cNvPr>
+          <p:cNvPicPr>
+            <a:picLocks noChangeAspect="1"/>
+          </p:cNvPicPr>
+          <p:nvPr/>
+        </p:nvPicPr>
+        <p:blipFill>
+          <a:blip r:embed="rId3"/>
+          <a:stretch>
+            <a:fillRect/>
+          </a:stretch>
+        </p:blipFill>
+        <p:spPr>
+          <a:xfrm>
+            <a:off x="2592044" y="1089019"/>
+            <a:ext cx="2085090" cy="1482731"/>
+          </a:xfrm>
+          <a:prstGeom prst="rect">
+            <a:avLst/>
+          </a:prstGeom>
+        </p:spPr>
+      </p:pic>
+      <p:pic>
+        <p:nvPicPr>
+          <p:cNvPr id="8" name="Immagine 7" descr="Immagine che contiene schermata, testo, design, Elementi grafici&#10;&#10;Il contenuto generato dall'IA potrebbe non essere corretto.">
+            <a:extLst>
+              <a:ext uri="{FF2B5EF4-FFF2-40B4-BE49-F238E27FC236}">
+                <a16:creationId xmlns:a16="http://schemas.microsoft.com/office/drawing/2014/main" id="{8236F5C8-2173-2BCF-EAA8-427E84649554}"/>
+              </a:ext>
+            </a:extLst>
+          </p:cNvPr>
+          <p:cNvPicPr>
+            <a:picLocks noChangeAspect="1"/>
+          </p:cNvPicPr>
+          <p:nvPr/>
+        </p:nvPicPr>
+        <p:blipFill>
+          <a:blip r:embed="rId4"/>
+          <a:stretch>
+            <a:fillRect/>
+          </a:stretch>
+        </p:blipFill>
+        <p:spPr>
+          <a:xfrm>
+            <a:off x="4829085" y="1078110"/>
+            <a:ext cx="2128393" cy="1513524"/>
+          </a:xfrm>
+          <a:prstGeom prst="rect">
+            <a:avLst/>
+          </a:prstGeom>
+        </p:spPr>
+      </p:pic>
+      <p:pic>
+        <p:nvPicPr>
+          <p:cNvPr id="10" name="Immagine 9" descr="Immagine che contiene schermata, testo, cerchio, design&#10;&#10;Il contenuto generato dall'IA potrebbe non essere corretto.">
+            <a:extLst>
+              <a:ext uri="{FF2B5EF4-FFF2-40B4-BE49-F238E27FC236}">
+                <a16:creationId xmlns:a16="http://schemas.microsoft.com/office/drawing/2014/main" id="{C4AD75DE-06D1-537A-DB7A-87D75298689F}"/>
+              </a:ext>
+            </a:extLst>
+          </p:cNvPr>
+          <p:cNvPicPr>
+            <a:picLocks noChangeAspect="1"/>
+          </p:cNvPicPr>
+          <p:nvPr/>
+        </p:nvPicPr>
+        <p:blipFill>
+          <a:blip r:embed="rId5"/>
+          <a:stretch>
+            <a:fillRect/>
+          </a:stretch>
+        </p:blipFill>
+        <p:spPr>
+          <a:xfrm>
+            <a:off x="1748763" y="2838509"/>
+            <a:ext cx="2240972" cy="1593580"/>
+          </a:xfrm>
+          <a:prstGeom prst="rect">
+            <a:avLst/>
+          </a:prstGeom>
+        </p:spPr>
+      </p:pic>
+      <p:pic>
+        <p:nvPicPr>
+          <p:cNvPr id="12" name="Immagine 11" descr="Immagine che contiene testo, schermata, cerchio, diagramma&#10;&#10;Il contenuto generato dall'IA potrebbe non essere corretto.">
+            <a:extLst>
+              <a:ext uri="{FF2B5EF4-FFF2-40B4-BE49-F238E27FC236}">
+                <a16:creationId xmlns:a16="http://schemas.microsoft.com/office/drawing/2014/main" id="{AEAE007B-6A8C-99BD-7749-F1EBF1475769}"/>
+              </a:ext>
+            </a:extLst>
+          </p:cNvPr>
+          <p:cNvPicPr>
+            <a:picLocks noChangeAspect="1"/>
+          </p:cNvPicPr>
+          <p:nvPr/>
+        </p:nvPicPr>
+        <p:blipFill>
+          <a:blip r:embed="rId6"/>
+          <a:stretch>
+            <a:fillRect/>
+          </a:stretch>
+        </p:blipFill>
+        <p:spPr>
+          <a:xfrm>
+            <a:off x="6478749" y="2838509"/>
+            <a:ext cx="2240972" cy="1593580"/>
+          </a:xfrm>
+          <a:prstGeom prst="rect">
+            <a:avLst/>
+          </a:prstGeom>
+        </p:spPr>
+      </p:pic>
+      <p:pic>
+        <p:nvPicPr>
+          <p:cNvPr id="14" name="Immagine 13" descr="Immagine che contiene testo, schermata, cerchio, Carattere&#10;&#10;Il contenuto generato dall'IA potrebbe non essere corretto.">
+            <a:extLst>
+              <a:ext uri="{FF2B5EF4-FFF2-40B4-BE49-F238E27FC236}">
+                <a16:creationId xmlns:a16="http://schemas.microsoft.com/office/drawing/2014/main" id="{D95841B2-2456-E748-DEA3-96AA3DD12DD3}"/>
+              </a:ext>
+            </a:extLst>
+          </p:cNvPr>
+          <p:cNvPicPr>
+            <a:picLocks noChangeAspect="1"/>
+          </p:cNvPicPr>
+          <p:nvPr/>
+        </p:nvPicPr>
+        <p:blipFill>
+          <a:blip r:embed="rId7"/>
+          <a:stretch>
+            <a:fillRect/>
+          </a:stretch>
+        </p:blipFill>
+        <p:spPr>
+          <a:xfrm>
+            <a:off x="4113756" y="2838509"/>
+            <a:ext cx="2240972" cy="1593580"/>
+          </a:xfrm>
+          <a:prstGeom prst="rect">
+            <a:avLst/>
+          </a:prstGeom>
+        </p:spPr>
+      </p:pic>
+    </p:spTree>
+    <p:extLst>
+      <p:ext uri="{BB962C8B-B14F-4D97-AF65-F5344CB8AC3E}">
+        <p14:creationId xmlns:p14="http://schemas.microsoft.com/office/powerpoint/2010/main" val="4143030323"/>
+      </p:ext>
+    </p:extLst>
+  </p:cSld>
+  <p:clrMapOvr>
+    <a:masterClrMapping/>
+  </p:clrMapOvr>
+  <p:timing>
+    <p:tnLst>
+      <p:par>
+        <p:cTn id="1" dur="indefinite" restart="never" nodeType="tmRoot">
+          <p:childTnLst>
+            <p:seq concurrent="1" nextAc="seek">
+              <p:cTn id="2" dur="indefinite" nodeType="mainSeq">
+                <p:childTnLst>
+                  <p:par>
+                    <p:cTn id="3" fill="hold">
+                      <p:stCondLst>
+                        <p:cond delay="indefinite"/>
+                      </p:stCondLst>
+                      <p:childTnLst>
+                        <p:par>
+                          <p:cTn id="4" fill="hold">
+                            <p:stCondLst>
+                              <p:cond delay="0"/>
+                            </p:stCondLst>
+                            <p:childTnLst>
+                              <p:par>
+                                <p:cTn id="5" presetID="10" presetClass="entr" presetSubtype="0" fill="hold" nodeType="clickEffect">
+                                  <p:stCondLst>
+                                    <p:cond delay="0"/>
+                                  </p:stCondLst>
+                                  <p:childTnLst>
+                                    <p:set>
+                                      <p:cBhvr>
+                                        <p:cTn id="6" dur="1" fill="hold">
+                                          <p:stCondLst>
+                                            <p:cond delay="0"/>
+                                          </p:stCondLst>
+                                        </p:cTn>
+                                        <p:tgtEl>
+                                          <p:spTgt spid="4"/>
+                                        </p:tgtEl>
+                                        <p:attrNameLst>
+                                          <p:attrName>style.visibility</p:attrName>
+                                        </p:attrNameLst>
+                                      </p:cBhvr>
+                                      <p:to>
+                                        <p:strVal val="visible"/>
+                                      </p:to>
+                                    </p:set>
+                                    <p:animEffect transition="in" filter="fade">
+                                      <p:cBhvr>
+                                        <p:cTn id="7" dur="500"/>
+                                        <p:tgtEl>
+                                          <p:spTgt spid="4"/>
+                                        </p:tgtEl>
+                                      </p:cBhvr>
+                                    </p:animEffect>
+                                  </p:childTnLst>
+                                </p:cTn>
+                              </p:par>
+                              <p:par>
+                                <p:cTn id="8" presetID="10" presetClass="entr" presetSubtype="0" fill="hold" nodeType="withEffect">
+                                  <p:stCondLst>
+                                    <p:cond delay="0"/>
+                                  </p:stCondLst>
+                                  <p:childTnLst>
+                                    <p:set>
+                                      <p:cBhvr>
+                                        <p:cTn id="9" dur="1" fill="hold">
+                                          <p:stCondLst>
+                                            <p:cond delay="0"/>
+                                          </p:stCondLst>
+                                        </p:cTn>
+                                        <p:tgtEl>
+                                          <p:spTgt spid="6"/>
+                                        </p:tgtEl>
+                                        <p:attrNameLst>
+                                          <p:attrName>style.visibility</p:attrName>
+                                        </p:attrNameLst>
+                                      </p:cBhvr>
+                                      <p:to>
+                                        <p:strVal val="visible"/>
+                                      </p:to>
+                                    </p:set>
+                                    <p:animEffect transition="in" filter="fade">
+                                      <p:cBhvr>
+                                        <p:cTn id="10" dur="500"/>
+                                        <p:tgtEl>
+                                          <p:spTgt spid="6"/>
+                                        </p:tgtEl>
+                                      </p:cBhvr>
+                                    </p:animEffect>
+                                  </p:childTnLst>
+                                </p:cTn>
+                              </p:par>
+                              <p:par>
+                                <p:cTn id="11" presetID="10" presetClass="entr" presetSubtype="0" fill="hold" nodeType="withEffect">
+                                  <p:stCondLst>
+                                    <p:cond delay="0"/>
+                                  </p:stCondLst>
+                                  <p:childTnLst>
+                                    <p:set>
+                                      <p:cBhvr>
+                                        <p:cTn id="12" dur="1" fill="hold">
+                                          <p:stCondLst>
+                                            <p:cond delay="0"/>
+                                          </p:stCondLst>
+                                        </p:cTn>
+                                        <p:tgtEl>
+                                          <p:spTgt spid="8"/>
+                                        </p:tgtEl>
+                                        <p:attrNameLst>
+                                          <p:attrName>style.visibility</p:attrName>
+                                        </p:attrNameLst>
+                                      </p:cBhvr>
+                                      <p:to>
+                                        <p:strVal val="visible"/>
+                                      </p:to>
+                                    </p:set>
+                                    <p:animEffect transition="in" filter="fade">
+                                      <p:cBhvr>
+                                        <p:cTn id="13" dur="500"/>
+                                        <p:tgtEl>
+                                          <p:spTgt spid="8"/>
+                                        </p:tgtEl>
+                                      </p:cBhvr>
+                                    </p:animEffect>
+                                  </p:childTnLst>
+                                </p:cTn>
+                              </p:par>
+                            </p:childTnLst>
+                          </p:cTn>
+                        </p:par>
+                      </p:childTnLst>
+                    </p:cTn>
+                  </p:par>
+                  <p:par>
+                    <p:cTn id="14" fill="hold">
+                      <p:stCondLst>
+                        <p:cond delay="indefinite"/>
+                      </p:stCondLst>
+                      <p:childTnLst>
+                        <p:par>
+                          <p:cTn id="15" fill="hold">
+                            <p:stCondLst>
+                              <p:cond delay="0"/>
+                            </p:stCondLst>
+                            <p:childTnLst>
+                              <p:par>
+                                <p:cTn id="16" presetID="10" presetClass="entr" presetSubtype="0" fill="hold" nodeType="clickEffect">
+                                  <p:stCondLst>
+                                    <p:cond delay="0"/>
+                                  </p:stCondLst>
+                                  <p:childTnLst>
+                                    <p:set>
+                                      <p:cBhvr>
+                                        <p:cTn id="17" dur="1" fill="hold">
+                                          <p:stCondLst>
+                                            <p:cond delay="0"/>
+                                          </p:stCondLst>
+                                        </p:cTn>
+                                        <p:tgtEl>
+                                          <p:spTgt spid="10"/>
+                                        </p:tgtEl>
+                                        <p:attrNameLst>
+                                          <p:attrName>style.visibility</p:attrName>
+                                        </p:attrNameLst>
+                                      </p:cBhvr>
+                                      <p:to>
+                                        <p:strVal val="visible"/>
+                                      </p:to>
+                                    </p:set>
+                                    <p:animEffect transition="in" filter="fade">
+                                      <p:cBhvr>
+                                        <p:cTn id="18" dur="500"/>
+                                        <p:tgtEl>
+                                          <p:spTgt spid="10"/>
+                                        </p:tgtEl>
+                                      </p:cBhvr>
+                                    </p:animEffect>
+                                  </p:childTnLst>
+                                </p:cTn>
+                              </p:par>
+                              <p:par>
+                                <p:cTn id="19" presetID="10" presetClass="entr" presetSubtype="0" fill="hold" nodeType="withEffect">
+                                  <p:stCondLst>
+                                    <p:cond delay="0"/>
+                                  </p:stCondLst>
+                                  <p:childTnLst>
+                                    <p:set>
+                                      <p:cBhvr>
+                                        <p:cTn id="20" dur="1" fill="hold">
+                                          <p:stCondLst>
+                                            <p:cond delay="0"/>
+                                          </p:stCondLst>
+                                        </p:cTn>
+                                        <p:tgtEl>
+                                          <p:spTgt spid="14"/>
+                                        </p:tgtEl>
+                                        <p:attrNameLst>
+                                          <p:attrName>style.visibility</p:attrName>
+                                        </p:attrNameLst>
+                                      </p:cBhvr>
+                                      <p:to>
+                                        <p:strVal val="visible"/>
+                                      </p:to>
+                                    </p:set>
+                                    <p:animEffect transition="in" filter="fade">
+                                      <p:cBhvr>
+                                        <p:cTn id="21" dur="500"/>
+                                        <p:tgtEl>
+                                          <p:spTgt spid="14"/>
+                                        </p:tgtEl>
+                                      </p:cBhvr>
+                                    </p:animEffect>
+                                  </p:childTnLst>
+                                </p:cTn>
+                              </p:par>
+                              <p:par>
+                                <p:cTn id="22" presetID="10" presetClass="entr" presetSubtype="0" fill="hold" nodeType="withEffect">
+                                  <p:stCondLst>
+                                    <p:cond delay="0"/>
+                                  </p:stCondLst>
+                                  <p:childTnLst>
+                                    <p:set>
+                                      <p:cBhvr>
+                                        <p:cTn id="23" dur="1" fill="hold">
+                                          <p:stCondLst>
+                                            <p:cond delay="0"/>
+                                          </p:stCondLst>
+                                        </p:cTn>
+                                        <p:tgtEl>
+                                          <p:spTgt spid="12"/>
+                                        </p:tgtEl>
+                                        <p:attrNameLst>
+                                          <p:attrName>style.visibility</p:attrName>
+                                        </p:attrNameLst>
+                                      </p:cBhvr>
+                                      <p:to>
+                                        <p:strVal val="visible"/>
+                                      </p:to>
+                                    </p:set>
+                                    <p:animEffect transition="in" filter="fade">
+                                      <p:cBhvr>
+                                        <p:cTn id="24" dur="500"/>
+                                        <p:tgtEl>
+                                          <p:spTgt spid="12"/>
+                                        </p:tgtEl>
+                                      </p:cBhvr>
+                                    </p:animEffect>
+                                  </p:childTnLst>
+                                </p:cTn>
+                              </p:par>
+                            </p:childTnLst>
+                          </p:cTn>
+                        </p:par>
+                      </p:childTnLst>
+                    </p:cTn>
+                  </p:par>
+                </p:childTnLst>
+              </p:cTn>
+              <p:prevCondLst>
+                <p:cond evt="onPrev" delay="0">
+                  <p:tgtEl>
+                    <p:sldTgt/>
+                  </p:tgtEl>
+                </p:cond>
+              </p:prevCondLst>
+              <p:nextCondLst>
+                <p:cond evt="onNext" delay="0">
+                  <p:tgtEl>
+                    <p:sldTgt/>
+                  </p:tgtEl>
+                </p:cond>
+              </p:nextCondLst>
+            </p:seq>
+          </p:childTnLst>
+        </p:cTn>
+      </p:par>
+    </p:tnLst>
+  </p:timing>
+</p:sld>
+</file>
+
+<file path=ppt/slides/slide12.xml><?xml version="1.0" encoding="utf-8"?>
+<p:sld xmlns:a="http://schemas.openxmlformats.org/drawingml/2006/main" xmlns:r="http://schemas.openxmlformats.org/officeDocument/2006/relationships" xmlns:p="http://schemas.openxmlformats.org/presentationml/2006/main">
+  <p:cSld>
+    <p:spTree>
+      <p:nvGrpSpPr>
+        <p:cNvPr id="1" name=""/>
+        <p:cNvGrpSpPr/>
+        <p:nvPr/>
+      </p:nvGrpSpPr>
+      <p:grpSpPr>
+        <a:xfrm>
+          <a:off x="0" y="0"/>
+          <a:ext cx="0" cy="0"/>
+          <a:chOff x="0" y="0"/>
+          <a:chExt cx="0" cy="0"/>
+        </a:xfrm>
+      </p:grpSpPr>
+      <p:sp>
+        <p:nvSpPr>
+          <p:cNvPr id="2" name="Titolo 1">
+            <a:extLst>
+              <a:ext uri="{FF2B5EF4-FFF2-40B4-BE49-F238E27FC236}">
                 <a16:creationId xmlns:a16="http://schemas.microsoft.com/office/drawing/2014/main" id="{A05A74FC-2392-6C82-B228-D989AD37A21C}"/>
               </a:ext>
             </a:extLst>
@@ -7603,7 +8123,7 @@
 </p:sld>
 </file>
 
-<file path=ppt/slides/slide12.xml><?xml version="1.0" encoding="utf-8"?>
+<file path=ppt/slides/slide13.xml><?xml version="1.0" encoding="utf-8"?>
 <p:sld xmlns:a="http://schemas.openxmlformats.org/drawingml/2006/main" xmlns:r="http://schemas.openxmlformats.org/officeDocument/2006/relationships" xmlns:p="http://schemas.openxmlformats.org/presentationml/2006/main">
   <p:cSld>
     <p:spTree>
@@ -7727,7 +8247,7 @@
 </p:sld>
 </file>
 
-<file path=ppt/slides/slide13.xml><?xml version="1.0" encoding="utf-8"?>
+<file path=ppt/slides/slide14.xml><?xml version="1.0" encoding="utf-8"?>
 <p:sld xmlns:a="http://schemas.openxmlformats.org/drawingml/2006/main" xmlns:r="http://schemas.openxmlformats.org/officeDocument/2006/relationships" xmlns:p="http://schemas.openxmlformats.org/presentationml/2006/main">
   <p:cSld>
     <p:spTree>
@@ -8096,7 +8616,7 @@
 </p:sld>
 </file>
 
-<file path=ppt/slides/slide14.xml><?xml version="1.0" encoding="utf-8"?>
+<file path=ppt/slides/slide15.xml><?xml version="1.0" encoding="utf-8"?>
 <p:sld xmlns:a="http://schemas.openxmlformats.org/drawingml/2006/main" xmlns:r="http://schemas.openxmlformats.org/officeDocument/2006/relationships" xmlns:p="http://schemas.openxmlformats.org/presentationml/2006/main">
   <p:cSld>
     <p:spTree>
@@ -8338,7 +8858,7 @@
 </p:sld>
 </file>
 
-<file path=ppt/slides/slide15.xml><?xml version="1.0" encoding="utf-8"?>
+<file path=ppt/slides/slide16.xml><?xml version="1.0" encoding="utf-8"?>
 <p:sld xmlns:a="http://schemas.openxmlformats.org/drawingml/2006/main" xmlns:r="http://schemas.openxmlformats.org/officeDocument/2006/relationships" xmlns:p="http://schemas.openxmlformats.org/presentationml/2006/main">
   <p:cSld>
     <p:spTree>
@@ -8715,7 +9235,7 @@
 </p:sld>
 </file>
 
-<file path=ppt/slides/slide16.xml><?xml version="1.0" encoding="utf-8"?>
+<file path=ppt/slides/slide17.xml><?xml version="1.0" encoding="utf-8"?>
 <p:sld xmlns:a="http://schemas.openxmlformats.org/drawingml/2006/main" xmlns:r="http://schemas.openxmlformats.org/officeDocument/2006/relationships" xmlns:p="http://schemas.openxmlformats.org/presentationml/2006/main">
   <p:cSld>
     <p:spTree>
@@ -9159,7 +9679,7 @@
 </p:sld>
 </file>
 
-<file path=ppt/slides/slide17.xml><?xml version="1.0" encoding="utf-8"?>
+<file path=ppt/slides/slide18.xml><?xml version="1.0" encoding="utf-8"?>
 <p:sld xmlns:a="http://schemas.openxmlformats.org/drawingml/2006/main" xmlns:r="http://schemas.openxmlformats.org/officeDocument/2006/relationships" xmlns:p="http://schemas.openxmlformats.org/presentationml/2006/main">
   <p:cSld>
     <p:spTree>
@@ -9383,7 +9903,7 @@
 </p:sld>
 </file>
 
-<file path=ppt/slides/slide18.xml><?xml version="1.0" encoding="utf-8"?>
+<file path=ppt/slides/slide19.xml><?xml version="1.0" encoding="utf-8"?>
 <p:sld xmlns:a="http://schemas.openxmlformats.org/drawingml/2006/main" xmlns:r="http://schemas.openxmlformats.org/officeDocument/2006/relationships" xmlns:p="http://schemas.openxmlformats.org/presentationml/2006/main">
   <p:cSld>
     <p:spTree>
@@ -9607,7 +10127,74 @@
 </p:sld>
 </file>
 
-<file path=ppt/slides/slide19.xml><?xml version="1.0" encoding="utf-8"?>
+<file path=ppt/slides/slide2.xml><?xml version="1.0" encoding="utf-8"?>
+<p:sld xmlns:a="http://schemas.openxmlformats.org/drawingml/2006/main" xmlns:r="http://schemas.openxmlformats.org/officeDocument/2006/relationships" xmlns:p="http://schemas.openxmlformats.org/presentationml/2006/main">
+  <p:cSld>
+    <p:spTree>
+      <p:nvGrpSpPr>
+        <p:cNvPr id="1" name="Shape 64"/>
+        <p:cNvGrpSpPr/>
+        <p:nvPr/>
+      </p:nvGrpSpPr>
+      <p:grpSpPr>
+        <a:xfrm>
+          <a:off x="0" y="0"/>
+          <a:ext cx="0" cy="0"/>
+          <a:chOff x="0" y="0"/>
+          <a:chExt cx="0" cy="0"/>
+        </a:xfrm>
+      </p:grpSpPr>
+      <p:sp>
+        <p:nvSpPr>
+          <p:cNvPr id="65" name="Google Shape;65;p14"/>
+          <p:cNvSpPr txBox="1">
+            <a:spLocks noGrp="1"/>
+          </p:cNvSpPr>
+          <p:nvPr>
+            <p:ph type="title"/>
+          </p:nvPr>
+        </p:nvSpPr>
+        <p:spPr>
+          <a:xfrm>
+            <a:off x="490250" y="526350"/>
+            <a:ext cx="5604000" cy="4090800"/>
+          </a:xfrm>
+          <a:prstGeom prst="rect">
+            <a:avLst/>
+          </a:prstGeom>
+        </p:spPr>
+        <p:txBody>
+          <a:bodyPr spcFirstLastPara="1" wrap="square" lIns="91425" tIns="91425" rIns="91425" bIns="91425" anchor="ctr" anchorCtr="0">
+            <a:noAutofit/>
+          </a:bodyPr>
+          <a:lstStyle/>
+          <a:p>
+            <a:pPr marL="0" lvl="0" indent="0" algn="l" rtl="0">
+              <a:spcBef>
+                <a:spcPts val="0"/>
+              </a:spcBef>
+              <a:spcAft>
+                <a:spcPts val="0"/>
+              </a:spcAft>
+              <a:buNone/>
+            </a:pPr>
+            <a:r>
+              <a:rPr lang="it"/>
+              <a:t>Il progetto</a:t>
+            </a:r>
+            <a:endParaRPr/>
+          </a:p>
+        </p:txBody>
+      </p:sp>
+    </p:spTree>
+  </p:cSld>
+  <p:clrMapOvr>
+    <a:masterClrMapping/>
+  </p:clrMapOvr>
+</p:sld>
+</file>
+
+<file path=ppt/slides/slide20.xml><?xml version="1.0" encoding="utf-8"?>
 <p:sld xmlns:a="http://schemas.openxmlformats.org/drawingml/2006/main" xmlns:r="http://schemas.openxmlformats.org/officeDocument/2006/relationships" xmlns:p="http://schemas.openxmlformats.org/presentationml/2006/main">
   <p:cSld>
     <p:spTree>
@@ -9831,74 +10418,7 @@
 </p:sld>
 </file>
 
-<file path=ppt/slides/slide2.xml><?xml version="1.0" encoding="utf-8"?>
-<p:sld xmlns:a="http://schemas.openxmlformats.org/drawingml/2006/main" xmlns:r="http://schemas.openxmlformats.org/officeDocument/2006/relationships" xmlns:p="http://schemas.openxmlformats.org/presentationml/2006/main">
-  <p:cSld>
-    <p:spTree>
-      <p:nvGrpSpPr>
-        <p:cNvPr id="1" name="Shape 64"/>
-        <p:cNvGrpSpPr/>
-        <p:nvPr/>
-      </p:nvGrpSpPr>
-      <p:grpSpPr>
-        <a:xfrm>
-          <a:off x="0" y="0"/>
-          <a:ext cx="0" cy="0"/>
-          <a:chOff x="0" y="0"/>
-          <a:chExt cx="0" cy="0"/>
-        </a:xfrm>
-      </p:grpSpPr>
-      <p:sp>
-        <p:nvSpPr>
-          <p:cNvPr id="65" name="Google Shape;65;p14"/>
-          <p:cNvSpPr txBox="1">
-            <a:spLocks noGrp="1"/>
-          </p:cNvSpPr>
-          <p:nvPr>
-            <p:ph type="title"/>
-          </p:nvPr>
-        </p:nvSpPr>
-        <p:spPr>
-          <a:xfrm>
-            <a:off x="490250" y="526350"/>
-            <a:ext cx="5604000" cy="4090800"/>
-          </a:xfrm>
-          <a:prstGeom prst="rect">
-            <a:avLst/>
-          </a:prstGeom>
-        </p:spPr>
-        <p:txBody>
-          <a:bodyPr spcFirstLastPara="1" wrap="square" lIns="91425" tIns="91425" rIns="91425" bIns="91425" anchor="ctr" anchorCtr="0">
-            <a:noAutofit/>
-          </a:bodyPr>
-          <a:lstStyle/>
-          <a:p>
-            <a:pPr marL="0" lvl="0" indent="0" algn="l" rtl="0">
-              <a:spcBef>
-                <a:spcPts val="0"/>
-              </a:spcBef>
-              <a:spcAft>
-                <a:spcPts val="0"/>
-              </a:spcAft>
-              <a:buNone/>
-            </a:pPr>
-            <a:r>
-              <a:rPr lang="it"/>
-              <a:t>Il progetto</a:t>
-            </a:r>
-            <a:endParaRPr/>
-          </a:p>
-        </p:txBody>
-      </p:sp>
-    </p:spTree>
-  </p:cSld>
-  <p:clrMapOvr>
-    <a:masterClrMapping/>
-  </p:clrMapOvr>
-</p:sld>
-</file>
-
-<file path=ppt/slides/slide20.xml><?xml version="1.0" encoding="utf-8"?>
+<file path=ppt/slides/slide21.xml><?xml version="1.0" encoding="utf-8"?>
 <p:sld xmlns:a="http://schemas.openxmlformats.org/drawingml/2006/main" xmlns:r="http://schemas.openxmlformats.org/officeDocument/2006/relationships" xmlns:p="http://schemas.openxmlformats.org/presentationml/2006/main">
   <p:cSld>
     <p:spTree>
@@ -10122,7 +10642,7 @@
 </p:sld>
 </file>
 
-<file path=ppt/slides/slide21.xml><?xml version="1.0" encoding="utf-8"?>
+<file path=ppt/slides/slide22.xml><?xml version="1.0" encoding="utf-8"?>
 <p:sld xmlns:a="http://schemas.openxmlformats.org/drawingml/2006/main" xmlns:r="http://schemas.openxmlformats.org/officeDocument/2006/relationships" xmlns:p="http://schemas.openxmlformats.org/presentationml/2006/main">
   <p:cSld>
     <p:spTree>

</xml_diff>

<commit_message>
Aggiunto struttura db a pp
</commit_message>
<xml_diff>
--- a/Documenti/Relazione Finale/PP relazione.pptx
+++ b/Documenti/Relazione Finale/PP relazione.pptx
@@ -5,7 +5,7 @@
     <p:sldMasterId id="2147483659" r:id="rId1"/>
   </p:sldMasterIdLst>
   <p:notesMasterIdLst>
-    <p:notesMasterId r:id="rId24"/>
+    <p:notesMasterId r:id="rId25"/>
   </p:notesMasterIdLst>
   <p:sldIdLst>
     <p:sldId id="256" r:id="rId2"/>
@@ -19,33 +19,34 @@
     <p:sldId id="265" r:id="rId10"/>
     <p:sldId id="260" r:id="rId11"/>
     <p:sldId id="279" r:id="rId12"/>
-    <p:sldId id="267" r:id="rId13"/>
-    <p:sldId id="269" r:id="rId14"/>
-    <p:sldId id="270" r:id="rId15"/>
-    <p:sldId id="271" r:id="rId16"/>
-    <p:sldId id="272" r:id="rId17"/>
-    <p:sldId id="273" r:id="rId18"/>
-    <p:sldId id="274" r:id="rId19"/>
-    <p:sldId id="275" r:id="rId20"/>
-    <p:sldId id="277" r:id="rId21"/>
-    <p:sldId id="278" r:id="rId22"/>
-    <p:sldId id="276" r:id="rId23"/>
+    <p:sldId id="280" r:id="rId13"/>
+    <p:sldId id="267" r:id="rId14"/>
+    <p:sldId id="269" r:id="rId15"/>
+    <p:sldId id="270" r:id="rId16"/>
+    <p:sldId id="271" r:id="rId17"/>
+    <p:sldId id="272" r:id="rId18"/>
+    <p:sldId id="273" r:id="rId19"/>
+    <p:sldId id="274" r:id="rId20"/>
+    <p:sldId id="275" r:id="rId21"/>
+    <p:sldId id="277" r:id="rId22"/>
+    <p:sldId id="278" r:id="rId23"/>
+    <p:sldId id="276" r:id="rId24"/>
   </p:sldIdLst>
   <p:sldSz cx="9144000" cy="5143500" type="screen16x9"/>
   <p:notesSz cx="6858000" cy="9144000"/>
   <p:embeddedFontLst>
     <p:embeddedFont>
       <p:font typeface="Amasis MT Pro" panose="02040504050005020304" pitchFamily="18" charset="0"/>
-      <p:regular r:id="rId25"/>
-      <p:bold r:id="rId26"/>
-      <p:italic r:id="rId27"/>
-      <p:boldItalic r:id="rId28"/>
+      <p:regular r:id="rId26"/>
+      <p:bold r:id="rId27"/>
+      <p:italic r:id="rId28"/>
+      <p:boldItalic r:id="rId29"/>
     </p:embeddedFont>
     <p:embeddedFont>
       <p:font typeface="Old Standard TT" panose="020B0604020202020204" charset="0"/>
-      <p:regular r:id="rId29"/>
-      <p:bold r:id="rId30"/>
-      <p:italic r:id="rId31"/>
+      <p:regular r:id="rId30"/>
+      <p:bold r:id="rId31"/>
+      <p:italic r:id="rId32"/>
     </p:embeddedFont>
   </p:embeddedFontLst>
   <p:defaultTextStyle>
@@ -7981,6 +7982,466 @@
           <p:cNvPr id="2" name="Titolo 1">
             <a:extLst>
               <a:ext uri="{FF2B5EF4-FFF2-40B4-BE49-F238E27FC236}">
+                <a16:creationId xmlns:a16="http://schemas.microsoft.com/office/drawing/2014/main" id="{E37A1EEA-6AF2-7B2F-FC04-0640DADB58C3}"/>
+              </a:ext>
+            </a:extLst>
+          </p:cNvPr>
+          <p:cNvSpPr>
+            <a:spLocks noGrp="1"/>
+          </p:cNvSpPr>
+          <p:nvPr>
+            <p:ph type="title"/>
+          </p:nvPr>
+        </p:nvSpPr>
+        <p:spPr/>
+        <p:txBody>
+          <a:bodyPr/>
+          <a:lstStyle/>
+          <a:p>
+            <a:pPr algn="ctr"/>
+            <a:r>
+              <a:rPr lang="it-IT" dirty="0"/>
+              <a:t>Struttura </a:t>
+            </a:r>
+            <a:r>
+              <a:rPr lang="it-IT" dirty="0" err="1"/>
+              <a:t>DataBase</a:t>
+            </a:r>
+            <a:r>
+              <a:rPr lang="it-IT" dirty="0"/>
+              <a:t> SQL</a:t>
+            </a:r>
+          </a:p>
+        </p:txBody>
+      </p:sp>
+      <p:pic>
+        <p:nvPicPr>
+          <p:cNvPr id="4" name="Immagine 3" descr="Immagine che contiene testo, schermata, Carattere, linea&#10;&#10;Il contenuto generato dall'IA potrebbe non essere corretto.">
+            <a:extLst>
+              <a:ext uri="{FF2B5EF4-FFF2-40B4-BE49-F238E27FC236}">
+                <a16:creationId xmlns:a16="http://schemas.microsoft.com/office/drawing/2014/main" id="{3A88FB4C-CC61-BC27-1DBC-EBF02223BC0C}"/>
+              </a:ext>
+            </a:extLst>
+          </p:cNvPr>
+          <p:cNvPicPr>
+            <a:picLocks noChangeAspect="1"/>
+          </p:cNvPicPr>
+          <p:nvPr/>
+        </p:nvPicPr>
+        <p:blipFill>
+          <a:blip r:embed="rId2"/>
+          <a:stretch>
+            <a:fillRect/>
+          </a:stretch>
+        </p:blipFill>
+        <p:spPr>
+          <a:xfrm>
+            <a:off x="2450475" y="997820"/>
+            <a:ext cx="4243048" cy="1367388"/>
+          </a:xfrm>
+          <a:prstGeom prst="rect">
+            <a:avLst/>
+          </a:prstGeom>
+        </p:spPr>
+      </p:pic>
+      <p:pic>
+        <p:nvPicPr>
+          <p:cNvPr id="6" name="Immagine 5" descr="Immagine che contiene testo, schermata, Carattere, linea&#10;&#10;Il contenuto generato dall'IA potrebbe non essere corretto.">
+            <a:extLst>
+              <a:ext uri="{FF2B5EF4-FFF2-40B4-BE49-F238E27FC236}">
+                <a16:creationId xmlns:a16="http://schemas.microsoft.com/office/drawing/2014/main" id="{A31ABDCE-E2A6-EA34-D785-76A91AE119E6}"/>
+              </a:ext>
+            </a:extLst>
+          </p:cNvPr>
+          <p:cNvPicPr>
+            <a:picLocks noChangeAspect="1"/>
+          </p:cNvPicPr>
+          <p:nvPr/>
+        </p:nvPicPr>
+        <p:blipFill>
+          <a:blip r:embed="rId3"/>
+          <a:stretch>
+            <a:fillRect/>
+          </a:stretch>
+        </p:blipFill>
+        <p:spPr>
+          <a:xfrm>
+            <a:off x="2805621" y="2363907"/>
+            <a:ext cx="3289018" cy="1292661"/>
+          </a:xfrm>
+          <a:prstGeom prst="rect">
+            <a:avLst/>
+          </a:prstGeom>
+        </p:spPr>
+      </p:pic>
+      <p:pic>
+        <p:nvPicPr>
+          <p:cNvPr id="8" name="Immagine 7" descr="Immagine che contiene testo, schermata, Carattere, numero&#10;&#10;Il contenuto generato dall'IA potrebbe non essere corretto.">
+            <a:extLst>
+              <a:ext uri="{FF2B5EF4-FFF2-40B4-BE49-F238E27FC236}">
+                <a16:creationId xmlns:a16="http://schemas.microsoft.com/office/drawing/2014/main" id="{E420661F-4F64-BDA6-6746-3E208A6A7A0B}"/>
+              </a:ext>
+            </a:extLst>
+          </p:cNvPr>
+          <p:cNvPicPr>
+            <a:picLocks noChangeAspect="1"/>
+          </p:cNvPicPr>
+          <p:nvPr/>
+        </p:nvPicPr>
+        <p:blipFill>
+          <a:blip r:embed="rId4"/>
+          <a:stretch>
+            <a:fillRect/>
+          </a:stretch>
+        </p:blipFill>
+        <p:spPr>
+          <a:xfrm>
+            <a:off x="3001506" y="3656568"/>
+            <a:ext cx="2897247" cy="1401459"/>
+          </a:xfrm>
+          <a:prstGeom prst="rect">
+            <a:avLst/>
+          </a:prstGeom>
+        </p:spPr>
+      </p:pic>
+    </p:spTree>
+    <p:extLst>
+      <p:ext uri="{BB962C8B-B14F-4D97-AF65-F5344CB8AC3E}">
+        <p14:creationId xmlns:p14="http://schemas.microsoft.com/office/powerpoint/2010/main" val="622900377"/>
+      </p:ext>
+    </p:extLst>
+  </p:cSld>
+  <p:clrMapOvr>
+    <a:masterClrMapping/>
+  </p:clrMapOvr>
+  <p:timing>
+    <p:tnLst>
+      <p:par>
+        <p:cTn id="1" dur="indefinite" restart="never" nodeType="tmRoot">
+          <p:childTnLst>
+            <p:seq concurrent="1" nextAc="seek">
+              <p:cTn id="2" dur="indefinite" nodeType="mainSeq">
+                <p:childTnLst>
+                  <p:par>
+                    <p:cTn id="3" fill="hold">
+                      <p:stCondLst>
+                        <p:cond delay="indefinite"/>
+                      </p:stCondLst>
+                      <p:childTnLst>
+                        <p:par>
+                          <p:cTn id="4" fill="hold">
+                            <p:stCondLst>
+                              <p:cond delay="0"/>
+                            </p:stCondLst>
+                            <p:childTnLst>
+                              <p:par>
+                                <p:cTn id="5" presetID="2" presetClass="entr" presetSubtype="4" fill="hold" nodeType="clickEffect">
+                                  <p:stCondLst>
+                                    <p:cond delay="0"/>
+                                  </p:stCondLst>
+                                  <p:childTnLst>
+                                    <p:set>
+                                      <p:cBhvr>
+                                        <p:cTn id="6" dur="1" fill="hold">
+                                          <p:stCondLst>
+                                            <p:cond delay="0"/>
+                                          </p:stCondLst>
+                                        </p:cTn>
+                                        <p:tgtEl>
+                                          <p:spTgt spid="4"/>
+                                        </p:tgtEl>
+                                        <p:attrNameLst>
+                                          <p:attrName>style.visibility</p:attrName>
+                                        </p:attrNameLst>
+                                      </p:cBhvr>
+                                      <p:to>
+                                        <p:strVal val="visible"/>
+                                      </p:to>
+                                    </p:set>
+                                    <p:anim calcmode="lin" valueType="num">
+                                      <p:cBhvr additive="base">
+                                        <p:cTn id="7" dur="500" fill="hold"/>
+                                        <p:tgtEl>
+                                          <p:spTgt spid="4"/>
+                                        </p:tgtEl>
+                                        <p:attrNameLst>
+                                          <p:attrName>ppt_x</p:attrName>
+                                        </p:attrNameLst>
+                                      </p:cBhvr>
+                                      <p:tavLst>
+                                        <p:tav tm="0">
+                                          <p:val>
+                                            <p:strVal val="#ppt_x"/>
+                                          </p:val>
+                                        </p:tav>
+                                        <p:tav tm="100000">
+                                          <p:val>
+                                            <p:strVal val="#ppt_x"/>
+                                          </p:val>
+                                        </p:tav>
+                                      </p:tavLst>
+                                    </p:anim>
+                                    <p:anim calcmode="lin" valueType="num">
+                                      <p:cBhvr additive="base">
+                                        <p:cTn id="8" dur="500" fill="hold"/>
+                                        <p:tgtEl>
+                                          <p:spTgt spid="4"/>
+                                        </p:tgtEl>
+                                        <p:attrNameLst>
+                                          <p:attrName>ppt_y</p:attrName>
+                                        </p:attrNameLst>
+                                      </p:cBhvr>
+                                      <p:tavLst>
+                                        <p:tav tm="0">
+                                          <p:val>
+                                            <p:strVal val="1+#ppt_h/2"/>
+                                          </p:val>
+                                        </p:tav>
+                                        <p:tav tm="100000">
+                                          <p:val>
+                                            <p:strVal val="#ppt_y"/>
+                                          </p:val>
+                                        </p:tav>
+                                      </p:tavLst>
+                                    </p:anim>
+                                  </p:childTnLst>
+                                </p:cTn>
+                              </p:par>
+                            </p:childTnLst>
+                          </p:cTn>
+                        </p:par>
+                      </p:childTnLst>
+                    </p:cTn>
+                  </p:par>
+                  <p:par>
+                    <p:cTn id="9" fill="hold">
+                      <p:stCondLst>
+                        <p:cond delay="indefinite"/>
+                      </p:stCondLst>
+                      <p:childTnLst>
+                        <p:par>
+                          <p:cTn id="10" fill="hold">
+                            <p:stCondLst>
+                              <p:cond delay="0"/>
+                            </p:stCondLst>
+                            <p:childTnLst>
+                              <p:par>
+                                <p:cTn id="11" presetID="2" presetClass="entr" presetSubtype="4" fill="hold" nodeType="clickEffect">
+                                  <p:stCondLst>
+                                    <p:cond delay="0"/>
+                                  </p:stCondLst>
+                                  <p:childTnLst>
+                                    <p:set>
+                                      <p:cBhvr>
+                                        <p:cTn id="12" dur="1" fill="hold">
+                                          <p:stCondLst>
+                                            <p:cond delay="0"/>
+                                          </p:stCondLst>
+                                        </p:cTn>
+                                        <p:tgtEl>
+                                          <p:spTgt spid="6"/>
+                                        </p:tgtEl>
+                                        <p:attrNameLst>
+                                          <p:attrName>style.visibility</p:attrName>
+                                        </p:attrNameLst>
+                                      </p:cBhvr>
+                                      <p:to>
+                                        <p:strVal val="visible"/>
+                                      </p:to>
+                                    </p:set>
+                                    <p:anim calcmode="lin" valueType="num">
+                                      <p:cBhvr additive="base">
+                                        <p:cTn id="13" dur="500" fill="hold"/>
+                                        <p:tgtEl>
+                                          <p:spTgt spid="6"/>
+                                        </p:tgtEl>
+                                        <p:attrNameLst>
+                                          <p:attrName>ppt_x</p:attrName>
+                                        </p:attrNameLst>
+                                      </p:cBhvr>
+                                      <p:tavLst>
+                                        <p:tav tm="0">
+                                          <p:val>
+                                            <p:strVal val="#ppt_x"/>
+                                          </p:val>
+                                        </p:tav>
+                                        <p:tav tm="100000">
+                                          <p:val>
+                                            <p:strVal val="#ppt_x"/>
+                                          </p:val>
+                                        </p:tav>
+                                      </p:tavLst>
+                                    </p:anim>
+                                    <p:anim calcmode="lin" valueType="num">
+                                      <p:cBhvr additive="base">
+                                        <p:cTn id="14" dur="500" fill="hold"/>
+                                        <p:tgtEl>
+                                          <p:spTgt spid="6"/>
+                                        </p:tgtEl>
+                                        <p:attrNameLst>
+                                          <p:attrName>ppt_y</p:attrName>
+                                        </p:attrNameLst>
+                                      </p:cBhvr>
+                                      <p:tavLst>
+                                        <p:tav tm="0">
+                                          <p:val>
+                                            <p:strVal val="1+#ppt_h/2"/>
+                                          </p:val>
+                                        </p:tav>
+                                        <p:tav tm="100000">
+                                          <p:val>
+                                            <p:strVal val="#ppt_y"/>
+                                          </p:val>
+                                        </p:tav>
+                                      </p:tavLst>
+                                    </p:anim>
+                                  </p:childTnLst>
+                                </p:cTn>
+                              </p:par>
+                            </p:childTnLst>
+                          </p:cTn>
+                        </p:par>
+                      </p:childTnLst>
+                    </p:cTn>
+                  </p:par>
+                  <p:par>
+                    <p:cTn id="15" fill="hold">
+                      <p:stCondLst>
+                        <p:cond delay="indefinite"/>
+                      </p:stCondLst>
+                      <p:childTnLst>
+                        <p:par>
+                          <p:cTn id="16" fill="hold">
+                            <p:stCondLst>
+                              <p:cond delay="0"/>
+                            </p:stCondLst>
+                            <p:childTnLst>
+                              <p:par>
+                                <p:cTn id="17" presetID="2" presetClass="entr" presetSubtype="4" fill="hold" nodeType="clickEffect">
+                                  <p:stCondLst>
+                                    <p:cond delay="0"/>
+                                  </p:stCondLst>
+                                  <p:childTnLst>
+                                    <p:set>
+                                      <p:cBhvr>
+                                        <p:cTn id="18" dur="1" fill="hold">
+                                          <p:stCondLst>
+                                            <p:cond delay="0"/>
+                                          </p:stCondLst>
+                                        </p:cTn>
+                                        <p:tgtEl>
+                                          <p:spTgt spid="8"/>
+                                        </p:tgtEl>
+                                        <p:attrNameLst>
+                                          <p:attrName>style.visibility</p:attrName>
+                                        </p:attrNameLst>
+                                      </p:cBhvr>
+                                      <p:to>
+                                        <p:strVal val="visible"/>
+                                      </p:to>
+                                    </p:set>
+                                    <p:anim calcmode="lin" valueType="num">
+                                      <p:cBhvr additive="base">
+                                        <p:cTn id="19" dur="500" fill="hold"/>
+                                        <p:tgtEl>
+                                          <p:spTgt spid="8"/>
+                                        </p:tgtEl>
+                                        <p:attrNameLst>
+                                          <p:attrName>ppt_x</p:attrName>
+                                        </p:attrNameLst>
+                                      </p:cBhvr>
+                                      <p:tavLst>
+                                        <p:tav tm="0">
+                                          <p:val>
+                                            <p:strVal val="#ppt_x"/>
+                                          </p:val>
+                                        </p:tav>
+                                        <p:tav tm="100000">
+                                          <p:val>
+                                            <p:strVal val="#ppt_x"/>
+                                          </p:val>
+                                        </p:tav>
+                                      </p:tavLst>
+                                    </p:anim>
+                                    <p:anim calcmode="lin" valueType="num">
+                                      <p:cBhvr additive="base">
+                                        <p:cTn id="20" dur="500" fill="hold"/>
+                                        <p:tgtEl>
+                                          <p:spTgt spid="8"/>
+                                        </p:tgtEl>
+                                        <p:attrNameLst>
+                                          <p:attrName>ppt_y</p:attrName>
+                                        </p:attrNameLst>
+                                      </p:cBhvr>
+                                      <p:tavLst>
+                                        <p:tav tm="0">
+                                          <p:val>
+                                            <p:strVal val="1+#ppt_h/2"/>
+                                          </p:val>
+                                        </p:tav>
+                                        <p:tav tm="100000">
+                                          <p:val>
+                                            <p:strVal val="#ppt_y"/>
+                                          </p:val>
+                                        </p:tav>
+                                      </p:tavLst>
+                                    </p:anim>
+                                  </p:childTnLst>
+                                </p:cTn>
+                              </p:par>
+                            </p:childTnLst>
+                          </p:cTn>
+                        </p:par>
+                      </p:childTnLst>
+                    </p:cTn>
+                  </p:par>
+                </p:childTnLst>
+              </p:cTn>
+              <p:prevCondLst>
+                <p:cond evt="onPrev" delay="0">
+                  <p:tgtEl>
+                    <p:sldTgt/>
+                  </p:tgtEl>
+                </p:cond>
+              </p:prevCondLst>
+              <p:nextCondLst>
+                <p:cond evt="onNext" delay="0">
+                  <p:tgtEl>
+                    <p:sldTgt/>
+                  </p:tgtEl>
+                </p:cond>
+              </p:nextCondLst>
+            </p:seq>
+          </p:childTnLst>
+        </p:cTn>
+      </p:par>
+    </p:tnLst>
+  </p:timing>
+</p:sld>
+</file>
+
+<file path=ppt/slides/slide13.xml><?xml version="1.0" encoding="utf-8"?>
+<p:sld xmlns:a="http://schemas.openxmlformats.org/drawingml/2006/main" xmlns:r="http://schemas.openxmlformats.org/officeDocument/2006/relationships" xmlns:p="http://schemas.openxmlformats.org/presentationml/2006/main">
+  <p:cSld>
+    <p:spTree>
+      <p:nvGrpSpPr>
+        <p:cNvPr id="1" name=""/>
+        <p:cNvGrpSpPr/>
+        <p:nvPr/>
+      </p:nvGrpSpPr>
+      <p:grpSpPr>
+        <a:xfrm>
+          <a:off x="0" y="0"/>
+          <a:ext cx="0" cy="0"/>
+          <a:chOff x="0" y="0"/>
+          <a:chExt cx="0" cy="0"/>
+        </a:xfrm>
+      </p:grpSpPr>
+      <p:sp>
+        <p:nvSpPr>
+          <p:cNvPr id="2" name="Titolo 1">
+            <a:extLst>
+              <a:ext uri="{FF2B5EF4-FFF2-40B4-BE49-F238E27FC236}">
                 <a16:creationId xmlns:a16="http://schemas.microsoft.com/office/drawing/2014/main" id="{A05A74FC-2392-6C82-B228-D989AD37A21C}"/>
               </a:ext>
             </a:extLst>
@@ -8123,7 +8584,7 @@
 </p:sld>
 </file>
 
-<file path=ppt/slides/slide13.xml><?xml version="1.0" encoding="utf-8"?>
+<file path=ppt/slides/slide14.xml><?xml version="1.0" encoding="utf-8"?>
 <p:sld xmlns:a="http://schemas.openxmlformats.org/drawingml/2006/main" xmlns:r="http://schemas.openxmlformats.org/officeDocument/2006/relationships" xmlns:p="http://schemas.openxmlformats.org/presentationml/2006/main">
   <p:cSld>
     <p:spTree>
@@ -8247,7 +8708,7 @@
 </p:sld>
 </file>
 
-<file path=ppt/slides/slide14.xml><?xml version="1.0" encoding="utf-8"?>
+<file path=ppt/slides/slide15.xml><?xml version="1.0" encoding="utf-8"?>
 <p:sld xmlns:a="http://schemas.openxmlformats.org/drawingml/2006/main" xmlns:r="http://schemas.openxmlformats.org/officeDocument/2006/relationships" xmlns:p="http://schemas.openxmlformats.org/presentationml/2006/main">
   <p:cSld>
     <p:spTree>
@@ -8616,7 +9077,7 @@
 </p:sld>
 </file>
 
-<file path=ppt/slides/slide15.xml><?xml version="1.0" encoding="utf-8"?>
+<file path=ppt/slides/slide16.xml><?xml version="1.0" encoding="utf-8"?>
 <p:sld xmlns:a="http://schemas.openxmlformats.org/drawingml/2006/main" xmlns:r="http://schemas.openxmlformats.org/officeDocument/2006/relationships" xmlns:p="http://schemas.openxmlformats.org/presentationml/2006/main">
   <p:cSld>
     <p:spTree>
@@ -8858,7 +9319,7 @@
 </p:sld>
 </file>
 
-<file path=ppt/slides/slide16.xml><?xml version="1.0" encoding="utf-8"?>
+<file path=ppt/slides/slide17.xml><?xml version="1.0" encoding="utf-8"?>
 <p:sld xmlns:a="http://schemas.openxmlformats.org/drawingml/2006/main" xmlns:r="http://schemas.openxmlformats.org/officeDocument/2006/relationships" xmlns:p="http://schemas.openxmlformats.org/presentationml/2006/main">
   <p:cSld>
     <p:spTree>
@@ -9235,7 +9696,7 @@
 </p:sld>
 </file>
 
-<file path=ppt/slides/slide17.xml><?xml version="1.0" encoding="utf-8"?>
+<file path=ppt/slides/slide18.xml><?xml version="1.0" encoding="utf-8"?>
 <p:sld xmlns:a="http://schemas.openxmlformats.org/drawingml/2006/main" xmlns:r="http://schemas.openxmlformats.org/officeDocument/2006/relationships" xmlns:p="http://schemas.openxmlformats.org/presentationml/2006/main">
   <p:cSld>
     <p:spTree>
@@ -9679,7 +10140,7 @@
 </p:sld>
 </file>
 
-<file path=ppt/slides/slide18.xml><?xml version="1.0" encoding="utf-8"?>
+<file path=ppt/slides/slide19.xml><?xml version="1.0" encoding="utf-8"?>
 <p:sld xmlns:a="http://schemas.openxmlformats.org/drawingml/2006/main" xmlns:r="http://schemas.openxmlformats.org/officeDocument/2006/relationships" xmlns:p="http://schemas.openxmlformats.org/presentationml/2006/main">
   <p:cSld>
     <p:spTree>
@@ -9903,7 +10364,74 @@
 </p:sld>
 </file>
 
-<file path=ppt/slides/slide19.xml><?xml version="1.0" encoding="utf-8"?>
+<file path=ppt/slides/slide2.xml><?xml version="1.0" encoding="utf-8"?>
+<p:sld xmlns:a="http://schemas.openxmlformats.org/drawingml/2006/main" xmlns:r="http://schemas.openxmlformats.org/officeDocument/2006/relationships" xmlns:p="http://schemas.openxmlformats.org/presentationml/2006/main">
+  <p:cSld>
+    <p:spTree>
+      <p:nvGrpSpPr>
+        <p:cNvPr id="1" name="Shape 64"/>
+        <p:cNvGrpSpPr/>
+        <p:nvPr/>
+      </p:nvGrpSpPr>
+      <p:grpSpPr>
+        <a:xfrm>
+          <a:off x="0" y="0"/>
+          <a:ext cx="0" cy="0"/>
+          <a:chOff x="0" y="0"/>
+          <a:chExt cx="0" cy="0"/>
+        </a:xfrm>
+      </p:grpSpPr>
+      <p:sp>
+        <p:nvSpPr>
+          <p:cNvPr id="65" name="Google Shape;65;p14"/>
+          <p:cNvSpPr txBox="1">
+            <a:spLocks noGrp="1"/>
+          </p:cNvSpPr>
+          <p:nvPr>
+            <p:ph type="title"/>
+          </p:nvPr>
+        </p:nvSpPr>
+        <p:spPr>
+          <a:xfrm>
+            <a:off x="490250" y="526350"/>
+            <a:ext cx="5604000" cy="4090800"/>
+          </a:xfrm>
+          <a:prstGeom prst="rect">
+            <a:avLst/>
+          </a:prstGeom>
+        </p:spPr>
+        <p:txBody>
+          <a:bodyPr spcFirstLastPara="1" wrap="square" lIns="91425" tIns="91425" rIns="91425" bIns="91425" anchor="ctr" anchorCtr="0">
+            <a:noAutofit/>
+          </a:bodyPr>
+          <a:lstStyle/>
+          <a:p>
+            <a:pPr marL="0" lvl="0" indent="0" algn="l" rtl="0">
+              <a:spcBef>
+                <a:spcPts val="0"/>
+              </a:spcBef>
+              <a:spcAft>
+                <a:spcPts val="0"/>
+              </a:spcAft>
+              <a:buNone/>
+            </a:pPr>
+            <a:r>
+              <a:rPr lang="it"/>
+              <a:t>Il progetto</a:t>
+            </a:r>
+            <a:endParaRPr/>
+          </a:p>
+        </p:txBody>
+      </p:sp>
+    </p:spTree>
+  </p:cSld>
+  <p:clrMapOvr>
+    <a:masterClrMapping/>
+  </p:clrMapOvr>
+</p:sld>
+</file>
+
+<file path=ppt/slides/slide20.xml><?xml version="1.0" encoding="utf-8"?>
 <p:sld xmlns:a="http://schemas.openxmlformats.org/drawingml/2006/main" xmlns:r="http://schemas.openxmlformats.org/officeDocument/2006/relationships" xmlns:p="http://schemas.openxmlformats.org/presentationml/2006/main">
   <p:cSld>
     <p:spTree>
@@ -10127,74 +10655,7 @@
 </p:sld>
 </file>
 
-<file path=ppt/slides/slide2.xml><?xml version="1.0" encoding="utf-8"?>
-<p:sld xmlns:a="http://schemas.openxmlformats.org/drawingml/2006/main" xmlns:r="http://schemas.openxmlformats.org/officeDocument/2006/relationships" xmlns:p="http://schemas.openxmlformats.org/presentationml/2006/main">
-  <p:cSld>
-    <p:spTree>
-      <p:nvGrpSpPr>
-        <p:cNvPr id="1" name="Shape 64"/>
-        <p:cNvGrpSpPr/>
-        <p:nvPr/>
-      </p:nvGrpSpPr>
-      <p:grpSpPr>
-        <a:xfrm>
-          <a:off x="0" y="0"/>
-          <a:ext cx="0" cy="0"/>
-          <a:chOff x="0" y="0"/>
-          <a:chExt cx="0" cy="0"/>
-        </a:xfrm>
-      </p:grpSpPr>
-      <p:sp>
-        <p:nvSpPr>
-          <p:cNvPr id="65" name="Google Shape;65;p14"/>
-          <p:cNvSpPr txBox="1">
-            <a:spLocks noGrp="1"/>
-          </p:cNvSpPr>
-          <p:nvPr>
-            <p:ph type="title"/>
-          </p:nvPr>
-        </p:nvSpPr>
-        <p:spPr>
-          <a:xfrm>
-            <a:off x="490250" y="526350"/>
-            <a:ext cx="5604000" cy="4090800"/>
-          </a:xfrm>
-          <a:prstGeom prst="rect">
-            <a:avLst/>
-          </a:prstGeom>
-        </p:spPr>
-        <p:txBody>
-          <a:bodyPr spcFirstLastPara="1" wrap="square" lIns="91425" tIns="91425" rIns="91425" bIns="91425" anchor="ctr" anchorCtr="0">
-            <a:noAutofit/>
-          </a:bodyPr>
-          <a:lstStyle/>
-          <a:p>
-            <a:pPr marL="0" lvl="0" indent="0" algn="l" rtl="0">
-              <a:spcBef>
-                <a:spcPts val="0"/>
-              </a:spcBef>
-              <a:spcAft>
-                <a:spcPts val="0"/>
-              </a:spcAft>
-              <a:buNone/>
-            </a:pPr>
-            <a:r>
-              <a:rPr lang="it"/>
-              <a:t>Il progetto</a:t>
-            </a:r>
-            <a:endParaRPr/>
-          </a:p>
-        </p:txBody>
-      </p:sp>
-    </p:spTree>
-  </p:cSld>
-  <p:clrMapOvr>
-    <a:masterClrMapping/>
-  </p:clrMapOvr>
-</p:sld>
-</file>
-
-<file path=ppt/slides/slide20.xml><?xml version="1.0" encoding="utf-8"?>
+<file path=ppt/slides/slide21.xml><?xml version="1.0" encoding="utf-8"?>
 <p:sld xmlns:a="http://schemas.openxmlformats.org/drawingml/2006/main" xmlns:r="http://schemas.openxmlformats.org/officeDocument/2006/relationships" xmlns:p="http://schemas.openxmlformats.org/presentationml/2006/main">
   <p:cSld>
     <p:spTree>
@@ -10418,7 +10879,7 @@
 </p:sld>
 </file>
 
-<file path=ppt/slides/slide21.xml><?xml version="1.0" encoding="utf-8"?>
+<file path=ppt/slides/slide22.xml><?xml version="1.0" encoding="utf-8"?>
 <p:sld xmlns:a="http://schemas.openxmlformats.org/drawingml/2006/main" xmlns:r="http://schemas.openxmlformats.org/officeDocument/2006/relationships" xmlns:p="http://schemas.openxmlformats.org/presentationml/2006/main">
   <p:cSld>
     <p:spTree>
@@ -10642,7 +11103,7 @@
 </p:sld>
 </file>
 
-<file path=ppt/slides/slide22.xml><?xml version="1.0" encoding="utf-8"?>
+<file path=ppt/slides/slide23.xml><?xml version="1.0" encoding="utf-8"?>
 <p:sld xmlns:a="http://schemas.openxmlformats.org/drawingml/2006/main" xmlns:r="http://schemas.openxmlformats.org/officeDocument/2006/relationships" xmlns:p="http://schemas.openxmlformats.org/presentationml/2006/main">
   <p:cSld>
     <p:spTree>

</xml_diff>

<commit_message>
Aggiunte slide a pp
</commit_message>
<xml_diff>
--- a/Documenti/Relazione Finale/PP relazione.pptx
+++ b/Documenti/Relazione Finale/PP relazione.pptx
@@ -5,7 +5,7 @@
     <p:sldMasterId id="2147483659" r:id="rId1"/>
   </p:sldMasterIdLst>
   <p:notesMasterIdLst>
-    <p:notesMasterId r:id="rId28"/>
+    <p:notesMasterId r:id="rId30"/>
   </p:notesMasterIdLst>
   <p:sldIdLst>
     <p:sldId id="256" r:id="rId2"/>
@@ -14,42 +14,44 @@
     <p:sldId id="264" r:id="rId5"/>
     <p:sldId id="259" r:id="rId6"/>
     <p:sldId id="266" r:id="rId7"/>
-    <p:sldId id="268" r:id="rId8"/>
-    <p:sldId id="262" r:id="rId9"/>
-    <p:sldId id="265" r:id="rId10"/>
-    <p:sldId id="279" r:id="rId11"/>
-    <p:sldId id="280" r:id="rId12"/>
+    <p:sldId id="280" r:id="rId8"/>
+    <p:sldId id="268" r:id="rId9"/>
+    <p:sldId id="262" r:id="rId10"/>
+    <p:sldId id="265" r:id="rId11"/>
+    <p:sldId id="279" r:id="rId12"/>
     <p:sldId id="260" r:id="rId13"/>
     <p:sldId id="267" r:id="rId14"/>
-    <p:sldId id="269" r:id="rId15"/>
-    <p:sldId id="270" r:id="rId16"/>
-    <p:sldId id="271" r:id="rId17"/>
-    <p:sldId id="272" r:id="rId18"/>
-    <p:sldId id="273" r:id="rId19"/>
-    <p:sldId id="274" r:id="rId20"/>
-    <p:sldId id="275" r:id="rId21"/>
-    <p:sldId id="277" r:id="rId22"/>
-    <p:sldId id="278" r:id="rId23"/>
-    <p:sldId id="276" r:id="rId24"/>
-    <p:sldId id="281" r:id="rId25"/>
-    <p:sldId id="282" r:id="rId26"/>
-    <p:sldId id="283" r:id="rId27"/>
+    <p:sldId id="285" r:id="rId15"/>
+    <p:sldId id="269" r:id="rId16"/>
+    <p:sldId id="284" r:id="rId17"/>
+    <p:sldId id="270" r:id="rId18"/>
+    <p:sldId id="271" r:id="rId19"/>
+    <p:sldId id="272" r:id="rId20"/>
+    <p:sldId id="273" r:id="rId21"/>
+    <p:sldId id="274" r:id="rId22"/>
+    <p:sldId id="275" r:id="rId23"/>
+    <p:sldId id="277" r:id="rId24"/>
+    <p:sldId id="278" r:id="rId25"/>
+    <p:sldId id="276" r:id="rId26"/>
+    <p:sldId id="281" r:id="rId27"/>
+    <p:sldId id="282" r:id="rId28"/>
+    <p:sldId id="283" r:id="rId29"/>
   </p:sldIdLst>
   <p:sldSz cx="9144000" cy="5143500" type="screen16x9"/>
   <p:notesSz cx="6858000" cy="9144000"/>
   <p:embeddedFontLst>
     <p:embeddedFont>
       <p:font typeface="Amasis MT Pro" panose="02040504050005020304" pitchFamily="18" charset="0"/>
-      <p:regular r:id="rId29"/>
-      <p:bold r:id="rId30"/>
-      <p:italic r:id="rId31"/>
-      <p:boldItalic r:id="rId32"/>
+      <p:regular r:id="rId31"/>
+      <p:bold r:id="rId32"/>
+      <p:italic r:id="rId33"/>
+      <p:boldItalic r:id="rId34"/>
     </p:embeddedFont>
     <p:embeddedFont>
       <p:font typeface="Old Standard TT" panose="020B0604020202020204" charset="0"/>
-      <p:regular r:id="rId33"/>
-      <p:bold r:id="rId34"/>
-      <p:italic r:id="rId35"/>
+      <p:regular r:id="rId35"/>
+      <p:bold r:id="rId36"/>
+      <p:italic r:id="rId37"/>
     </p:embeddedFont>
   </p:embeddedFontLst>
   <p:defaultTextStyle>
@@ -7072,6 +7074,1349 @@
           <p:cNvPr id="2" name="Titolo 1">
             <a:extLst>
               <a:ext uri="{FF2B5EF4-FFF2-40B4-BE49-F238E27FC236}">
+                <a16:creationId xmlns:a16="http://schemas.microsoft.com/office/drawing/2014/main" id="{CDA77C0F-428A-8B4D-B18A-BC19217C36C7}"/>
+              </a:ext>
+            </a:extLst>
+          </p:cNvPr>
+          <p:cNvSpPr>
+            <a:spLocks noGrp="1"/>
+          </p:cNvSpPr>
+          <p:nvPr>
+            <p:ph type="title"/>
+          </p:nvPr>
+        </p:nvSpPr>
+        <p:spPr/>
+        <p:txBody>
+          <a:bodyPr/>
+          <a:lstStyle/>
+          <a:p>
+            <a:pPr algn="ctr"/>
+            <a:r>
+              <a:rPr lang="it-IT" dirty="0"/>
+              <a:t>WIREFRAME DELL’APP</a:t>
+            </a:r>
+          </a:p>
+        </p:txBody>
+      </p:sp>
+      <p:pic>
+        <p:nvPicPr>
+          <p:cNvPr id="4" name="Immagine 3" descr="Immagine che contiene testo, schermata, cerchio, logo&#10;&#10;Il contenuto generato dall'IA potrebbe non essere corretto.">
+            <a:extLst>
+              <a:ext uri="{FF2B5EF4-FFF2-40B4-BE49-F238E27FC236}">
+                <a16:creationId xmlns:a16="http://schemas.microsoft.com/office/drawing/2014/main" id="{217FE4B0-D712-635C-F1D1-D43A9F7986FC}"/>
+              </a:ext>
+            </a:extLst>
+          </p:cNvPr>
+          <p:cNvPicPr>
+            <a:picLocks noChangeAspect="1"/>
+          </p:cNvPicPr>
+          <p:nvPr/>
+        </p:nvPicPr>
+        <p:blipFill>
+          <a:blip r:embed="rId2"/>
+          <a:stretch>
+            <a:fillRect/>
+          </a:stretch>
+        </p:blipFill>
+        <p:spPr>
+          <a:xfrm>
+            <a:off x="533468" y="1019785"/>
+            <a:ext cx="830804" cy="1849143"/>
+          </a:xfrm>
+          <a:prstGeom prst="rect">
+            <a:avLst/>
+          </a:prstGeom>
+        </p:spPr>
+      </p:pic>
+      <p:pic>
+        <p:nvPicPr>
+          <p:cNvPr id="26" name="Immagine 25" descr="Immagine che contiene testo, schermata, Carattere, design&#10;&#10;Il contenuto generato dall'IA potrebbe non essere corretto.">
+            <a:extLst>
+              <a:ext uri="{FF2B5EF4-FFF2-40B4-BE49-F238E27FC236}">
+                <a16:creationId xmlns:a16="http://schemas.microsoft.com/office/drawing/2014/main" id="{EB8A02DE-DEB9-3CE5-085A-AEC786AC52A0}"/>
+              </a:ext>
+            </a:extLst>
+          </p:cNvPr>
+          <p:cNvPicPr>
+            <a:picLocks noChangeAspect="1"/>
+          </p:cNvPicPr>
+          <p:nvPr/>
+        </p:nvPicPr>
+        <p:blipFill>
+          <a:blip r:embed="rId3"/>
+          <a:stretch>
+            <a:fillRect/>
+          </a:stretch>
+        </p:blipFill>
+        <p:spPr>
+          <a:xfrm flipH="1">
+            <a:off x="2653483" y="3044883"/>
+            <a:ext cx="830802" cy="1849140"/>
+          </a:xfrm>
+          <a:prstGeom prst="rect">
+            <a:avLst/>
+          </a:prstGeom>
+        </p:spPr>
+      </p:pic>
+      <p:pic>
+        <p:nvPicPr>
+          <p:cNvPr id="28" name="Immagine 27" descr="Immagine che contiene testo, schermata, Carattere, design&#10;&#10;Il contenuto generato dall'IA potrebbe non essere corretto.">
+            <a:extLst>
+              <a:ext uri="{FF2B5EF4-FFF2-40B4-BE49-F238E27FC236}">
+                <a16:creationId xmlns:a16="http://schemas.microsoft.com/office/drawing/2014/main" id="{5A62DBC2-49C9-4D2B-5B8A-40074EE76EC3}"/>
+              </a:ext>
+            </a:extLst>
+          </p:cNvPr>
+          <p:cNvPicPr>
+            <a:picLocks noChangeAspect="1"/>
+          </p:cNvPicPr>
+          <p:nvPr/>
+        </p:nvPicPr>
+        <p:blipFill>
+          <a:blip r:embed="rId4"/>
+          <a:stretch>
+            <a:fillRect/>
+          </a:stretch>
+        </p:blipFill>
+        <p:spPr>
+          <a:xfrm>
+            <a:off x="5667200" y="1067394"/>
+            <a:ext cx="864552" cy="1924258"/>
+          </a:xfrm>
+          <a:prstGeom prst="rect">
+            <a:avLst/>
+          </a:prstGeom>
+        </p:spPr>
+      </p:pic>
+      <p:pic>
+        <p:nvPicPr>
+          <p:cNvPr id="30" name="Immagine 29" descr="Immagine che contiene testo, schermata, biglietto da visita, design&#10;&#10;Il contenuto generato dall'IA potrebbe non essere corretto.">
+            <a:extLst>
+              <a:ext uri="{FF2B5EF4-FFF2-40B4-BE49-F238E27FC236}">
+                <a16:creationId xmlns:a16="http://schemas.microsoft.com/office/drawing/2014/main" id="{030715D4-13A2-9A99-BC46-49964438FCE4}"/>
+              </a:ext>
+            </a:extLst>
+          </p:cNvPr>
+          <p:cNvPicPr>
+            <a:picLocks noChangeAspect="1"/>
+          </p:cNvPicPr>
+          <p:nvPr/>
+        </p:nvPicPr>
+        <p:blipFill>
+          <a:blip r:embed="rId5"/>
+          <a:stretch>
+            <a:fillRect/>
+          </a:stretch>
+        </p:blipFill>
+        <p:spPr>
+          <a:xfrm>
+            <a:off x="6774478" y="1057344"/>
+            <a:ext cx="864552" cy="1924259"/>
+          </a:xfrm>
+          <a:prstGeom prst="rect">
+            <a:avLst/>
+          </a:prstGeom>
+        </p:spPr>
+      </p:pic>
+      <p:pic>
+        <p:nvPicPr>
+          <p:cNvPr id="32" name="Immagine 31" descr="Immagine che contiene testo, schermata, Carattere, design&#10;&#10;Il contenuto generato dall'IA potrebbe non essere corretto.">
+            <a:extLst>
+              <a:ext uri="{FF2B5EF4-FFF2-40B4-BE49-F238E27FC236}">
+                <a16:creationId xmlns:a16="http://schemas.microsoft.com/office/drawing/2014/main" id="{B7D876EF-870A-461F-D6E3-AF266C3C95B9}"/>
+              </a:ext>
+            </a:extLst>
+          </p:cNvPr>
+          <p:cNvPicPr>
+            <a:picLocks noChangeAspect="1"/>
+          </p:cNvPicPr>
+          <p:nvPr/>
+        </p:nvPicPr>
+        <p:blipFill>
+          <a:blip r:embed="rId6"/>
+          <a:stretch>
+            <a:fillRect/>
+          </a:stretch>
+        </p:blipFill>
+        <p:spPr>
+          <a:xfrm>
+            <a:off x="4869823" y="3073459"/>
+            <a:ext cx="864553" cy="1924259"/>
+          </a:xfrm>
+          <a:prstGeom prst="rect">
+            <a:avLst/>
+          </a:prstGeom>
+        </p:spPr>
+      </p:pic>
+      <p:pic>
+        <p:nvPicPr>
+          <p:cNvPr id="34" name="Immagine 33" descr="Immagine che contiene testo, schermata, logo, design&#10;&#10;Il contenuto generato dall'IA potrebbe non essere corretto.">
+            <a:extLst>
+              <a:ext uri="{FF2B5EF4-FFF2-40B4-BE49-F238E27FC236}">
+                <a16:creationId xmlns:a16="http://schemas.microsoft.com/office/drawing/2014/main" id="{C5AF193D-71B0-A3F6-0501-C0D09EAB8DF2}"/>
+              </a:ext>
+            </a:extLst>
+          </p:cNvPr>
+          <p:cNvPicPr>
+            <a:picLocks noChangeAspect="1"/>
+          </p:cNvPicPr>
+          <p:nvPr/>
+        </p:nvPicPr>
+        <p:blipFill>
+          <a:blip r:embed="rId7"/>
+          <a:stretch>
+            <a:fillRect/>
+          </a:stretch>
+        </p:blipFill>
+        <p:spPr>
+          <a:xfrm>
+            <a:off x="2550270" y="1058737"/>
+            <a:ext cx="838875" cy="1867109"/>
+          </a:xfrm>
+          <a:prstGeom prst="rect">
+            <a:avLst/>
+          </a:prstGeom>
+        </p:spPr>
+      </p:pic>
+      <p:pic>
+        <p:nvPicPr>
+          <p:cNvPr id="36" name="Immagine 35" descr="Immagine che contiene testo, schermata, numero, Carattere&#10;&#10;Il contenuto generato dall'IA potrebbe non essere corretto.">
+            <a:extLst>
+              <a:ext uri="{FF2B5EF4-FFF2-40B4-BE49-F238E27FC236}">
+                <a16:creationId xmlns:a16="http://schemas.microsoft.com/office/drawing/2014/main" id="{9F8718C3-4DCB-1ED3-E28B-E299F8ED67A2}"/>
+              </a:ext>
+            </a:extLst>
+          </p:cNvPr>
+          <p:cNvPicPr>
+            <a:picLocks noChangeAspect="1"/>
+          </p:cNvPicPr>
+          <p:nvPr/>
+        </p:nvPicPr>
+        <p:blipFill>
+          <a:blip r:embed="rId8"/>
+          <a:stretch>
+            <a:fillRect/>
+          </a:stretch>
+        </p:blipFill>
+        <p:spPr>
+          <a:xfrm>
+            <a:off x="3757616" y="3073459"/>
+            <a:ext cx="838876" cy="1867109"/>
+          </a:xfrm>
+          <a:prstGeom prst="rect">
+            <a:avLst/>
+          </a:prstGeom>
+        </p:spPr>
+      </p:pic>
+      <p:pic>
+        <p:nvPicPr>
+          <p:cNvPr id="38" name="Immagine 37" descr="Immagine che contiene testo, schermata, cerchio, Carattere&#10;&#10;Il contenuto generato dall'IA potrebbe non essere corretto.">
+            <a:extLst>
+              <a:ext uri="{FF2B5EF4-FFF2-40B4-BE49-F238E27FC236}">
+                <a16:creationId xmlns:a16="http://schemas.microsoft.com/office/drawing/2014/main" id="{81F0ABAE-28AE-C04C-9E3D-B61298F422DF}"/>
+              </a:ext>
+            </a:extLst>
+          </p:cNvPr>
+          <p:cNvPicPr>
+            <a:picLocks noChangeAspect="1"/>
+          </p:cNvPicPr>
+          <p:nvPr/>
+        </p:nvPicPr>
+        <p:blipFill>
+          <a:blip r:embed="rId9"/>
+          <a:stretch>
+            <a:fillRect/>
+          </a:stretch>
+        </p:blipFill>
+        <p:spPr>
+          <a:xfrm>
+            <a:off x="4633612" y="1048800"/>
+            <a:ext cx="838876" cy="1867109"/>
+          </a:xfrm>
+          <a:prstGeom prst="rect">
+            <a:avLst/>
+          </a:prstGeom>
+        </p:spPr>
+      </p:pic>
+      <p:pic>
+        <p:nvPicPr>
+          <p:cNvPr id="40" name="Immagine 39" descr="Immagine che contiene testo, schermata, grafica, logo&#10;&#10;Il contenuto generato dall'IA potrebbe non essere corretto.">
+            <a:extLst>
+              <a:ext uri="{FF2B5EF4-FFF2-40B4-BE49-F238E27FC236}">
+                <a16:creationId xmlns:a16="http://schemas.microsoft.com/office/drawing/2014/main" id="{5938B6A7-133E-B8E0-A180-2A475E9BADA9}"/>
+              </a:ext>
+            </a:extLst>
+          </p:cNvPr>
+          <p:cNvPicPr>
+            <a:picLocks noChangeAspect="1"/>
+          </p:cNvPicPr>
+          <p:nvPr/>
+        </p:nvPicPr>
+        <p:blipFill>
+          <a:blip r:embed="rId10"/>
+          <a:stretch>
+            <a:fillRect/>
+          </a:stretch>
+        </p:blipFill>
+        <p:spPr>
+          <a:xfrm>
+            <a:off x="7875587" y="1057344"/>
+            <a:ext cx="830803" cy="1849140"/>
+          </a:xfrm>
+          <a:prstGeom prst="rect">
+            <a:avLst/>
+          </a:prstGeom>
+        </p:spPr>
+      </p:pic>
+      <p:pic>
+        <p:nvPicPr>
+          <p:cNvPr id="42" name="Immagine 41" descr="Immagine che contiene testo, schermata, cerchio, Elementi grafici&#10;&#10;Il contenuto generato dall'IA potrebbe non essere corretto.">
+            <a:extLst>
+              <a:ext uri="{FF2B5EF4-FFF2-40B4-BE49-F238E27FC236}">
+                <a16:creationId xmlns:a16="http://schemas.microsoft.com/office/drawing/2014/main" id="{AC90764F-519C-F11F-4791-3F7545F71713}"/>
+              </a:ext>
+            </a:extLst>
+          </p:cNvPr>
+          <p:cNvPicPr>
+            <a:picLocks noChangeAspect="1"/>
+          </p:cNvPicPr>
+          <p:nvPr/>
+        </p:nvPicPr>
+        <p:blipFill>
+          <a:blip r:embed="rId11"/>
+          <a:stretch>
+            <a:fillRect/>
+          </a:stretch>
+        </p:blipFill>
+        <p:spPr>
+          <a:xfrm>
+            <a:off x="3528047" y="1039005"/>
+            <a:ext cx="890062" cy="1981036"/>
+          </a:xfrm>
+          <a:prstGeom prst="rect">
+            <a:avLst/>
+          </a:prstGeom>
+        </p:spPr>
+      </p:pic>
+      <p:pic>
+        <p:nvPicPr>
+          <p:cNvPr id="44" name="Immagine 43" descr="Immagine che contiene testo, schermata, Carattere, design&#10;&#10;Il contenuto generato dall'IA potrebbe non essere corretto.">
+            <a:extLst>
+              <a:ext uri="{FF2B5EF4-FFF2-40B4-BE49-F238E27FC236}">
+                <a16:creationId xmlns:a16="http://schemas.microsoft.com/office/drawing/2014/main" id="{D54A1AA3-F9D8-A2C5-A901-76D1109BB44B}"/>
+              </a:ext>
+            </a:extLst>
+          </p:cNvPr>
+          <p:cNvPicPr>
+            <a:picLocks noChangeAspect="1"/>
+          </p:cNvPicPr>
+          <p:nvPr/>
+        </p:nvPicPr>
+        <p:blipFill>
+          <a:blip r:embed="rId12"/>
+          <a:stretch>
+            <a:fillRect/>
+          </a:stretch>
+        </p:blipFill>
+        <p:spPr>
+          <a:xfrm>
+            <a:off x="6008393" y="3073460"/>
+            <a:ext cx="864552" cy="1924258"/>
+          </a:xfrm>
+          <a:prstGeom prst="rect">
+            <a:avLst/>
+          </a:prstGeom>
+        </p:spPr>
+      </p:pic>
+      <p:pic>
+        <p:nvPicPr>
+          <p:cNvPr id="46" name="Immagine 45" descr="Immagine che contiene testo, schermata, cerchio, design&#10;&#10;Il contenuto generato dall'IA potrebbe non essere corretto.">
+            <a:extLst>
+              <a:ext uri="{FF2B5EF4-FFF2-40B4-BE49-F238E27FC236}">
+                <a16:creationId xmlns:a16="http://schemas.microsoft.com/office/drawing/2014/main" id="{0BC4043E-2ACA-8C92-2EA6-1753C6C170A0}"/>
+              </a:ext>
+            </a:extLst>
+          </p:cNvPr>
+          <p:cNvPicPr>
+            <a:picLocks noChangeAspect="1"/>
+          </p:cNvPicPr>
+          <p:nvPr/>
+        </p:nvPicPr>
+        <p:blipFill>
+          <a:blip r:embed="rId13"/>
+          <a:stretch>
+            <a:fillRect/>
+          </a:stretch>
+        </p:blipFill>
+        <p:spPr>
+          <a:xfrm>
+            <a:off x="1524994" y="1035021"/>
+            <a:ext cx="864553" cy="1924261"/>
+          </a:xfrm>
+          <a:prstGeom prst="rect">
+            <a:avLst/>
+          </a:prstGeom>
+        </p:spPr>
+      </p:pic>
+    </p:spTree>
+    <p:extLst>
+      <p:ext uri="{BB962C8B-B14F-4D97-AF65-F5344CB8AC3E}">
+        <p14:creationId xmlns:p14="http://schemas.microsoft.com/office/powerpoint/2010/main" val="2210377371"/>
+      </p:ext>
+    </p:extLst>
+  </p:cSld>
+  <p:clrMapOvr>
+    <a:masterClrMapping/>
+  </p:clrMapOvr>
+  <p:timing>
+    <p:tnLst>
+      <p:par>
+        <p:cTn id="1" dur="indefinite" restart="never" nodeType="tmRoot">
+          <p:childTnLst>
+            <p:seq concurrent="1" nextAc="seek">
+              <p:cTn id="2" dur="indefinite" nodeType="mainSeq">
+                <p:childTnLst>
+                  <p:par>
+                    <p:cTn id="3" fill="hold">
+                      <p:stCondLst>
+                        <p:cond delay="indefinite"/>
+                      </p:stCondLst>
+                      <p:childTnLst>
+                        <p:par>
+                          <p:cTn id="4" fill="hold">
+                            <p:stCondLst>
+                              <p:cond delay="0"/>
+                            </p:stCondLst>
+                            <p:childTnLst>
+                              <p:par>
+                                <p:cTn id="5" presetID="2" presetClass="entr" presetSubtype="4" fill="hold" nodeType="clickEffect">
+                                  <p:stCondLst>
+                                    <p:cond delay="0"/>
+                                  </p:stCondLst>
+                                  <p:childTnLst>
+                                    <p:set>
+                                      <p:cBhvr>
+                                        <p:cTn id="6" dur="1" fill="hold">
+                                          <p:stCondLst>
+                                            <p:cond delay="0"/>
+                                          </p:stCondLst>
+                                        </p:cTn>
+                                        <p:tgtEl>
+                                          <p:spTgt spid="4"/>
+                                        </p:tgtEl>
+                                        <p:attrNameLst>
+                                          <p:attrName>style.visibility</p:attrName>
+                                        </p:attrNameLst>
+                                      </p:cBhvr>
+                                      <p:to>
+                                        <p:strVal val="visible"/>
+                                      </p:to>
+                                    </p:set>
+                                    <p:anim calcmode="lin" valueType="num">
+                                      <p:cBhvr additive="base">
+                                        <p:cTn id="7" dur="500" fill="hold"/>
+                                        <p:tgtEl>
+                                          <p:spTgt spid="4"/>
+                                        </p:tgtEl>
+                                        <p:attrNameLst>
+                                          <p:attrName>ppt_x</p:attrName>
+                                        </p:attrNameLst>
+                                      </p:cBhvr>
+                                      <p:tavLst>
+                                        <p:tav tm="0">
+                                          <p:val>
+                                            <p:strVal val="#ppt_x"/>
+                                          </p:val>
+                                        </p:tav>
+                                        <p:tav tm="100000">
+                                          <p:val>
+                                            <p:strVal val="#ppt_x"/>
+                                          </p:val>
+                                        </p:tav>
+                                      </p:tavLst>
+                                    </p:anim>
+                                    <p:anim calcmode="lin" valueType="num">
+                                      <p:cBhvr additive="base">
+                                        <p:cTn id="8" dur="500" fill="hold"/>
+                                        <p:tgtEl>
+                                          <p:spTgt spid="4"/>
+                                        </p:tgtEl>
+                                        <p:attrNameLst>
+                                          <p:attrName>ppt_y</p:attrName>
+                                        </p:attrNameLst>
+                                      </p:cBhvr>
+                                      <p:tavLst>
+                                        <p:tav tm="0">
+                                          <p:val>
+                                            <p:strVal val="1+#ppt_h/2"/>
+                                          </p:val>
+                                        </p:tav>
+                                        <p:tav tm="100000">
+                                          <p:val>
+                                            <p:strVal val="#ppt_y"/>
+                                          </p:val>
+                                        </p:tav>
+                                      </p:tavLst>
+                                    </p:anim>
+                                  </p:childTnLst>
+                                </p:cTn>
+                              </p:par>
+                              <p:par>
+                                <p:cTn id="9" presetID="2" presetClass="entr" presetSubtype="4" fill="hold" nodeType="withEffect">
+                                  <p:stCondLst>
+                                    <p:cond delay="0"/>
+                                  </p:stCondLst>
+                                  <p:childTnLst>
+                                    <p:set>
+                                      <p:cBhvr>
+                                        <p:cTn id="10" dur="1" fill="hold">
+                                          <p:stCondLst>
+                                            <p:cond delay="0"/>
+                                          </p:stCondLst>
+                                        </p:cTn>
+                                        <p:tgtEl>
+                                          <p:spTgt spid="46"/>
+                                        </p:tgtEl>
+                                        <p:attrNameLst>
+                                          <p:attrName>style.visibility</p:attrName>
+                                        </p:attrNameLst>
+                                      </p:cBhvr>
+                                      <p:to>
+                                        <p:strVal val="visible"/>
+                                      </p:to>
+                                    </p:set>
+                                    <p:anim calcmode="lin" valueType="num">
+                                      <p:cBhvr additive="base">
+                                        <p:cTn id="11" dur="500" fill="hold"/>
+                                        <p:tgtEl>
+                                          <p:spTgt spid="46"/>
+                                        </p:tgtEl>
+                                        <p:attrNameLst>
+                                          <p:attrName>ppt_x</p:attrName>
+                                        </p:attrNameLst>
+                                      </p:cBhvr>
+                                      <p:tavLst>
+                                        <p:tav tm="0">
+                                          <p:val>
+                                            <p:strVal val="#ppt_x"/>
+                                          </p:val>
+                                        </p:tav>
+                                        <p:tav tm="100000">
+                                          <p:val>
+                                            <p:strVal val="#ppt_x"/>
+                                          </p:val>
+                                        </p:tav>
+                                      </p:tavLst>
+                                    </p:anim>
+                                    <p:anim calcmode="lin" valueType="num">
+                                      <p:cBhvr additive="base">
+                                        <p:cTn id="12" dur="500" fill="hold"/>
+                                        <p:tgtEl>
+                                          <p:spTgt spid="46"/>
+                                        </p:tgtEl>
+                                        <p:attrNameLst>
+                                          <p:attrName>ppt_y</p:attrName>
+                                        </p:attrNameLst>
+                                      </p:cBhvr>
+                                      <p:tavLst>
+                                        <p:tav tm="0">
+                                          <p:val>
+                                            <p:strVal val="1+#ppt_h/2"/>
+                                          </p:val>
+                                        </p:tav>
+                                        <p:tav tm="100000">
+                                          <p:val>
+                                            <p:strVal val="#ppt_y"/>
+                                          </p:val>
+                                        </p:tav>
+                                      </p:tavLst>
+                                    </p:anim>
+                                  </p:childTnLst>
+                                </p:cTn>
+                              </p:par>
+                              <p:par>
+                                <p:cTn id="13" presetID="2" presetClass="entr" presetSubtype="4" fill="hold" nodeType="withEffect">
+                                  <p:stCondLst>
+                                    <p:cond delay="0"/>
+                                  </p:stCondLst>
+                                  <p:childTnLst>
+                                    <p:set>
+                                      <p:cBhvr>
+                                        <p:cTn id="14" dur="1" fill="hold">
+                                          <p:stCondLst>
+                                            <p:cond delay="0"/>
+                                          </p:stCondLst>
+                                        </p:cTn>
+                                        <p:tgtEl>
+                                          <p:spTgt spid="34"/>
+                                        </p:tgtEl>
+                                        <p:attrNameLst>
+                                          <p:attrName>style.visibility</p:attrName>
+                                        </p:attrNameLst>
+                                      </p:cBhvr>
+                                      <p:to>
+                                        <p:strVal val="visible"/>
+                                      </p:to>
+                                    </p:set>
+                                    <p:anim calcmode="lin" valueType="num">
+                                      <p:cBhvr additive="base">
+                                        <p:cTn id="15" dur="500" fill="hold"/>
+                                        <p:tgtEl>
+                                          <p:spTgt spid="34"/>
+                                        </p:tgtEl>
+                                        <p:attrNameLst>
+                                          <p:attrName>ppt_x</p:attrName>
+                                        </p:attrNameLst>
+                                      </p:cBhvr>
+                                      <p:tavLst>
+                                        <p:tav tm="0">
+                                          <p:val>
+                                            <p:strVal val="#ppt_x"/>
+                                          </p:val>
+                                        </p:tav>
+                                        <p:tav tm="100000">
+                                          <p:val>
+                                            <p:strVal val="#ppt_x"/>
+                                          </p:val>
+                                        </p:tav>
+                                      </p:tavLst>
+                                    </p:anim>
+                                    <p:anim calcmode="lin" valueType="num">
+                                      <p:cBhvr additive="base">
+                                        <p:cTn id="16" dur="500" fill="hold"/>
+                                        <p:tgtEl>
+                                          <p:spTgt spid="34"/>
+                                        </p:tgtEl>
+                                        <p:attrNameLst>
+                                          <p:attrName>ppt_y</p:attrName>
+                                        </p:attrNameLst>
+                                      </p:cBhvr>
+                                      <p:tavLst>
+                                        <p:tav tm="0">
+                                          <p:val>
+                                            <p:strVal val="1+#ppt_h/2"/>
+                                          </p:val>
+                                        </p:tav>
+                                        <p:tav tm="100000">
+                                          <p:val>
+                                            <p:strVal val="#ppt_y"/>
+                                          </p:val>
+                                        </p:tav>
+                                      </p:tavLst>
+                                    </p:anim>
+                                  </p:childTnLst>
+                                </p:cTn>
+                              </p:par>
+                              <p:par>
+                                <p:cTn id="17" presetID="2" presetClass="entr" presetSubtype="4" fill="hold" nodeType="withEffect">
+                                  <p:stCondLst>
+                                    <p:cond delay="0"/>
+                                  </p:stCondLst>
+                                  <p:childTnLst>
+                                    <p:set>
+                                      <p:cBhvr>
+                                        <p:cTn id="18" dur="1" fill="hold">
+                                          <p:stCondLst>
+                                            <p:cond delay="0"/>
+                                          </p:stCondLst>
+                                        </p:cTn>
+                                        <p:tgtEl>
+                                          <p:spTgt spid="42"/>
+                                        </p:tgtEl>
+                                        <p:attrNameLst>
+                                          <p:attrName>style.visibility</p:attrName>
+                                        </p:attrNameLst>
+                                      </p:cBhvr>
+                                      <p:to>
+                                        <p:strVal val="visible"/>
+                                      </p:to>
+                                    </p:set>
+                                    <p:anim calcmode="lin" valueType="num">
+                                      <p:cBhvr additive="base">
+                                        <p:cTn id="19" dur="500" fill="hold"/>
+                                        <p:tgtEl>
+                                          <p:spTgt spid="42"/>
+                                        </p:tgtEl>
+                                        <p:attrNameLst>
+                                          <p:attrName>ppt_x</p:attrName>
+                                        </p:attrNameLst>
+                                      </p:cBhvr>
+                                      <p:tavLst>
+                                        <p:tav tm="0">
+                                          <p:val>
+                                            <p:strVal val="#ppt_x"/>
+                                          </p:val>
+                                        </p:tav>
+                                        <p:tav tm="100000">
+                                          <p:val>
+                                            <p:strVal val="#ppt_x"/>
+                                          </p:val>
+                                        </p:tav>
+                                      </p:tavLst>
+                                    </p:anim>
+                                    <p:anim calcmode="lin" valueType="num">
+                                      <p:cBhvr additive="base">
+                                        <p:cTn id="20" dur="500" fill="hold"/>
+                                        <p:tgtEl>
+                                          <p:spTgt spid="42"/>
+                                        </p:tgtEl>
+                                        <p:attrNameLst>
+                                          <p:attrName>ppt_y</p:attrName>
+                                        </p:attrNameLst>
+                                      </p:cBhvr>
+                                      <p:tavLst>
+                                        <p:tav tm="0">
+                                          <p:val>
+                                            <p:strVal val="1+#ppt_h/2"/>
+                                          </p:val>
+                                        </p:tav>
+                                        <p:tav tm="100000">
+                                          <p:val>
+                                            <p:strVal val="#ppt_y"/>
+                                          </p:val>
+                                        </p:tav>
+                                      </p:tavLst>
+                                    </p:anim>
+                                  </p:childTnLst>
+                                </p:cTn>
+                              </p:par>
+                              <p:par>
+                                <p:cTn id="21" presetID="2" presetClass="entr" presetSubtype="4" fill="hold" nodeType="withEffect">
+                                  <p:stCondLst>
+                                    <p:cond delay="0"/>
+                                  </p:stCondLst>
+                                  <p:childTnLst>
+                                    <p:set>
+                                      <p:cBhvr>
+                                        <p:cTn id="22" dur="1" fill="hold">
+                                          <p:stCondLst>
+                                            <p:cond delay="0"/>
+                                          </p:stCondLst>
+                                        </p:cTn>
+                                        <p:tgtEl>
+                                          <p:spTgt spid="38"/>
+                                        </p:tgtEl>
+                                        <p:attrNameLst>
+                                          <p:attrName>style.visibility</p:attrName>
+                                        </p:attrNameLst>
+                                      </p:cBhvr>
+                                      <p:to>
+                                        <p:strVal val="visible"/>
+                                      </p:to>
+                                    </p:set>
+                                    <p:anim calcmode="lin" valueType="num">
+                                      <p:cBhvr additive="base">
+                                        <p:cTn id="23" dur="500" fill="hold"/>
+                                        <p:tgtEl>
+                                          <p:spTgt spid="38"/>
+                                        </p:tgtEl>
+                                        <p:attrNameLst>
+                                          <p:attrName>ppt_x</p:attrName>
+                                        </p:attrNameLst>
+                                      </p:cBhvr>
+                                      <p:tavLst>
+                                        <p:tav tm="0">
+                                          <p:val>
+                                            <p:strVal val="#ppt_x"/>
+                                          </p:val>
+                                        </p:tav>
+                                        <p:tav tm="100000">
+                                          <p:val>
+                                            <p:strVal val="#ppt_x"/>
+                                          </p:val>
+                                        </p:tav>
+                                      </p:tavLst>
+                                    </p:anim>
+                                    <p:anim calcmode="lin" valueType="num">
+                                      <p:cBhvr additive="base">
+                                        <p:cTn id="24" dur="500" fill="hold"/>
+                                        <p:tgtEl>
+                                          <p:spTgt spid="38"/>
+                                        </p:tgtEl>
+                                        <p:attrNameLst>
+                                          <p:attrName>ppt_y</p:attrName>
+                                        </p:attrNameLst>
+                                      </p:cBhvr>
+                                      <p:tavLst>
+                                        <p:tav tm="0">
+                                          <p:val>
+                                            <p:strVal val="1+#ppt_h/2"/>
+                                          </p:val>
+                                        </p:tav>
+                                        <p:tav tm="100000">
+                                          <p:val>
+                                            <p:strVal val="#ppt_y"/>
+                                          </p:val>
+                                        </p:tav>
+                                      </p:tavLst>
+                                    </p:anim>
+                                  </p:childTnLst>
+                                </p:cTn>
+                              </p:par>
+                              <p:par>
+                                <p:cTn id="25" presetID="2" presetClass="entr" presetSubtype="4" fill="hold" nodeType="withEffect">
+                                  <p:stCondLst>
+                                    <p:cond delay="0"/>
+                                  </p:stCondLst>
+                                  <p:childTnLst>
+                                    <p:set>
+                                      <p:cBhvr>
+                                        <p:cTn id="26" dur="1" fill="hold">
+                                          <p:stCondLst>
+                                            <p:cond delay="0"/>
+                                          </p:stCondLst>
+                                        </p:cTn>
+                                        <p:tgtEl>
+                                          <p:spTgt spid="28"/>
+                                        </p:tgtEl>
+                                        <p:attrNameLst>
+                                          <p:attrName>style.visibility</p:attrName>
+                                        </p:attrNameLst>
+                                      </p:cBhvr>
+                                      <p:to>
+                                        <p:strVal val="visible"/>
+                                      </p:to>
+                                    </p:set>
+                                    <p:anim calcmode="lin" valueType="num">
+                                      <p:cBhvr additive="base">
+                                        <p:cTn id="27" dur="500" fill="hold"/>
+                                        <p:tgtEl>
+                                          <p:spTgt spid="28"/>
+                                        </p:tgtEl>
+                                        <p:attrNameLst>
+                                          <p:attrName>ppt_x</p:attrName>
+                                        </p:attrNameLst>
+                                      </p:cBhvr>
+                                      <p:tavLst>
+                                        <p:tav tm="0">
+                                          <p:val>
+                                            <p:strVal val="#ppt_x"/>
+                                          </p:val>
+                                        </p:tav>
+                                        <p:tav tm="100000">
+                                          <p:val>
+                                            <p:strVal val="#ppt_x"/>
+                                          </p:val>
+                                        </p:tav>
+                                      </p:tavLst>
+                                    </p:anim>
+                                    <p:anim calcmode="lin" valueType="num">
+                                      <p:cBhvr additive="base">
+                                        <p:cTn id="28" dur="500" fill="hold"/>
+                                        <p:tgtEl>
+                                          <p:spTgt spid="28"/>
+                                        </p:tgtEl>
+                                        <p:attrNameLst>
+                                          <p:attrName>ppt_y</p:attrName>
+                                        </p:attrNameLst>
+                                      </p:cBhvr>
+                                      <p:tavLst>
+                                        <p:tav tm="0">
+                                          <p:val>
+                                            <p:strVal val="1+#ppt_h/2"/>
+                                          </p:val>
+                                        </p:tav>
+                                        <p:tav tm="100000">
+                                          <p:val>
+                                            <p:strVal val="#ppt_y"/>
+                                          </p:val>
+                                        </p:tav>
+                                      </p:tavLst>
+                                    </p:anim>
+                                  </p:childTnLst>
+                                </p:cTn>
+                              </p:par>
+                              <p:par>
+                                <p:cTn id="29" presetID="2" presetClass="entr" presetSubtype="4" fill="hold" nodeType="withEffect">
+                                  <p:stCondLst>
+                                    <p:cond delay="0"/>
+                                  </p:stCondLst>
+                                  <p:childTnLst>
+                                    <p:set>
+                                      <p:cBhvr>
+                                        <p:cTn id="30" dur="1" fill="hold">
+                                          <p:stCondLst>
+                                            <p:cond delay="0"/>
+                                          </p:stCondLst>
+                                        </p:cTn>
+                                        <p:tgtEl>
+                                          <p:spTgt spid="30"/>
+                                        </p:tgtEl>
+                                        <p:attrNameLst>
+                                          <p:attrName>style.visibility</p:attrName>
+                                        </p:attrNameLst>
+                                      </p:cBhvr>
+                                      <p:to>
+                                        <p:strVal val="visible"/>
+                                      </p:to>
+                                    </p:set>
+                                    <p:anim calcmode="lin" valueType="num">
+                                      <p:cBhvr additive="base">
+                                        <p:cTn id="31" dur="500" fill="hold"/>
+                                        <p:tgtEl>
+                                          <p:spTgt spid="30"/>
+                                        </p:tgtEl>
+                                        <p:attrNameLst>
+                                          <p:attrName>ppt_x</p:attrName>
+                                        </p:attrNameLst>
+                                      </p:cBhvr>
+                                      <p:tavLst>
+                                        <p:tav tm="0">
+                                          <p:val>
+                                            <p:strVal val="#ppt_x"/>
+                                          </p:val>
+                                        </p:tav>
+                                        <p:tav tm="100000">
+                                          <p:val>
+                                            <p:strVal val="#ppt_x"/>
+                                          </p:val>
+                                        </p:tav>
+                                      </p:tavLst>
+                                    </p:anim>
+                                    <p:anim calcmode="lin" valueType="num">
+                                      <p:cBhvr additive="base">
+                                        <p:cTn id="32" dur="500" fill="hold"/>
+                                        <p:tgtEl>
+                                          <p:spTgt spid="30"/>
+                                        </p:tgtEl>
+                                        <p:attrNameLst>
+                                          <p:attrName>ppt_y</p:attrName>
+                                        </p:attrNameLst>
+                                      </p:cBhvr>
+                                      <p:tavLst>
+                                        <p:tav tm="0">
+                                          <p:val>
+                                            <p:strVal val="1+#ppt_h/2"/>
+                                          </p:val>
+                                        </p:tav>
+                                        <p:tav tm="100000">
+                                          <p:val>
+                                            <p:strVal val="#ppt_y"/>
+                                          </p:val>
+                                        </p:tav>
+                                      </p:tavLst>
+                                    </p:anim>
+                                  </p:childTnLst>
+                                </p:cTn>
+                              </p:par>
+                              <p:par>
+                                <p:cTn id="33" presetID="2" presetClass="entr" presetSubtype="4" fill="hold" nodeType="withEffect">
+                                  <p:stCondLst>
+                                    <p:cond delay="0"/>
+                                  </p:stCondLst>
+                                  <p:childTnLst>
+                                    <p:set>
+                                      <p:cBhvr>
+                                        <p:cTn id="34" dur="1" fill="hold">
+                                          <p:stCondLst>
+                                            <p:cond delay="0"/>
+                                          </p:stCondLst>
+                                        </p:cTn>
+                                        <p:tgtEl>
+                                          <p:spTgt spid="40"/>
+                                        </p:tgtEl>
+                                        <p:attrNameLst>
+                                          <p:attrName>style.visibility</p:attrName>
+                                        </p:attrNameLst>
+                                      </p:cBhvr>
+                                      <p:to>
+                                        <p:strVal val="visible"/>
+                                      </p:to>
+                                    </p:set>
+                                    <p:anim calcmode="lin" valueType="num">
+                                      <p:cBhvr additive="base">
+                                        <p:cTn id="35" dur="500" fill="hold"/>
+                                        <p:tgtEl>
+                                          <p:spTgt spid="40"/>
+                                        </p:tgtEl>
+                                        <p:attrNameLst>
+                                          <p:attrName>ppt_x</p:attrName>
+                                        </p:attrNameLst>
+                                      </p:cBhvr>
+                                      <p:tavLst>
+                                        <p:tav tm="0">
+                                          <p:val>
+                                            <p:strVal val="#ppt_x"/>
+                                          </p:val>
+                                        </p:tav>
+                                        <p:tav tm="100000">
+                                          <p:val>
+                                            <p:strVal val="#ppt_x"/>
+                                          </p:val>
+                                        </p:tav>
+                                      </p:tavLst>
+                                    </p:anim>
+                                    <p:anim calcmode="lin" valueType="num">
+                                      <p:cBhvr additive="base">
+                                        <p:cTn id="36" dur="500" fill="hold"/>
+                                        <p:tgtEl>
+                                          <p:spTgt spid="40"/>
+                                        </p:tgtEl>
+                                        <p:attrNameLst>
+                                          <p:attrName>ppt_y</p:attrName>
+                                        </p:attrNameLst>
+                                      </p:cBhvr>
+                                      <p:tavLst>
+                                        <p:tav tm="0">
+                                          <p:val>
+                                            <p:strVal val="1+#ppt_h/2"/>
+                                          </p:val>
+                                        </p:tav>
+                                        <p:tav tm="100000">
+                                          <p:val>
+                                            <p:strVal val="#ppt_y"/>
+                                          </p:val>
+                                        </p:tav>
+                                      </p:tavLst>
+                                    </p:anim>
+                                  </p:childTnLst>
+                                </p:cTn>
+                              </p:par>
+                              <p:par>
+                                <p:cTn id="37" presetID="2" presetClass="entr" presetSubtype="4" fill="hold" nodeType="withEffect">
+                                  <p:stCondLst>
+                                    <p:cond delay="0"/>
+                                  </p:stCondLst>
+                                  <p:childTnLst>
+                                    <p:set>
+                                      <p:cBhvr>
+                                        <p:cTn id="38" dur="1" fill="hold">
+                                          <p:stCondLst>
+                                            <p:cond delay="0"/>
+                                          </p:stCondLst>
+                                        </p:cTn>
+                                        <p:tgtEl>
+                                          <p:spTgt spid="26"/>
+                                        </p:tgtEl>
+                                        <p:attrNameLst>
+                                          <p:attrName>style.visibility</p:attrName>
+                                        </p:attrNameLst>
+                                      </p:cBhvr>
+                                      <p:to>
+                                        <p:strVal val="visible"/>
+                                      </p:to>
+                                    </p:set>
+                                    <p:anim calcmode="lin" valueType="num">
+                                      <p:cBhvr additive="base">
+                                        <p:cTn id="39" dur="500" fill="hold"/>
+                                        <p:tgtEl>
+                                          <p:spTgt spid="26"/>
+                                        </p:tgtEl>
+                                        <p:attrNameLst>
+                                          <p:attrName>ppt_x</p:attrName>
+                                        </p:attrNameLst>
+                                      </p:cBhvr>
+                                      <p:tavLst>
+                                        <p:tav tm="0">
+                                          <p:val>
+                                            <p:strVal val="#ppt_x"/>
+                                          </p:val>
+                                        </p:tav>
+                                        <p:tav tm="100000">
+                                          <p:val>
+                                            <p:strVal val="#ppt_x"/>
+                                          </p:val>
+                                        </p:tav>
+                                      </p:tavLst>
+                                    </p:anim>
+                                    <p:anim calcmode="lin" valueType="num">
+                                      <p:cBhvr additive="base">
+                                        <p:cTn id="40" dur="500" fill="hold"/>
+                                        <p:tgtEl>
+                                          <p:spTgt spid="26"/>
+                                        </p:tgtEl>
+                                        <p:attrNameLst>
+                                          <p:attrName>ppt_y</p:attrName>
+                                        </p:attrNameLst>
+                                      </p:cBhvr>
+                                      <p:tavLst>
+                                        <p:tav tm="0">
+                                          <p:val>
+                                            <p:strVal val="1+#ppt_h/2"/>
+                                          </p:val>
+                                        </p:tav>
+                                        <p:tav tm="100000">
+                                          <p:val>
+                                            <p:strVal val="#ppt_y"/>
+                                          </p:val>
+                                        </p:tav>
+                                      </p:tavLst>
+                                    </p:anim>
+                                  </p:childTnLst>
+                                </p:cTn>
+                              </p:par>
+                              <p:par>
+                                <p:cTn id="41" presetID="2" presetClass="entr" presetSubtype="4" fill="hold" nodeType="withEffect">
+                                  <p:stCondLst>
+                                    <p:cond delay="0"/>
+                                  </p:stCondLst>
+                                  <p:childTnLst>
+                                    <p:set>
+                                      <p:cBhvr>
+                                        <p:cTn id="42" dur="1" fill="hold">
+                                          <p:stCondLst>
+                                            <p:cond delay="0"/>
+                                          </p:stCondLst>
+                                        </p:cTn>
+                                        <p:tgtEl>
+                                          <p:spTgt spid="36"/>
+                                        </p:tgtEl>
+                                        <p:attrNameLst>
+                                          <p:attrName>style.visibility</p:attrName>
+                                        </p:attrNameLst>
+                                      </p:cBhvr>
+                                      <p:to>
+                                        <p:strVal val="visible"/>
+                                      </p:to>
+                                    </p:set>
+                                    <p:anim calcmode="lin" valueType="num">
+                                      <p:cBhvr additive="base">
+                                        <p:cTn id="43" dur="500" fill="hold"/>
+                                        <p:tgtEl>
+                                          <p:spTgt spid="36"/>
+                                        </p:tgtEl>
+                                        <p:attrNameLst>
+                                          <p:attrName>ppt_x</p:attrName>
+                                        </p:attrNameLst>
+                                      </p:cBhvr>
+                                      <p:tavLst>
+                                        <p:tav tm="0">
+                                          <p:val>
+                                            <p:strVal val="#ppt_x"/>
+                                          </p:val>
+                                        </p:tav>
+                                        <p:tav tm="100000">
+                                          <p:val>
+                                            <p:strVal val="#ppt_x"/>
+                                          </p:val>
+                                        </p:tav>
+                                      </p:tavLst>
+                                    </p:anim>
+                                    <p:anim calcmode="lin" valueType="num">
+                                      <p:cBhvr additive="base">
+                                        <p:cTn id="44" dur="500" fill="hold"/>
+                                        <p:tgtEl>
+                                          <p:spTgt spid="36"/>
+                                        </p:tgtEl>
+                                        <p:attrNameLst>
+                                          <p:attrName>ppt_y</p:attrName>
+                                        </p:attrNameLst>
+                                      </p:cBhvr>
+                                      <p:tavLst>
+                                        <p:tav tm="0">
+                                          <p:val>
+                                            <p:strVal val="1+#ppt_h/2"/>
+                                          </p:val>
+                                        </p:tav>
+                                        <p:tav tm="100000">
+                                          <p:val>
+                                            <p:strVal val="#ppt_y"/>
+                                          </p:val>
+                                        </p:tav>
+                                      </p:tavLst>
+                                    </p:anim>
+                                  </p:childTnLst>
+                                </p:cTn>
+                              </p:par>
+                              <p:par>
+                                <p:cTn id="45" presetID="2" presetClass="entr" presetSubtype="4" fill="hold" nodeType="withEffect">
+                                  <p:stCondLst>
+                                    <p:cond delay="0"/>
+                                  </p:stCondLst>
+                                  <p:childTnLst>
+                                    <p:set>
+                                      <p:cBhvr>
+                                        <p:cTn id="46" dur="1" fill="hold">
+                                          <p:stCondLst>
+                                            <p:cond delay="0"/>
+                                          </p:stCondLst>
+                                        </p:cTn>
+                                        <p:tgtEl>
+                                          <p:spTgt spid="32"/>
+                                        </p:tgtEl>
+                                        <p:attrNameLst>
+                                          <p:attrName>style.visibility</p:attrName>
+                                        </p:attrNameLst>
+                                      </p:cBhvr>
+                                      <p:to>
+                                        <p:strVal val="visible"/>
+                                      </p:to>
+                                    </p:set>
+                                    <p:anim calcmode="lin" valueType="num">
+                                      <p:cBhvr additive="base">
+                                        <p:cTn id="47" dur="500" fill="hold"/>
+                                        <p:tgtEl>
+                                          <p:spTgt spid="32"/>
+                                        </p:tgtEl>
+                                        <p:attrNameLst>
+                                          <p:attrName>ppt_x</p:attrName>
+                                        </p:attrNameLst>
+                                      </p:cBhvr>
+                                      <p:tavLst>
+                                        <p:tav tm="0">
+                                          <p:val>
+                                            <p:strVal val="#ppt_x"/>
+                                          </p:val>
+                                        </p:tav>
+                                        <p:tav tm="100000">
+                                          <p:val>
+                                            <p:strVal val="#ppt_x"/>
+                                          </p:val>
+                                        </p:tav>
+                                      </p:tavLst>
+                                    </p:anim>
+                                    <p:anim calcmode="lin" valueType="num">
+                                      <p:cBhvr additive="base">
+                                        <p:cTn id="48" dur="500" fill="hold"/>
+                                        <p:tgtEl>
+                                          <p:spTgt spid="32"/>
+                                        </p:tgtEl>
+                                        <p:attrNameLst>
+                                          <p:attrName>ppt_y</p:attrName>
+                                        </p:attrNameLst>
+                                      </p:cBhvr>
+                                      <p:tavLst>
+                                        <p:tav tm="0">
+                                          <p:val>
+                                            <p:strVal val="1+#ppt_h/2"/>
+                                          </p:val>
+                                        </p:tav>
+                                        <p:tav tm="100000">
+                                          <p:val>
+                                            <p:strVal val="#ppt_y"/>
+                                          </p:val>
+                                        </p:tav>
+                                      </p:tavLst>
+                                    </p:anim>
+                                  </p:childTnLst>
+                                </p:cTn>
+                              </p:par>
+                              <p:par>
+                                <p:cTn id="49" presetID="2" presetClass="entr" presetSubtype="4" fill="hold" nodeType="withEffect">
+                                  <p:stCondLst>
+                                    <p:cond delay="0"/>
+                                  </p:stCondLst>
+                                  <p:childTnLst>
+                                    <p:set>
+                                      <p:cBhvr>
+                                        <p:cTn id="50" dur="1" fill="hold">
+                                          <p:stCondLst>
+                                            <p:cond delay="0"/>
+                                          </p:stCondLst>
+                                        </p:cTn>
+                                        <p:tgtEl>
+                                          <p:spTgt spid="44"/>
+                                        </p:tgtEl>
+                                        <p:attrNameLst>
+                                          <p:attrName>style.visibility</p:attrName>
+                                        </p:attrNameLst>
+                                      </p:cBhvr>
+                                      <p:to>
+                                        <p:strVal val="visible"/>
+                                      </p:to>
+                                    </p:set>
+                                    <p:anim calcmode="lin" valueType="num">
+                                      <p:cBhvr additive="base">
+                                        <p:cTn id="51" dur="500" fill="hold"/>
+                                        <p:tgtEl>
+                                          <p:spTgt spid="44"/>
+                                        </p:tgtEl>
+                                        <p:attrNameLst>
+                                          <p:attrName>ppt_x</p:attrName>
+                                        </p:attrNameLst>
+                                      </p:cBhvr>
+                                      <p:tavLst>
+                                        <p:tav tm="0">
+                                          <p:val>
+                                            <p:strVal val="#ppt_x"/>
+                                          </p:val>
+                                        </p:tav>
+                                        <p:tav tm="100000">
+                                          <p:val>
+                                            <p:strVal val="#ppt_x"/>
+                                          </p:val>
+                                        </p:tav>
+                                      </p:tavLst>
+                                    </p:anim>
+                                    <p:anim calcmode="lin" valueType="num">
+                                      <p:cBhvr additive="base">
+                                        <p:cTn id="52" dur="500" fill="hold"/>
+                                        <p:tgtEl>
+                                          <p:spTgt spid="44"/>
+                                        </p:tgtEl>
+                                        <p:attrNameLst>
+                                          <p:attrName>ppt_y</p:attrName>
+                                        </p:attrNameLst>
+                                      </p:cBhvr>
+                                      <p:tavLst>
+                                        <p:tav tm="0">
+                                          <p:val>
+                                            <p:strVal val="1+#ppt_h/2"/>
+                                          </p:val>
+                                        </p:tav>
+                                        <p:tav tm="100000">
+                                          <p:val>
+                                            <p:strVal val="#ppt_y"/>
+                                          </p:val>
+                                        </p:tav>
+                                      </p:tavLst>
+                                    </p:anim>
+                                  </p:childTnLst>
+                                </p:cTn>
+                              </p:par>
+                            </p:childTnLst>
+                          </p:cTn>
+                        </p:par>
+                      </p:childTnLst>
+                    </p:cTn>
+                  </p:par>
+                </p:childTnLst>
+              </p:cTn>
+              <p:prevCondLst>
+                <p:cond evt="onPrev" delay="0">
+                  <p:tgtEl>
+                    <p:sldTgt/>
+                  </p:tgtEl>
+                </p:cond>
+              </p:prevCondLst>
+              <p:nextCondLst>
+                <p:cond evt="onNext" delay="0">
+                  <p:tgtEl>
+                    <p:sldTgt/>
+                  </p:tgtEl>
+                </p:cond>
+              </p:nextCondLst>
+            </p:seq>
+          </p:childTnLst>
+        </p:cTn>
+      </p:par>
+    </p:tnLst>
+  </p:timing>
+</p:sld>
+</file>
+
+<file path=ppt/slides/slide11.xml><?xml version="1.0" encoding="utf-8"?>
+<p:sld xmlns:a="http://schemas.openxmlformats.org/drawingml/2006/main" xmlns:r="http://schemas.openxmlformats.org/officeDocument/2006/relationships" xmlns:p="http://schemas.openxmlformats.org/presentationml/2006/main">
+  <p:cSld>
+    <p:spTree>
+      <p:nvGrpSpPr>
+        <p:cNvPr id="1" name=""/>
+        <p:cNvGrpSpPr/>
+        <p:nvPr/>
+      </p:nvGrpSpPr>
+      <p:grpSpPr>
+        <a:xfrm>
+          <a:off x="0" y="0"/>
+          <a:ext cx="0" cy="0"/>
+          <a:chOff x="0" y="0"/>
+          <a:chExt cx="0" cy="0"/>
+        </a:xfrm>
+      </p:grpSpPr>
+      <p:sp>
+        <p:nvSpPr>
+          <p:cNvPr id="2" name="Titolo 1">
+            <a:extLst>
+              <a:ext uri="{FF2B5EF4-FFF2-40B4-BE49-F238E27FC236}">
                 <a16:creationId xmlns:a16="http://schemas.microsoft.com/office/drawing/2014/main" id="{D7801592-9091-B6BB-BCF7-AC7640166F9F}"/>
               </a:ext>
             </a:extLst>
@@ -7569,466 +8914,6 @@
 </p:sld>
 </file>
 
-<file path=ppt/slides/slide11.xml><?xml version="1.0" encoding="utf-8"?>
-<p:sld xmlns:a="http://schemas.openxmlformats.org/drawingml/2006/main" xmlns:r="http://schemas.openxmlformats.org/officeDocument/2006/relationships" xmlns:p="http://schemas.openxmlformats.org/presentationml/2006/main">
-  <p:cSld>
-    <p:spTree>
-      <p:nvGrpSpPr>
-        <p:cNvPr id="1" name=""/>
-        <p:cNvGrpSpPr/>
-        <p:nvPr/>
-      </p:nvGrpSpPr>
-      <p:grpSpPr>
-        <a:xfrm>
-          <a:off x="0" y="0"/>
-          <a:ext cx="0" cy="0"/>
-          <a:chOff x="0" y="0"/>
-          <a:chExt cx="0" cy="0"/>
-        </a:xfrm>
-      </p:grpSpPr>
-      <p:sp>
-        <p:nvSpPr>
-          <p:cNvPr id="2" name="Titolo 1">
-            <a:extLst>
-              <a:ext uri="{FF2B5EF4-FFF2-40B4-BE49-F238E27FC236}">
-                <a16:creationId xmlns:a16="http://schemas.microsoft.com/office/drawing/2014/main" id="{E37A1EEA-6AF2-7B2F-FC04-0640DADB58C3}"/>
-              </a:ext>
-            </a:extLst>
-          </p:cNvPr>
-          <p:cNvSpPr>
-            <a:spLocks noGrp="1"/>
-          </p:cNvSpPr>
-          <p:nvPr>
-            <p:ph type="title"/>
-          </p:nvPr>
-        </p:nvSpPr>
-        <p:spPr/>
-        <p:txBody>
-          <a:bodyPr/>
-          <a:lstStyle/>
-          <a:p>
-            <a:pPr algn="ctr"/>
-            <a:r>
-              <a:rPr lang="it-IT" dirty="0"/>
-              <a:t>Struttura </a:t>
-            </a:r>
-            <a:r>
-              <a:rPr lang="it-IT" dirty="0" err="1"/>
-              <a:t>DataBase</a:t>
-            </a:r>
-            <a:r>
-              <a:rPr lang="it-IT" dirty="0"/>
-              <a:t> SQL</a:t>
-            </a:r>
-          </a:p>
-        </p:txBody>
-      </p:sp>
-      <p:pic>
-        <p:nvPicPr>
-          <p:cNvPr id="4" name="Immagine 3" descr="Immagine che contiene testo, schermata, Carattere, linea&#10;&#10;Il contenuto generato dall'IA potrebbe non essere corretto.">
-            <a:extLst>
-              <a:ext uri="{FF2B5EF4-FFF2-40B4-BE49-F238E27FC236}">
-                <a16:creationId xmlns:a16="http://schemas.microsoft.com/office/drawing/2014/main" id="{3A88FB4C-CC61-BC27-1DBC-EBF02223BC0C}"/>
-              </a:ext>
-            </a:extLst>
-          </p:cNvPr>
-          <p:cNvPicPr>
-            <a:picLocks noChangeAspect="1"/>
-          </p:cNvPicPr>
-          <p:nvPr/>
-        </p:nvPicPr>
-        <p:blipFill>
-          <a:blip r:embed="rId2"/>
-          <a:stretch>
-            <a:fillRect/>
-          </a:stretch>
-        </p:blipFill>
-        <p:spPr>
-          <a:xfrm>
-            <a:off x="2450475" y="997820"/>
-            <a:ext cx="4243048" cy="1367388"/>
-          </a:xfrm>
-          <a:prstGeom prst="rect">
-            <a:avLst/>
-          </a:prstGeom>
-        </p:spPr>
-      </p:pic>
-      <p:pic>
-        <p:nvPicPr>
-          <p:cNvPr id="6" name="Immagine 5" descr="Immagine che contiene testo, schermata, Carattere, linea&#10;&#10;Il contenuto generato dall'IA potrebbe non essere corretto.">
-            <a:extLst>
-              <a:ext uri="{FF2B5EF4-FFF2-40B4-BE49-F238E27FC236}">
-                <a16:creationId xmlns:a16="http://schemas.microsoft.com/office/drawing/2014/main" id="{A31ABDCE-E2A6-EA34-D785-76A91AE119E6}"/>
-              </a:ext>
-            </a:extLst>
-          </p:cNvPr>
-          <p:cNvPicPr>
-            <a:picLocks noChangeAspect="1"/>
-          </p:cNvPicPr>
-          <p:nvPr/>
-        </p:nvPicPr>
-        <p:blipFill>
-          <a:blip r:embed="rId3"/>
-          <a:stretch>
-            <a:fillRect/>
-          </a:stretch>
-        </p:blipFill>
-        <p:spPr>
-          <a:xfrm>
-            <a:off x="2805621" y="2363907"/>
-            <a:ext cx="3289018" cy="1292661"/>
-          </a:xfrm>
-          <a:prstGeom prst="rect">
-            <a:avLst/>
-          </a:prstGeom>
-        </p:spPr>
-      </p:pic>
-      <p:pic>
-        <p:nvPicPr>
-          <p:cNvPr id="8" name="Immagine 7" descr="Immagine che contiene testo, schermata, Carattere, numero&#10;&#10;Il contenuto generato dall'IA potrebbe non essere corretto.">
-            <a:extLst>
-              <a:ext uri="{FF2B5EF4-FFF2-40B4-BE49-F238E27FC236}">
-                <a16:creationId xmlns:a16="http://schemas.microsoft.com/office/drawing/2014/main" id="{E420661F-4F64-BDA6-6746-3E208A6A7A0B}"/>
-              </a:ext>
-            </a:extLst>
-          </p:cNvPr>
-          <p:cNvPicPr>
-            <a:picLocks noChangeAspect="1"/>
-          </p:cNvPicPr>
-          <p:nvPr/>
-        </p:nvPicPr>
-        <p:blipFill>
-          <a:blip r:embed="rId4"/>
-          <a:stretch>
-            <a:fillRect/>
-          </a:stretch>
-        </p:blipFill>
-        <p:spPr>
-          <a:xfrm>
-            <a:off x="3001506" y="3656568"/>
-            <a:ext cx="2897247" cy="1401459"/>
-          </a:xfrm>
-          <a:prstGeom prst="rect">
-            <a:avLst/>
-          </a:prstGeom>
-        </p:spPr>
-      </p:pic>
-    </p:spTree>
-    <p:extLst>
-      <p:ext uri="{BB962C8B-B14F-4D97-AF65-F5344CB8AC3E}">
-        <p14:creationId xmlns:p14="http://schemas.microsoft.com/office/powerpoint/2010/main" val="622900377"/>
-      </p:ext>
-    </p:extLst>
-  </p:cSld>
-  <p:clrMapOvr>
-    <a:masterClrMapping/>
-  </p:clrMapOvr>
-  <p:timing>
-    <p:tnLst>
-      <p:par>
-        <p:cTn id="1" dur="indefinite" restart="never" nodeType="tmRoot">
-          <p:childTnLst>
-            <p:seq concurrent="1" nextAc="seek">
-              <p:cTn id="2" dur="indefinite" nodeType="mainSeq">
-                <p:childTnLst>
-                  <p:par>
-                    <p:cTn id="3" fill="hold">
-                      <p:stCondLst>
-                        <p:cond delay="indefinite"/>
-                      </p:stCondLst>
-                      <p:childTnLst>
-                        <p:par>
-                          <p:cTn id="4" fill="hold">
-                            <p:stCondLst>
-                              <p:cond delay="0"/>
-                            </p:stCondLst>
-                            <p:childTnLst>
-                              <p:par>
-                                <p:cTn id="5" presetID="2" presetClass="entr" presetSubtype="4" fill="hold" nodeType="clickEffect">
-                                  <p:stCondLst>
-                                    <p:cond delay="0"/>
-                                  </p:stCondLst>
-                                  <p:childTnLst>
-                                    <p:set>
-                                      <p:cBhvr>
-                                        <p:cTn id="6" dur="1" fill="hold">
-                                          <p:stCondLst>
-                                            <p:cond delay="0"/>
-                                          </p:stCondLst>
-                                        </p:cTn>
-                                        <p:tgtEl>
-                                          <p:spTgt spid="4"/>
-                                        </p:tgtEl>
-                                        <p:attrNameLst>
-                                          <p:attrName>style.visibility</p:attrName>
-                                        </p:attrNameLst>
-                                      </p:cBhvr>
-                                      <p:to>
-                                        <p:strVal val="visible"/>
-                                      </p:to>
-                                    </p:set>
-                                    <p:anim calcmode="lin" valueType="num">
-                                      <p:cBhvr additive="base">
-                                        <p:cTn id="7" dur="500" fill="hold"/>
-                                        <p:tgtEl>
-                                          <p:spTgt spid="4"/>
-                                        </p:tgtEl>
-                                        <p:attrNameLst>
-                                          <p:attrName>ppt_x</p:attrName>
-                                        </p:attrNameLst>
-                                      </p:cBhvr>
-                                      <p:tavLst>
-                                        <p:tav tm="0">
-                                          <p:val>
-                                            <p:strVal val="#ppt_x"/>
-                                          </p:val>
-                                        </p:tav>
-                                        <p:tav tm="100000">
-                                          <p:val>
-                                            <p:strVal val="#ppt_x"/>
-                                          </p:val>
-                                        </p:tav>
-                                      </p:tavLst>
-                                    </p:anim>
-                                    <p:anim calcmode="lin" valueType="num">
-                                      <p:cBhvr additive="base">
-                                        <p:cTn id="8" dur="500" fill="hold"/>
-                                        <p:tgtEl>
-                                          <p:spTgt spid="4"/>
-                                        </p:tgtEl>
-                                        <p:attrNameLst>
-                                          <p:attrName>ppt_y</p:attrName>
-                                        </p:attrNameLst>
-                                      </p:cBhvr>
-                                      <p:tavLst>
-                                        <p:tav tm="0">
-                                          <p:val>
-                                            <p:strVal val="1+#ppt_h/2"/>
-                                          </p:val>
-                                        </p:tav>
-                                        <p:tav tm="100000">
-                                          <p:val>
-                                            <p:strVal val="#ppt_y"/>
-                                          </p:val>
-                                        </p:tav>
-                                      </p:tavLst>
-                                    </p:anim>
-                                  </p:childTnLst>
-                                </p:cTn>
-                              </p:par>
-                            </p:childTnLst>
-                          </p:cTn>
-                        </p:par>
-                      </p:childTnLst>
-                    </p:cTn>
-                  </p:par>
-                  <p:par>
-                    <p:cTn id="9" fill="hold">
-                      <p:stCondLst>
-                        <p:cond delay="indefinite"/>
-                      </p:stCondLst>
-                      <p:childTnLst>
-                        <p:par>
-                          <p:cTn id="10" fill="hold">
-                            <p:stCondLst>
-                              <p:cond delay="0"/>
-                            </p:stCondLst>
-                            <p:childTnLst>
-                              <p:par>
-                                <p:cTn id="11" presetID="2" presetClass="entr" presetSubtype="4" fill="hold" nodeType="clickEffect">
-                                  <p:stCondLst>
-                                    <p:cond delay="0"/>
-                                  </p:stCondLst>
-                                  <p:childTnLst>
-                                    <p:set>
-                                      <p:cBhvr>
-                                        <p:cTn id="12" dur="1" fill="hold">
-                                          <p:stCondLst>
-                                            <p:cond delay="0"/>
-                                          </p:stCondLst>
-                                        </p:cTn>
-                                        <p:tgtEl>
-                                          <p:spTgt spid="6"/>
-                                        </p:tgtEl>
-                                        <p:attrNameLst>
-                                          <p:attrName>style.visibility</p:attrName>
-                                        </p:attrNameLst>
-                                      </p:cBhvr>
-                                      <p:to>
-                                        <p:strVal val="visible"/>
-                                      </p:to>
-                                    </p:set>
-                                    <p:anim calcmode="lin" valueType="num">
-                                      <p:cBhvr additive="base">
-                                        <p:cTn id="13" dur="500" fill="hold"/>
-                                        <p:tgtEl>
-                                          <p:spTgt spid="6"/>
-                                        </p:tgtEl>
-                                        <p:attrNameLst>
-                                          <p:attrName>ppt_x</p:attrName>
-                                        </p:attrNameLst>
-                                      </p:cBhvr>
-                                      <p:tavLst>
-                                        <p:tav tm="0">
-                                          <p:val>
-                                            <p:strVal val="#ppt_x"/>
-                                          </p:val>
-                                        </p:tav>
-                                        <p:tav tm="100000">
-                                          <p:val>
-                                            <p:strVal val="#ppt_x"/>
-                                          </p:val>
-                                        </p:tav>
-                                      </p:tavLst>
-                                    </p:anim>
-                                    <p:anim calcmode="lin" valueType="num">
-                                      <p:cBhvr additive="base">
-                                        <p:cTn id="14" dur="500" fill="hold"/>
-                                        <p:tgtEl>
-                                          <p:spTgt spid="6"/>
-                                        </p:tgtEl>
-                                        <p:attrNameLst>
-                                          <p:attrName>ppt_y</p:attrName>
-                                        </p:attrNameLst>
-                                      </p:cBhvr>
-                                      <p:tavLst>
-                                        <p:tav tm="0">
-                                          <p:val>
-                                            <p:strVal val="1+#ppt_h/2"/>
-                                          </p:val>
-                                        </p:tav>
-                                        <p:tav tm="100000">
-                                          <p:val>
-                                            <p:strVal val="#ppt_y"/>
-                                          </p:val>
-                                        </p:tav>
-                                      </p:tavLst>
-                                    </p:anim>
-                                  </p:childTnLst>
-                                </p:cTn>
-                              </p:par>
-                            </p:childTnLst>
-                          </p:cTn>
-                        </p:par>
-                      </p:childTnLst>
-                    </p:cTn>
-                  </p:par>
-                  <p:par>
-                    <p:cTn id="15" fill="hold">
-                      <p:stCondLst>
-                        <p:cond delay="indefinite"/>
-                      </p:stCondLst>
-                      <p:childTnLst>
-                        <p:par>
-                          <p:cTn id="16" fill="hold">
-                            <p:stCondLst>
-                              <p:cond delay="0"/>
-                            </p:stCondLst>
-                            <p:childTnLst>
-                              <p:par>
-                                <p:cTn id="17" presetID="2" presetClass="entr" presetSubtype="4" fill="hold" nodeType="clickEffect">
-                                  <p:stCondLst>
-                                    <p:cond delay="0"/>
-                                  </p:stCondLst>
-                                  <p:childTnLst>
-                                    <p:set>
-                                      <p:cBhvr>
-                                        <p:cTn id="18" dur="1" fill="hold">
-                                          <p:stCondLst>
-                                            <p:cond delay="0"/>
-                                          </p:stCondLst>
-                                        </p:cTn>
-                                        <p:tgtEl>
-                                          <p:spTgt spid="8"/>
-                                        </p:tgtEl>
-                                        <p:attrNameLst>
-                                          <p:attrName>style.visibility</p:attrName>
-                                        </p:attrNameLst>
-                                      </p:cBhvr>
-                                      <p:to>
-                                        <p:strVal val="visible"/>
-                                      </p:to>
-                                    </p:set>
-                                    <p:anim calcmode="lin" valueType="num">
-                                      <p:cBhvr additive="base">
-                                        <p:cTn id="19" dur="500" fill="hold"/>
-                                        <p:tgtEl>
-                                          <p:spTgt spid="8"/>
-                                        </p:tgtEl>
-                                        <p:attrNameLst>
-                                          <p:attrName>ppt_x</p:attrName>
-                                        </p:attrNameLst>
-                                      </p:cBhvr>
-                                      <p:tavLst>
-                                        <p:tav tm="0">
-                                          <p:val>
-                                            <p:strVal val="#ppt_x"/>
-                                          </p:val>
-                                        </p:tav>
-                                        <p:tav tm="100000">
-                                          <p:val>
-                                            <p:strVal val="#ppt_x"/>
-                                          </p:val>
-                                        </p:tav>
-                                      </p:tavLst>
-                                    </p:anim>
-                                    <p:anim calcmode="lin" valueType="num">
-                                      <p:cBhvr additive="base">
-                                        <p:cTn id="20" dur="500" fill="hold"/>
-                                        <p:tgtEl>
-                                          <p:spTgt spid="8"/>
-                                        </p:tgtEl>
-                                        <p:attrNameLst>
-                                          <p:attrName>ppt_y</p:attrName>
-                                        </p:attrNameLst>
-                                      </p:cBhvr>
-                                      <p:tavLst>
-                                        <p:tav tm="0">
-                                          <p:val>
-                                            <p:strVal val="1+#ppt_h/2"/>
-                                          </p:val>
-                                        </p:tav>
-                                        <p:tav tm="100000">
-                                          <p:val>
-                                            <p:strVal val="#ppt_y"/>
-                                          </p:val>
-                                        </p:tav>
-                                      </p:tavLst>
-                                    </p:anim>
-                                  </p:childTnLst>
-                                </p:cTn>
-                              </p:par>
-                            </p:childTnLst>
-                          </p:cTn>
-                        </p:par>
-                      </p:childTnLst>
-                    </p:cTn>
-                  </p:par>
-                </p:childTnLst>
-              </p:cTn>
-              <p:prevCondLst>
-                <p:cond evt="onPrev" delay="0">
-                  <p:tgtEl>
-                    <p:sldTgt/>
-                  </p:tgtEl>
-                </p:cond>
-              </p:prevCondLst>
-              <p:nextCondLst>
-                <p:cond evt="onNext" delay="0">
-                  <p:tgtEl>
-                    <p:sldTgt/>
-                  </p:tgtEl>
-                </p:cond>
-              </p:nextCondLst>
-            </p:seq>
-          </p:childTnLst>
-        </p:cTn>
-      </p:par>
-    </p:tnLst>
-  </p:timing>
-</p:sld>
-</file>
-
 <file path=ppt/slides/slide12.xml><?xml version="1.0" encoding="utf-8"?>
 <p:sld xmlns:a="http://schemas.openxmlformats.org/drawingml/2006/main" xmlns:r="http://schemas.openxmlformats.org/officeDocument/2006/relationships" xmlns:p="http://schemas.openxmlformats.org/presentationml/2006/main">
   <p:cSld>
@@ -8609,6 +9494,120 @@
           <p:cNvPr id="2" name="Titolo 1">
             <a:extLst>
               <a:ext uri="{FF2B5EF4-FFF2-40B4-BE49-F238E27FC236}">
+                <a16:creationId xmlns:a16="http://schemas.microsoft.com/office/drawing/2014/main" id="{48C00AFA-9F53-B324-A036-AD8F56F30572}"/>
+              </a:ext>
+            </a:extLst>
+          </p:cNvPr>
+          <p:cNvSpPr>
+            <a:spLocks noGrp="1"/>
+          </p:cNvSpPr>
+          <p:nvPr>
+            <p:ph type="title"/>
+          </p:nvPr>
+        </p:nvSpPr>
+        <p:spPr/>
+        <p:txBody>
+          <a:bodyPr/>
+          <a:lstStyle/>
+          <a:p>
+            <a:r>
+              <a:rPr lang="it-IT" dirty="0" err="1"/>
+              <a:t>Backend</a:t>
+            </a:r>
+            <a:endParaRPr lang="it-IT" dirty="0"/>
+          </a:p>
+        </p:txBody>
+      </p:sp>
+      <p:sp>
+        <p:nvSpPr>
+          <p:cNvPr id="3" name="Segnaposto testo 2">
+            <a:extLst>
+              <a:ext uri="{FF2B5EF4-FFF2-40B4-BE49-F238E27FC236}">
+                <a16:creationId xmlns:a16="http://schemas.microsoft.com/office/drawing/2014/main" id="{A3F04B0C-6616-F8AA-BBE4-8A9E265F3476}"/>
+              </a:ext>
+            </a:extLst>
+          </p:cNvPr>
+          <p:cNvSpPr>
+            <a:spLocks noGrp="1"/>
+          </p:cNvSpPr>
+          <p:nvPr>
+            <p:ph type="body" idx="1"/>
+          </p:nvPr>
+        </p:nvSpPr>
+        <p:spPr/>
+        <p:txBody>
+          <a:bodyPr/>
+          <a:lstStyle/>
+          <a:p>
+            <a:pPr marL="114300" indent="0">
+              <a:buNone/>
+            </a:pPr>
+            <a:r>
+              <a:rPr lang="it-IT" dirty="0"/>
+              <a:t>Il ruolo del </a:t>
+            </a:r>
+            <a:r>
+              <a:rPr lang="it-IT" dirty="0" err="1"/>
+              <a:t>backend</a:t>
+            </a:r>
+            <a:r>
+              <a:rPr lang="it-IT" dirty="0"/>
+              <a:t> è quello di rendere utilizzabili i dati e permettere il funzionamento interattivo di app e portale web. Il </a:t>
+            </a:r>
+            <a:r>
+              <a:rPr lang="it-IT" dirty="0" err="1"/>
+              <a:t>DataBase</a:t>
+            </a:r>
+            <a:r>
+              <a:rPr lang="it-IT" dirty="0"/>
+              <a:t> creato </a:t>
+            </a:r>
+            <a:r>
+              <a:rPr lang="it-IT" dirty="0" err="1"/>
+              <a:t>imagazzina</a:t>
+            </a:r>
+            <a:r>
+              <a:rPr lang="it-IT" dirty="0"/>
+              <a:t> i dati e li rende fruibili agli utenti tramite l’uso di API. In pratica quando un utente si registra su app o sito i suoi dati vengono salvati sul Server e successivamente possono essere modificati o cancellati a seconda delle esigenze degli utenti.</a:t>
+            </a:r>
+          </a:p>
+        </p:txBody>
+      </p:sp>
+    </p:spTree>
+    <p:extLst>
+      <p:ext uri="{BB962C8B-B14F-4D97-AF65-F5344CB8AC3E}">
+        <p14:creationId xmlns:p14="http://schemas.microsoft.com/office/powerpoint/2010/main" val="427418339"/>
+      </p:ext>
+    </p:extLst>
+  </p:cSld>
+  <p:clrMapOvr>
+    <a:masterClrMapping/>
+  </p:clrMapOvr>
+</p:sld>
+</file>
+
+<file path=ppt/slides/slide15.xml><?xml version="1.0" encoding="utf-8"?>
+<p:sld xmlns:a="http://schemas.openxmlformats.org/drawingml/2006/main" xmlns:r="http://schemas.openxmlformats.org/officeDocument/2006/relationships" xmlns:p="http://schemas.openxmlformats.org/presentationml/2006/main">
+  <p:cSld>
+    <p:spTree>
+      <p:nvGrpSpPr>
+        <p:cNvPr id="1" name=""/>
+        <p:cNvGrpSpPr/>
+        <p:nvPr/>
+      </p:nvGrpSpPr>
+      <p:grpSpPr>
+        <a:xfrm>
+          <a:off x="0" y="0"/>
+          <a:ext cx="0" cy="0"/>
+          <a:chOff x="0" y="0"/>
+          <a:chExt cx="0" cy="0"/>
+        </a:xfrm>
+      </p:grpSpPr>
+      <p:sp>
+        <p:nvSpPr>
+          <p:cNvPr id="2" name="Titolo 1">
+            <a:extLst>
+              <a:ext uri="{FF2B5EF4-FFF2-40B4-BE49-F238E27FC236}">
                 <a16:creationId xmlns:a16="http://schemas.microsoft.com/office/drawing/2014/main" id="{3CD9EF37-8F27-BC8E-AAF6-322944516B0D}"/>
               </a:ext>
             </a:extLst>
@@ -8711,7 +9710,111 @@
 </p:sld>
 </file>
 
-<file path=ppt/slides/slide15.xml><?xml version="1.0" encoding="utf-8"?>
+<file path=ppt/slides/slide16.xml><?xml version="1.0" encoding="utf-8"?>
+<p:sld xmlns:a="http://schemas.openxmlformats.org/drawingml/2006/main" xmlns:r="http://schemas.openxmlformats.org/officeDocument/2006/relationships" xmlns:p="http://schemas.openxmlformats.org/presentationml/2006/main">
+  <p:cSld>
+    <p:spTree>
+      <p:nvGrpSpPr>
+        <p:cNvPr id="1" name=""/>
+        <p:cNvGrpSpPr/>
+        <p:nvPr/>
+      </p:nvGrpSpPr>
+      <p:grpSpPr>
+        <a:xfrm>
+          <a:off x="0" y="0"/>
+          <a:ext cx="0" cy="0"/>
+          <a:chOff x="0" y="0"/>
+          <a:chExt cx="0" cy="0"/>
+        </a:xfrm>
+      </p:grpSpPr>
+      <p:sp>
+        <p:nvSpPr>
+          <p:cNvPr id="2" name="Titolo 1">
+            <a:extLst>
+              <a:ext uri="{FF2B5EF4-FFF2-40B4-BE49-F238E27FC236}">
+                <a16:creationId xmlns:a16="http://schemas.microsoft.com/office/drawing/2014/main" id="{51D6D180-D528-A515-B125-F5368256A319}"/>
+              </a:ext>
+            </a:extLst>
+          </p:cNvPr>
+          <p:cNvSpPr>
+            <a:spLocks noGrp="1"/>
+          </p:cNvSpPr>
+          <p:nvPr>
+            <p:ph type="title"/>
+          </p:nvPr>
+        </p:nvSpPr>
+        <p:spPr/>
+        <p:txBody>
+          <a:bodyPr/>
+          <a:lstStyle/>
+          <a:p>
+            <a:r>
+              <a:rPr lang="it-IT" dirty="0" err="1"/>
+              <a:t>FrontEnd</a:t>
+            </a:r>
+            <a:endParaRPr lang="it-IT" dirty="0"/>
+          </a:p>
+        </p:txBody>
+      </p:sp>
+      <p:sp>
+        <p:nvSpPr>
+          <p:cNvPr id="3" name="Segnaposto testo 2">
+            <a:extLst>
+              <a:ext uri="{FF2B5EF4-FFF2-40B4-BE49-F238E27FC236}">
+                <a16:creationId xmlns:a16="http://schemas.microsoft.com/office/drawing/2014/main" id="{961B30F2-96D0-37CD-00E7-63CBA35E7EF0}"/>
+              </a:ext>
+            </a:extLst>
+          </p:cNvPr>
+          <p:cNvSpPr>
+            <a:spLocks noGrp="1"/>
+          </p:cNvSpPr>
+          <p:nvPr>
+            <p:ph type="body" idx="1"/>
+          </p:nvPr>
+        </p:nvSpPr>
+        <p:spPr>
+          <a:xfrm>
+            <a:off x="204107" y="1171600"/>
+            <a:ext cx="8628193" cy="3397200"/>
+          </a:xfrm>
+        </p:spPr>
+        <p:txBody>
+          <a:bodyPr/>
+          <a:lstStyle/>
+          <a:p>
+            <a:pPr marL="114300" indent="0">
+              <a:buNone/>
+            </a:pPr>
+            <a:r>
+              <a:rPr lang="it-IT" dirty="0"/>
+              <a:t>Per l’app è stata creata una UI semplice e intuitiva. Ad esempio nella home abbiamo una grafica che ricorda, per i profili degli animali, i vari social più diffusi in modo da semplificare la UX .L’utente, tramite semplici bottoni riconoscibili è da  subito in grado di comprendere il funzionamento dei vari componenti dell’applicazione.</a:t>
+            </a:r>
+          </a:p>
+          <a:p>
+            <a:pPr marL="114300" indent="0">
+              <a:buNone/>
+            </a:pPr>
+            <a:r>
+              <a:rPr lang="it-IT" dirty="0"/>
+              <a:t>Per ciò che riguarda il portale Web si è scelto di utilizzare la stessa logica, e di rendere facile per l’utente l’inserimento dei propri dati e l’utilizzo del portale al fine di presentare i propri servizi agli utenti.</a:t>
+            </a:r>
+          </a:p>
+        </p:txBody>
+      </p:sp>
+    </p:spTree>
+    <p:extLst>
+      <p:ext uri="{BB962C8B-B14F-4D97-AF65-F5344CB8AC3E}">
+        <p14:creationId xmlns:p14="http://schemas.microsoft.com/office/powerpoint/2010/main" val="1794453119"/>
+      </p:ext>
+    </p:extLst>
+  </p:cSld>
+  <p:clrMapOvr>
+    <a:masterClrMapping/>
+  </p:clrMapOvr>
+</p:sld>
+</file>
+
+<file path=ppt/slides/slide17.xml><?xml version="1.0" encoding="utf-8"?>
 <p:sld xmlns:a="http://schemas.openxmlformats.org/drawingml/2006/main" xmlns:r="http://schemas.openxmlformats.org/officeDocument/2006/relationships" xmlns:p="http://schemas.openxmlformats.org/presentationml/2006/main">
   <p:cSld>
     <p:spTree>
@@ -9080,7 +10183,7 @@
 </p:sld>
 </file>
 
-<file path=ppt/slides/slide16.xml><?xml version="1.0" encoding="utf-8"?>
+<file path=ppt/slides/slide18.xml><?xml version="1.0" encoding="utf-8"?>
 <p:sld xmlns:a="http://schemas.openxmlformats.org/drawingml/2006/main" xmlns:r="http://schemas.openxmlformats.org/officeDocument/2006/relationships" xmlns:p="http://schemas.openxmlformats.org/presentationml/2006/main">
   <p:cSld>
     <p:spTree>
@@ -9322,7 +10425,7 @@
 </p:sld>
 </file>
 
-<file path=ppt/slides/slide17.xml><?xml version="1.0" encoding="utf-8"?>
+<file path=ppt/slides/slide19.xml><?xml version="1.0" encoding="utf-8"?>
 <p:sld xmlns:a="http://schemas.openxmlformats.org/drawingml/2006/main" xmlns:r="http://schemas.openxmlformats.org/officeDocument/2006/relationships" xmlns:p="http://schemas.openxmlformats.org/presentationml/2006/main">
   <p:cSld>
     <p:spTree>
@@ -9699,7 +10802,74 @@
 </p:sld>
 </file>
 
-<file path=ppt/slides/slide18.xml><?xml version="1.0" encoding="utf-8"?>
+<file path=ppt/slides/slide2.xml><?xml version="1.0" encoding="utf-8"?>
+<p:sld xmlns:a="http://schemas.openxmlformats.org/drawingml/2006/main" xmlns:r="http://schemas.openxmlformats.org/officeDocument/2006/relationships" xmlns:p="http://schemas.openxmlformats.org/presentationml/2006/main">
+  <p:cSld>
+    <p:spTree>
+      <p:nvGrpSpPr>
+        <p:cNvPr id="1" name="Shape 64"/>
+        <p:cNvGrpSpPr/>
+        <p:nvPr/>
+      </p:nvGrpSpPr>
+      <p:grpSpPr>
+        <a:xfrm>
+          <a:off x="0" y="0"/>
+          <a:ext cx="0" cy="0"/>
+          <a:chOff x="0" y="0"/>
+          <a:chExt cx="0" cy="0"/>
+        </a:xfrm>
+      </p:grpSpPr>
+      <p:sp>
+        <p:nvSpPr>
+          <p:cNvPr id="65" name="Google Shape;65;p14"/>
+          <p:cNvSpPr txBox="1">
+            <a:spLocks noGrp="1"/>
+          </p:cNvSpPr>
+          <p:nvPr>
+            <p:ph type="title"/>
+          </p:nvPr>
+        </p:nvSpPr>
+        <p:spPr>
+          <a:xfrm>
+            <a:off x="490250" y="526350"/>
+            <a:ext cx="5604000" cy="4090800"/>
+          </a:xfrm>
+          <a:prstGeom prst="rect">
+            <a:avLst/>
+          </a:prstGeom>
+        </p:spPr>
+        <p:txBody>
+          <a:bodyPr spcFirstLastPara="1" wrap="square" lIns="91425" tIns="91425" rIns="91425" bIns="91425" anchor="ctr" anchorCtr="0">
+            <a:noAutofit/>
+          </a:bodyPr>
+          <a:lstStyle/>
+          <a:p>
+            <a:pPr marL="0" lvl="0" indent="0" algn="l" rtl="0">
+              <a:spcBef>
+                <a:spcPts val="0"/>
+              </a:spcBef>
+              <a:spcAft>
+                <a:spcPts val="0"/>
+              </a:spcAft>
+              <a:buNone/>
+            </a:pPr>
+            <a:r>
+              <a:rPr lang="it"/>
+              <a:t>Il progetto</a:t>
+            </a:r>
+            <a:endParaRPr/>
+          </a:p>
+        </p:txBody>
+      </p:sp>
+    </p:spTree>
+  </p:cSld>
+  <p:clrMapOvr>
+    <a:masterClrMapping/>
+  </p:clrMapOvr>
+</p:sld>
+</file>
+
+<file path=ppt/slides/slide20.xml><?xml version="1.0" encoding="utf-8"?>
 <p:sld xmlns:a="http://schemas.openxmlformats.org/drawingml/2006/main" xmlns:r="http://schemas.openxmlformats.org/officeDocument/2006/relationships" xmlns:p="http://schemas.openxmlformats.org/presentationml/2006/main">
   <p:cSld>
     <p:spTree>
@@ -10143,7 +11313,7 @@
 </p:sld>
 </file>
 
-<file path=ppt/slides/slide19.xml><?xml version="1.0" encoding="utf-8"?>
+<file path=ppt/slides/slide21.xml><?xml version="1.0" encoding="utf-8"?>
 <p:sld xmlns:a="http://schemas.openxmlformats.org/drawingml/2006/main" xmlns:r="http://schemas.openxmlformats.org/officeDocument/2006/relationships" xmlns:p="http://schemas.openxmlformats.org/presentationml/2006/main">
   <p:cSld>
     <p:spTree>
@@ -10367,74 +11537,7 @@
 </p:sld>
 </file>
 
-<file path=ppt/slides/slide2.xml><?xml version="1.0" encoding="utf-8"?>
-<p:sld xmlns:a="http://schemas.openxmlformats.org/drawingml/2006/main" xmlns:r="http://schemas.openxmlformats.org/officeDocument/2006/relationships" xmlns:p="http://schemas.openxmlformats.org/presentationml/2006/main">
-  <p:cSld>
-    <p:spTree>
-      <p:nvGrpSpPr>
-        <p:cNvPr id="1" name="Shape 64"/>
-        <p:cNvGrpSpPr/>
-        <p:nvPr/>
-      </p:nvGrpSpPr>
-      <p:grpSpPr>
-        <a:xfrm>
-          <a:off x="0" y="0"/>
-          <a:ext cx="0" cy="0"/>
-          <a:chOff x="0" y="0"/>
-          <a:chExt cx="0" cy="0"/>
-        </a:xfrm>
-      </p:grpSpPr>
-      <p:sp>
-        <p:nvSpPr>
-          <p:cNvPr id="65" name="Google Shape;65;p14"/>
-          <p:cNvSpPr txBox="1">
-            <a:spLocks noGrp="1"/>
-          </p:cNvSpPr>
-          <p:nvPr>
-            <p:ph type="title"/>
-          </p:nvPr>
-        </p:nvSpPr>
-        <p:spPr>
-          <a:xfrm>
-            <a:off x="490250" y="526350"/>
-            <a:ext cx="5604000" cy="4090800"/>
-          </a:xfrm>
-          <a:prstGeom prst="rect">
-            <a:avLst/>
-          </a:prstGeom>
-        </p:spPr>
-        <p:txBody>
-          <a:bodyPr spcFirstLastPara="1" wrap="square" lIns="91425" tIns="91425" rIns="91425" bIns="91425" anchor="ctr" anchorCtr="0">
-            <a:noAutofit/>
-          </a:bodyPr>
-          <a:lstStyle/>
-          <a:p>
-            <a:pPr marL="0" lvl="0" indent="0" algn="l" rtl="0">
-              <a:spcBef>
-                <a:spcPts val="0"/>
-              </a:spcBef>
-              <a:spcAft>
-                <a:spcPts val="0"/>
-              </a:spcAft>
-              <a:buNone/>
-            </a:pPr>
-            <a:r>
-              <a:rPr lang="it"/>
-              <a:t>Il progetto</a:t>
-            </a:r>
-            <a:endParaRPr/>
-          </a:p>
-        </p:txBody>
-      </p:sp>
-    </p:spTree>
-  </p:cSld>
-  <p:clrMapOvr>
-    <a:masterClrMapping/>
-  </p:clrMapOvr>
-</p:sld>
-</file>
-
-<file path=ppt/slides/slide20.xml><?xml version="1.0" encoding="utf-8"?>
+<file path=ppt/slides/slide22.xml><?xml version="1.0" encoding="utf-8"?>
 <p:sld xmlns:a="http://schemas.openxmlformats.org/drawingml/2006/main" xmlns:r="http://schemas.openxmlformats.org/officeDocument/2006/relationships" xmlns:p="http://schemas.openxmlformats.org/presentationml/2006/main">
   <p:cSld>
     <p:spTree>
@@ -10658,7 +11761,7 @@
 </p:sld>
 </file>
 
-<file path=ppt/slides/slide21.xml><?xml version="1.0" encoding="utf-8"?>
+<file path=ppt/slides/slide23.xml><?xml version="1.0" encoding="utf-8"?>
 <p:sld xmlns:a="http://schemas.openxmlformats.org/drawingml/2006/main" xmlns:r="http://schemas.openxmlformats.org/officeDocument/2006/relationships" xmlns:p="http://schemas.openxmlformats.org/presentationml/2006/main">
   <p:cSld>
     <p:spTree>
@@ -10882,7 +11985,7 @@
 </p:sld>
 </file>
 
-<file path=ppt/slides/slide22.xml><?xml version="1.0" encoding="utf-8"?>
+<file path=ppt/slides/slide24.xml><?xml version="1.0" encoding="utf-8"?>
 <p:sld xmlns:a="http://schemas.openxmlformats.org/drawingml/2006/main" xmlns:r="http://schemas.openxmlformats.org/officeDocument/2006/relationships" xmlns:p="http://schemas.openxmlformats.org/presentationml/2006/main">
   <p:cSld>
     <p:spTree>
@@ -11106,7 +12209,7 @@
 </p:sld>
 </file>
 
-<file path=ppt/slides/slide23.xml><?xml version="1.0" encoding="utf-8"?>
+<file path=ppt/slides/slide25.xml><?xml version="1.0" encoding="utf-8"?>
 <p:sld xmlns:a="http://schemas.openxmlformats.org/drawingml/2006/main" xmlns:r="http://schemas.openxmlformats.org/officeDocument/2006/relationships" xmlns:p="http://schemas.openxmlformats.org/presentationml/2006/main">
   <p:cSld>
     <p:spTree>
@@ -11812,7 +12915,7 @@
 </p:sld>
 </file>
 
-<file path=ppt/slides/slide24.xml><?xml version="1.0" encoding="utf-8"?>
+<file path=ppt/slides/slide26.xml><?xml version="1.0" encoding="utf-8"?>
 <p:sld xmlns:a="http://schemas.openxmlformats.org/drawingml/2006/main" xmlns:r="http://schemas.openxmlformats.org/officeDocument/2006/relationships" xmlns:p="http://schemas.openxmlformats.org/presentationml/2006/main">
   <p:cSld>
     <p:spTree>
@@ -12290,7 +13393,7 @@
 </p:sld>
 </file>
 
-<file path=ppt/slides/slide25.xml><?xml version="1.0" encoding="utf-8"?>
+<file path=ppt/slides/slide27.xml><?xml version="1.0" encoding="utf-8"?>
 <p:sld xmlns:a="http://schemas.openxmlformats.org/drawingml/2006/main" xmlns:r="http://schemas.openxmlformats.org/officeDocument/2006/relationships" xmlns:p="http://schemas.openxmlformats.org/presentationml/2006/main">
   <p:cSld>
     <p:spTree>
@@ -12531,7 +13634,7 @@
 </p:sld>
 </file>
 
-<file path=ppt/slides/slide26.xml><?xml version="1.0" encoding="utf-8"?>
+<file path=ppt/slides/slide28.xml><?xml version="1.0" encoding="utf-8"?>
 <p:sld xmlns:a="http://schemas.openxmlformats.org/drawingml/2006/main" xmlns:r="http://schemas.openxmlformats.org/officeDocument/2006/relationships" xmlns:p="http://schemas.openxmlformats.org/presentationml/2006/main">
   <p:cSld>
     <p:spTree>
@@ -13534,6 +14637,466 @@
 </file>
 
 <file path=ppt/slides/slide7.xml><?xml version="1.0" encoding="utf-8"?>
+<p:sld xmlns:a="http://schemas.openxmlformats.org/drawingml/2006/main" xmlns:r="http://schemas.openxmlformats.org/officeDocument/2006/relationships" xmlns:p="http://schemas.openxmlformats.org/presentationml/2006/main">
+  <p:cSld>
+    <p:spTree>
+      <p:nvGrpSpPr>
+        <p:cNvPr id="1" name=""/>
+        <p:cNvGrpSpPr/>
+        <p:nvPr/>
+      </p:nvGrpSpPr>
+      <p:grpSpPr>
+        <a:xfrm>
+          <a:off x="0" y="0"/>
+          <a:ext cx="0" cy="0"/>
+          <a:chOff x="0" y="0"/>
+          <a:chExt cx="0" cy="0"/>
+        </a:xfrm>
+      </p:grpSpPr>
+      <p:sp>
+        <p:nvSpPr>
+          <p:cNvPr id="2" name="Titolo 1">
+            <a:extLst>
+              <a:ext uri="{FF2B5EF4-FFF2-40B4-BE49-F238E27FC236}">
+                <a16:creationId xmlns:a16="http://schemas.microsoft.com/office/drawing/2014/main" id="{E37A1EEA-6AF2-7B2F-FC04-0640DADB58C3}"/>
+              </a:ext>
+            </a:extLst>
+          </p:cNvPr>
+          <p:cNvSpPr>
+            <a:spLocks noGrp="1"/>
+          </p:cNvSpPr>
+          <p:nvPr>
+            <p:ph type="title"/>
+          </p:nvPr>
+        </p:nvSpPr>
+        <p:spPr/>
+        <p:txBody>
+          <a:bodyPr/>
+          <a:lstStyle/>
+          <a:p>
+            <a:pPr algn="ctr"/>
+            <a:r>
+              <a:rPr lang="it-IT" dirty="0"/>
+              <a:t>Struttura </a:t>
+            </a:r>
+            <a:r>
+              <a:rPr lang="it-IT" dirty="0" err="1"/>
+              <a:t>DataBase</a:t>
+            </a:r>
+            <a:r>
+              <a:rPr lang="it-IT" dirty="0"/>
+              <a:t> SQL</a:t>
+            </a:r>
+          </a:p>
+        </p:txBody>
+      </p:sp>
+      <p:pic>
+        <p:nvPicPr>
+          <p:cNvPr id="4" name="Immagine 3" descr="Immagine che contiene testo, schermata, Carattere, linea&#10;&#10;Il contenuto generato dall'IA potrebbe non essere corretto.">
+            <a:extLst>
+              <a:ext uri="{FF2B5EF4-FFF2-40B4-BE49-F238E27FC236}">
+                <a16:creationId xmlns:a16="http://schemas.microsoft.com/office/drawing/2014/main" id="{3A88FB4C-CC61-BC27-1DBC-EBF02223BC0C}"/>
+              </a:ext>
+            </a:extLst>
+          </p:cNvPr>
+          <p:cNvPicPr>
+            <a:picLocks noChangeAspect="1"/>
+          </p:cNvPicPr>
+          <p:nvPr/>
+        </p:nvPicPr>
+        <p:blipFill>
+          <a:blip r:embed="rId2"/>
+          <a:stretch>
+            <a:fillRect/>
+          </a:stretch>
+        </p:blipFill>
+        <p:spPr>
+          <a:xfrm>
+            <a:off x="2450475" y="997820"/>
+            <a:ext cx="4243048" cy="1367388"/>
+          </a:xfrm>
+          <a:prstGeom prst="rect">
+            <a:avLst/>
+          </a:prstGeom>
+        </p:spPr>
+      </p:pic>
+      <p:pic>
+        <p:nvPicPr>
+          <p:cNvPr id="6" name="Immagine 5" descr="Immagine che contiene testo, schermata, Carattere, linea&#10;&#10;Il contenuto generato dall'IA potrebbe non essere corretto.">
+            <a:extLst>
+              <a:ext uri="{FF2B5EF4-FFF2-40B4-BE49-F238E27FC236}">
+                <a16:creationId xmlns:a16="http://schemas.microsoft.com/office/drawing/2014/main" id="{A31ABDCE-E2A6-EA34-D785-76A91AE119E6}"/>
+              </a:ext>
+            </a:extLst>
+          </p:cNvPr>
+          <p:cNvPicPr>
+            <a:picLocks noChangeAspect="1"/>
+          </p:cNvPicPr>
+          <p:nvPr/>
+        </p:nvPicPr>
+        <p:blipFill>
+          <a:blip r:embed="rId3"/>
+          <a:stretch>
+            <a:fillRect/>
+          </a:stretch>
+        </p:blipFill>
+        <p:spPr>
+          <a:xfrm>
+            <a:off x="2805621" y="2363907"/>
+            <a:ext cx="3289018" cy="1292661"/>
+          </a:xfrm>
+          <a:prstGeom prst="rect">
+            <a:avLst/>
+          </a:prstGeom>
+        </p:spPr>
+      </p:pic>
+      <p:pic>
+        <p:nvPicPr>
+          <p:cNvPr id="8" name="Immagine 7" descr="Immagine che contiene testo, schermata, Carattere, numero&#10;&#10;Il contenuto generato dall'IA potrebbe non essere corretto.">
+            <a:extLst>
+              <a:ext uri="{FF2B5EF4-FFF2-40B4-BE49-F238E27FC236}">
+                <a16:creationId xmlns:a16="http://schemas.microsoft.com/office/drawing/2014/main" id="{E420661F-4F64-BDA6-6746-3E208A6A7A0B}"/>
+              </a:ext>
+            </a:extLst>
+          </p:cNvPr>
+          <p:cNvPicPr>
+            <a:picLocks noChangeAspect="1"/>
+          </p:cNvPicPr>
+          <p:nvPr/>
+        </p:nvPicPr>
+        <p:blipFill>
+          <a:blip r:embed="rId4"/>
+          <a:stretch>
+            <a:fillRect/>
+          </a:stretch>
+        </p:blipFill>
+        <p:spPr>
+          <a:xfrm>
+            <a:off x="3001506" y="3656568"/>
+            <a:ext cx="2897247" cy="1401459"/>
+          </a:xfrm>
+          <a:prstGeom prst="rect">
+            <a:avLst/>
+          </a:prstGeom>
+        </p:spPr>
+      </p:pic>
+    </p:spTree>
+    <p:extLst>
+      <p:ext uri="{BB962C8B-B14F-4D97-AF65-F5344CB8AC3E}">
+        <p14:creationId xmlns:p14="http://schemas.microsoft.com/office/powerpoint/2010/main" val="622900377"/>
+      </p:ext>
+    </p:extLst>
+  </p:cSld>
+  <p:clrMapOvr>
+    <a:masterClrMapping/>
+  </p:clrMapOvr>
+  <p:timing>
+    <p:tnLst>
+      <p:par>
+        <p:cTn id="1" dur="indefinite" restart="never" nodeType="tmRoot">
+          <p:childTnLst>
+            <p:seq concurrent="1" nextAc="seek">
+              <p:cTn id="2" dur="indefinite" nodeType="mainSeq">
+                <p:childTnLst>
+                  <p:par>
+                    <p:cTn id="3" fill="hold">
+                      <p:stCondLst>
+                        <p:cond delay="indefinite"/>
+                      </p:stCondLst>
+                      <p:childTnLst>
+                        <p:par>
+                          <p:cTn id="4" fill="hold">
+                            <p:stCondLst>
+                              <p:cond delay="0"/>
+                            </p:stCondLst>
+                            <p:childTnLst>
+                              <p:par>
+                                <p:cTn id="5" presetID="2" presetClass="entr" presetSubtype="4" fill="hold" nodeType="clickEffect">
+                                  <p:stCondLst>
+                                    <p:cond delay="0"/>
+                                  </p:stCondLst>
+                                  <p:childTnLst>
+                                    <p:set>
+                                      <p:cBhvr>
+                                        <p:cTn id="6" dur="1" fill="hold">
+                                          <p:stCondLst>
+                                            <p:cond delay="0"/>
+                                          </p:stCondLst>
+                                        </p:cTn>
+                                        <p:tgtEl>
+                                          <p:spTgt spid="4"/>
+                                        </p:tgtEl>
+                                        <p:attrNameLst>
+                                          <p:attrName>style.visibility</p:attrName>
+                                        </p:attrNameLst>
+                                      </p:cBhvr>
+                                      <p:to>
+                                        <p:strVal val="visible"/>
+                                      </p:to>
+                                    </p:set>
+                                    <p:anim calcmode="lin" valueType="num">
+                                      <p:cBhvr additive="base">
+                                        <p:cTn id="7" dur="500" fill="hold"/>
+                                        <p:tgtEl>
+                                          <p:spTgt spid="4"/>
+                                        </p:tgtEl>
+                                        <p:attrNameLst>
+                                          <p:attrName>ppt_x</p:attrName>
+                                        </p:attrNameLst>
+                                      </p:cBhvr>
+                                      <p:tavLst>
+                                        <p:tav tm="0">
+                                          <p:val>
+                                            <p:strVal val="#ppt_x"/>
+                                          </p:val>
+                                        </p:tav>
+                                        <p:tav tm="100000">
+                                          <p:val>
+                                            <p:strVal val="#ppt_x"/>
+                                          </p:val>
+                                        </p:tav>
+                                      </p:tavLst>
+                                    </p:anim>
+                                    <p:anim calcmode="lin" valueType="num">
+                                      <p:cBhvr additive="base">
+                                        <p:cTn id="8" dur="500" fill="hold"/>
+                                        <p:tgtEl>
+                                          <p:spTgt spid="4"/>
+                                        </p:tgtEl>
+                                        <p:attrNameLst>
+                                          <p:attrName>ppt_y</p:attrName>
+                                        </p:attrNameLst>
+                                      </p:cBhvr>
+                                      <p:tavLst>
+                                        <p:tav tm="0">
+                                          <p:val>
+                                            <p:strVal val="1+#ppt_h/2"/>
+                                          </p:val>
+                                        </p:tav>
+                                        <p:tav tm="100000">
+                                          <p:val>
+                                            <p:strVal val="#ppt_y"/>
+                                          </p:val>
+                                        </p:tav>
+                                      </p:tavLst>
+                                    </p:anim>
+                                  </p:childTnLst>
+                                </p:cTn>
+                              </p:par>
+                            </p:childTnLst>
+                          </p:cTn>
+                        </p:par>
+                      </p:childTnLst>
+                    </p:cTn>
+                  </p:par>
+                  <p:par>
+                    <p:cTn id="9" fill="hold">
+                      <p:stCondLst>
+                        <p:cond delay="indefinite"/>
+                      </p:stCondLst>
+                      <p:childTnLst>
+                        <p:par>
+                          <p:cTn id="10" fill="hold">
+                            <p:stCondLst>
+                              <p:cond delay="0"/>
+                            </p:stCondLst>
+                            <p:childTnLst>
+                              <p:par>
+                                <p:cTn id="11" presetID="2" presetClass="entr" presetSubtype="4" fill="hold" nodeType="clickEffect">
+                                  <p:stCondLst>
+                                    <p:cond delay="0"/>
+                                  </p:stCondLst>
+                                  <p:childTnLst>
+                                    <p:set>
+                                      <p:cBhvr>
+                                        <p:cTn id="12" dur="1" fill="hold">
+                                          <p:stCondLst>
+                                            <p:cond delay="0"/>
+                                          </p:stCondLst>
+                                        </p:cTn>
+                                        <p:tgtEl>
+                                          <p:spTgt spid="6"/>
+                                        </p:tgtEl>
+                                        <p:attrNameLst>
+                                          <p:attrName>style.visibility</p:attrName>
+                                        </p:attrNameLst>
+                                      </p:cBhvr>
+                                      <p:to>
+                                        <p:strVal val="visible"/>
+                                      </p:to>
+                                    </p:set>
+                                    <p:anim calcmode="lin" valueType="num">
+                                      <p:cBhvr additive="base">
+                                        <p:cTn id="13" dur="500" fill="hold"/>
+                                        <p:tgtEl>
+                                          <p:spTgt spid="6"/>
+                                        </p:tgtEl>
+                                        <p:attrNameLst>
+                                          <p:attrName>ppt_x</p:attrName>
+                                        </p:attrNameLst>
+                                      </p:cBhvr>
+                                      <p:tavLst>
+                                        <p:tav tm="0">
+                                          <p:val>
+                                            <p:strVal val="#ppt_x"/>
+                                          </p:val>
+                                        </p:tav>
+                                        <p:tav tm="100000">
+                                          <p:val>
+                                            <p:strVal val="#ppt_x"/>
+                                          </p:val>
+                                        </p:tav>
+                                      </p:tavLst>
+                                    </p:anim>
+                                    <p:anim calcmode="lin" valueType="num">
+                                      <p:cBhvr additive="base">
+                                        <p:cTn id="14" dur="500" fill="hold"/>
+                                        <p:tgtEl>
+                                          <p:spTgt spid="6"/>
+                                        </p:tgtEl>
+                                        <p:attrNameLst>
+                                          <p:attrName>ppt_y</p:attrName>
+                                        </p:attrNameLst>
+                                      </p:cBhvr>
+                                      <p:tavLst>
+                                        <p:tav tm="0">
+                                          <p:val>
+                                            <p:strVal val="1+#ppt_h/2"/>
+                                          </p:val>
+                                        </p:tav>
+                                        <p:tav tm="100000">
+                                          <p:val>
+                                            <p:strVal val="#ppt_y"/>
+                                          </p:val>
+                                        </p:tav>
+                                      </p:tavLst>
+                                    </p:anim>
+                                  </p:childTnLst>
+                                </p:cTn>
+                              </p:par>
+                            </p:childTnLst>
+                          </p:cTn>
+                        </p:par>
+                      </p:childTnLst>
+                    </p:cTn>
+                  </p:par>
+                  <p:par>
+                    <p:cTn id="15" fill="hold">
+                      <p:stCondLst>
+                        <p:cond delay="indefinite"/>
+                      </p:stCondLst>
+                      <p:childTnLst>
+                        <p:par>
+                          <p:cTn id="16" fill="hold">
+                            <p:stCondLst>
+                              <p:cond delay="0"/>
+                            </p:stCondLst>
+                            <p:childTnLst>
+                              <p:par>
+                                <p:cTn id="17" presetID="2" presetClass="entr" presetSubtype="4" fill="hold" nodeType="clickEffect">
+                                  <p:stCondLst>
+                                    <p:cond delay="0"/>
+                                  </p:stCondLst>
+                                  <p:childTnLst>
+                                    <p:set>
+                                      <p:cBhvr>
+                                        <p:cTn id="18" dur="1" fill="hold">
+                                          <p:stCondLst>
+                                            <p:cond delay="0"/>
+                                          </p:stCondLst>
+                                        </p:cTn>
+                                        <p:tgtEl>
+                                          <p:spTgt spid="8"/>
+                                        </p:tgtEl>
+                                        <p:attrNameLst>
+                                          <p:attrName>style.visibility</p:attrName>
+                                        </p:attrNameLst>
+                                      </p:cBhvr>
+                                      <p:to>
+                                        <p:strVal val="visible"/>
+                                      </p:to>
+                                    </p:set>
+                                    <p:anim calcmode="lin" valueType="num">
+                                      <p:cBhvr additive="base">
+                                        <p:cTn id="19" dur="500" fill="hold"/>
+                                        <p:tgtEl>
+                                          <p:spTgt spid="8"/>
+                                        </p:tgtEl>
+                                        <p:attrNameLst>
+                                          <p:attrName>ppt_x</p:attrName>
+                                        </p:attrNameLst>
+                                      </p:cBhvr>
+                                      <p:tavLst>
+                                        <p:tav tm="0">
+                                          <p:val>
+                                            <p:strVal val="#ppt_x"/>
+                                          </p:val>
+                                        </p:tav>
+                                        <p:tav tm="100000">
+                                          <p:val>
+                                            <p:strVal val="#ppt_x"/>
+                                          </p:val>
+                                        </p:tav>
+                                      </p:tavLst>
+                                    </p:anim>
+                                    <p:anim calcmode="lin" valueType="num">
+                                      <p:cBhvr additive="base">
+                                        <p:cTn id="20" dur="500" fill="hold"/>
+                                        <p:tgtEl>
+                                          <p:spTgt spid="8"/>
+                                        </p:tgtEl>
+                                        <p:attrNameLst>
+                                          <p:attrName>ppt_y</p:attrName>
+                                        </p:attrNameLst>
+                                      </p:cBhvr>
+                                      <p:tavLst>
+                                        <p:tav tm="0">
+                                          <p:val>
+                                            <p:strVal val="1+#ppt_h/2"/>
+                                          </p:val>
+                                        </p:tav>
+                                        <p:tav tm="100000">
+                                          <p:val>
+                                            <p:strVal val="#ppt_y"/>
+                                          </p:val>
+                                        </p:tav>
+                                      </p:tavLst>
+                                    </p:anim>
+                                  </p:childTnLst>
+                                </p:cTn>
+                              </p:par>
+                            </p:childTnLst>
+                          </p:cTn>
+                        </p:par>
+                      </p:childTnLst>
+                    </p:cTn>
+                  </p:par>
+                </p:childTnLst>
+              </p:cTn>
+              <p:prevCondLst>
+                <p:cond evt="onPrev" delay="0">
+                  <p:tgtEl>
+                    <p:sldTgt/>
+                  </p:tgtEl>
+                </p:cond>
+              </p:prevCondLst>
+              <p:nextCondLst>
+                <p:cond evt="onNext" delay="0">
+                  <p:tgtEl>
+                    <p:sldTgt/>
+                  </p:tgtEl>
+                </p:cond>
+              </p:nextCondLst>
+            </p:seq>
+          </p:childTnLst>
+        </p:cTn>
+      </p:par>
+    </p:tnLst>
+  </p:timing>
+</p:sld>
+</file>
+
+<file path=ppt/slides/slide8.xml><?xml version="1.0" encoding="utf-8"?>
 <p:sld xmlns:a="http://schemas.openxmlformats.org/drawingml/2006/main" xmlns:r="http://schemas.openxmlformats.org/officeDocument/2006/relationships" xmlns:p="http://schemas.openxmlformats.org/presentationml/2006/main">
   <p:cSld>
     <p:spTree>
@@ -15064,7 +16627,7 @@
 </p:sld>
 </file>
 
-<file path=ppt/slides/slide8.xml><?xml version="1.0" encoding="utf-8"?>
+<file path=ppt/slides/slide9.xml><?xml version="1.0" encoding="utf-8"?>
 <p:sld xmlns:a="http://schemas.openxmlformats.org/drawingml/2006/main" xmlns:r="http://schemas.openxmlformats.org/officeDocument/2006/relationships" xmlns:p="http://schemas.openxmlformats.org/presentationml/2006/main">
   <p:cSld>
     <p:spTree>
@@ -15453,1349 +17016,6 @@
   <p:clrMapOvr>
     <a:masterClrMapping/>
   </p:clrMapOvr>
-</p:sld>
-</file>
-
-<file path=ppt/slides/slide9.xml><?xml version="1.0" encoding="utf-8"?>
-<p:sld xmlns:a="http://schemas.openxmlformats.org/drawingml/2006/main" xmlns:r="http://schemas.openxmlformats.org/officeDocument/2006/relationships" xmlns:p="http://schemas.openxmlformats.org/presentationml/2006/main">
-  <p:cSld>
-    <p:spTree>
-      <p:nvGrpSpPr>
-        <p:cNvPr id="1" name=""/>
-        <p:cNvGrpSpPr/>
-        <p:nvPr/>
-      </p:nvGrpSpPr>
-      <p:grpSpPr>
-        <a:xfrm>
-          <a:off x="0" y="0"/>
-          <a:ext cx="0" cy="0"/>
-          <a:chOff x="0" y="0"/>
-          <a:chExt cx="0" cy="0"/>
-        </a:xfrm>
-      </p:grpSpPr>
-      <p:sp>
-        <p:nvSpPr>
-          <p:cNvPr id="2" name="Titolo 1">
-            <a:extLst>
-              <a:ext uri="{FF2B5EF4-FFF2-40B4-BE49-F238E27FC236}">
-                <a16:creationId xmlns:a16="http://schemas.microsoft.com/office/drawing/2014/main" id="{CDA77C0F-428A-8B4D-B18A-BC19217C36C7}"/>
-              </a:ext>
-            </a:extLst>
-          </p:cNvPr>
-          <p:cNvSpPr>
-            <a:spLocks noGrp="1"/>
-          </p:cNvSpPr>
-          <p:nvPr>
-            <p:ph type="title"/>
-          </p:nvPr>
-        </p:nvSpPr>
-        <p:spPr/>
-        <p:txBody>
-          <a:bodyPr/>
-          <a:lstStyle/>
-          <a:p>
-            <a:pPr algn="ctr"/>
-            <a:r>
-              <a:rPr lang="it-IT" dirty="0"/>
-              <a:t>WIREFRAME DELL’APP</a:t>
-            </a:r>
-          </a:p>
-        </p:txBody>
-      </p:sp>
-      <p:pic>
-        <p:nvPicPr>
-          <p:cNvPr id="4" name="Immagine 3" descr="Immagine che contiene testo, schermata, cerchio, logo&#10;&#10;Il contenuto generato dall'IA potrebbe non essere corretto.">
-            <a:extLst>
-              <a:ext uri="{FF2B5EF4-FFF2-40B4-BE49-F238E27FC236}">
-                <a16:creationId xmlns:a16="http://schemas.microsoft.com/office/drawing/2014/main" id="{217FE4B0-D712-635C-F1D1-D43A9F7986FC}"/>
-              </a:ext>
-            </a:extLst>
-          </p:cNvPr>
-          <p:cNvPicPr>
-            <a:picLocks noChangeAspect="1"/>
-          </p:cNvPicPr>
-          <p:nvPr/>
-        </p:nvPicPr>
-        <p:blipFill>
-          <a:blip r:embed="rId2"/>
-          <a:stretch>
-            <a:fillRect/>
-          </a:stretch>
-        </p:blipFill>
-        <p:spPr>
-          <a:xfrm>
-            <a:off x="533468" y="1019785"/>
-            <a:ext cx="830804" cy="1849143"/>
-          </a:xfrm>
-          <a:prstGeom prst="rect">
-            <a:avLst/>
-          </a:prstGeom>
-        </p:spPr>
-      </p:pic>
-      <p:pic>
-        <p:nvPicPr>
-          <p:cNvPr id="26" name="Immagine 25" descr="Immagine che contiene testo, schermata, Carattere, design&#10;&#10;Il contenuto generato dall'IA potrebbe non essere corretto.">
-            <a:extLst>
-              <a:ext uri="{FF2B5EF4-FFF2-40B4-BE49-F238E27FC236}">
-                <a16:creationId xmlns:a16="http://schemas.microsoft.com/office/drawing/2014/main" id="{EB8A02DE-DEB9-3CE5-085A-AEC786AC52A0}"/>
-              </a:ext>
-            </a:extLst>
-          </p:cNvPr>
-          <p:cNvPicPr>
-            <a:picLocks noChangeAspect="1"/>
-          </p:cNvPicPr>
-          <p:nvPr/>
-        </p:nvPicPr>
-        <p:blipFill>
-          <a:blip r:embed="rId3"/>
-          <a:stretch>
-            <a:fillRect/>
-          </a:stretch>
-        </p:blipFill>
-        <p:spPr>
-          <a:xfrm flipH="1">
-            <a:off x="2653483" y="3044883"/>
-            <a:ext cx="830802" cy="1849140"/>
-          </a:xfrm>
-          <a:prstGeom prst="rect">
-            <a:avLst/>
-          </a:prstGeom>
-        </p:spPr>
-      </p:pic>
-      <p:pic>
-        <p:nvPicPr>
-          <p:cNvPr id="28" name="Immagine 27" descr="Immagine che contiene testo, schermata, Carattere, design&#10;&#10;Il contenuto generato dall'IA potrebbe non essere corretto.">
-            <a:extLst>
-              <a:ext uri="{FF2B5EF4-FFF2-40B4-BE49-F238E27FC236}">
-                <a16:creationId xmlns:a16="http://schemas.microsoft.com/office/drawing/2014/main" id="{5A62DBC2-49C9-4D2B-5B8A-40074EE76EC3}"/>
-              </a:ext>
-            </a:extLst>
-          </p:cNvPr>
-          <p:cNvPicPr>
-            <a:picLocks noChangeAspect="1"/>
-          </p:cNvPicPr>
-          <p:nvPr/>
-        </p:nvPicPr>
-        <p:blipFill>
-          <a:blip r:embed="rId4"/>
-          <a:stretch>
-            <a:fillRect/>
-          </a:stretch>
-        </p:blipFill>
-        <p:spPr>
-          <a:xfrm>
-            <a:off x="5667200" y="1067394"/>
-            <a:ext cx="864552" cy="1924258"/>
-          </a:xfrm>
-          <a:prstGeom prst="rect">
-            <a:avLst/>
-          </a:prstGeom>
-        </p:spPr>
-      </p:pic>
-      <p:pic>
-        <p:nvPicPr>
-          <p:cNvPr id="30" name="Immagine 29" descr="Immagine che contiene testo, schermata, biglietto da visita, design&#10;&#10;Il contenuto generato dall'IA potrebbe non essere corretto.">
-            <a:extLst>
-              <a:ext uri="{FF2B5EF4-FFF2-40B4-BE49-F238E27FC236}">
-                <a16:creationId xmlns:a16="http://schemas.microsoft.com/office/drawing/2014/main" id="{030715D4-13A2-9A99-BC46-49964438FCE4}"/>
-              </a:ext>
-            </a:extLst>
-          </p:cNvPr>
-          <p:cNvPicPr>
-            <a:picLocks noChangeAspect="1"/>
-          </p:cNvPicPr>
-          <p:nvPr/>
-        </p:nvPicPr>
-        <p:blipFill>
-          <a:blip r:embed="rId5"/>
-          <a:stretch>
-            <a:fillRect/>
-          </a:stretch>
-        </p:blipFill>
-        <p:spPr>
-          <a:xfrm>
-            <a:off x="6774478" y="1057344"/>
-            <a:ext cx="864552" cy="1924259"/>
-          </a:xfrm>
-          <a:prstGeom prst="rect">
-            <a:avLst/>
-          </a:prstGeom>
-        </p:spPr>
-      </p:pic>
-      <p:pic>
-        <p:nvPicPr>
-          <p:cNvPr id="32" name="Immagine 31" descr="Immagine che contiene testo, schermata, Carattere, design&#10;&#10;Il contenuto generato dall'IA potrebbe non essere corretto.">
-            <a:extLst>
-              <a:ext uri="{FF2B5EF4-FFF2-40B4-BE49-F238E27FC236}">
-                <a16:creationId xmlns:a16="http://schemas.microsoft.com/office/drawing/2014/main" id="{B7D876EF-870A-461F-D6E3-AF266C3C95B9}"/>
-              </a:ext>
-            </a:extLst>
-          </p:cNvPr>
-          <p:cNvPicPr>
-            <a:picLocks noChangeAspect="1"/>
-          </p:cNvPicPr>
-          <p:nvPr/>
-        </p:nvPicPr>
-        <p:blipFill>
-          <a:blip r:embed="rId6"/>
-          <a:stretch>
-            <a:fillRect/>
-          </a:stretch>
-        </p:blipFill>
-        <p:spPr>
-          <a:xfrm>
-            <a:off x="4869823" y="3073459"/>
-            <a:ext cx="864553" cy="1924259"/>
-          </a:xfrm>
-          <a:prstGeom prst="rect">
-            <a:avLst/>
-          </a:prstGeom>
-        </p:spPr>
-      </p:pic>
-      <p:pic>
-        <p:nvPicPr>
-          <p:cNvPr id="34" name="Immagine 33" descr="Immagine che contiene testo, schermata, logo, design&#10;&#10;Il contenuto generato dall'IA potrebbe non essere corretto.">
-            <a:extLst>
-              <a:ext uri="{FF2B5EF4-FFF2-40B4-BE49-F238E27FC236}">
-                <a16:creationId xmlns:a16="http://schemas.microsoft.com/office/drawing/2014/main" id="{C5AF193D-71B0-A3F6-0501-C0D09EAB8DF2}"/>
-              </a:ext>
-            </a:extLst>
-          </p:cNvPr>
-          <p:cNvPicPr>
-            <a:picLocks noChangeAspect="1"/>
-          </p:cNvPicPr>
-          <p:nvPr/>
-        </p:nvPicPr>
-        <p:blipFill>
-          <a:blip r:embed="rId7"/>
-          <a:stretch>
-            <a:fillRect/>
-          </a:stretch>
-        </p:blipFill>
-        <p:spPr>
-          <a:xfrm>
-            <a:off x="2550270" y="1058737"/>
-            <a:ext cx="838875" cy="1867109"/>
-          </a:xfrm>
-          <a:prstGeom prst="rect">
-            <a:avLst/>
-          </a:prstGeom>
-        </p:spPr>
-      </p:pic>
-      <p:pic>
-        <p:nvPicPr>
-          <p:cNvPr id="36" name="Immagine 35" descr="Immagine che contiene testo, schermata, numero, Carattere&#10;&#10;Il contenuto generato dall'IA potrebbe non essere corretto.">
-            <a:extLst>
-              <a:ext uri="{FF2B5EF4-FFF2-40B4-BE49-F238E27FC236}">
-                <a16:creationId xmlns:a16="http://schemas.microsoft.com/office/drawing/2014/main" id="{9F8718C3-4DCB-1ED3-E28B-E299F8ED67A2}"/>
-              </a:ext>
-            </a:extLst>
-          </p:cNvPr>
-          <p:cNvPicPr>
-            <a:picLocks noChangeAspect="1"/>
-          </p:cNvPicPr>
-          <p:nvPr/>
-        </p:nvPicPr>
-        <p:blipFill>
-          <a:blip r:embed="rId8"/>
-          <a:stretch>
-            <a:fillRect/>
-          </a:stretch>
-        </p:blipFill>
-        <p:spPr>
-          <a:xfrm>
-            <a:off x="3757616" y="3073459"/>
-            <a:ext cx="838876" cy="1867109"/>
-          </a:xfrm>
-          <a:prstGeom prst="rect">
-            <a:avLst/>
-          </a:prstGeom>
-        </p:spPr>
-      </p:pic>
-      <p:pic>
-        <p:nvPicPr>
-          <p:cNvPr id="38" name="Immagine 37" descr="Immagine che contiene testo, schermata, cerchio, Carattere&#10;&#10;Il contenuto generato dall'IA potrebbe non essere corretto.">
-            <a:extLst>
-              <a:ext uri="{FF2B5EF4-FFF2-40B4-BE49-F238E27FC236}">
-                <a16:creationId xmlns:a16="http://schemas.microsoft.com/office/drawing/2014/main" id="{81F0ABAE-28AE-C04C-9E3D-B61298F422DF}"/>
-              </a:ext>
-            </a:extLst>
-          </p:cNvPr>
-          <p:cNvPicPr>
-            <a:picLocks noChangeAspect="1"/>
-          </p:cNvPicPr>
-          <p:nvPr/>
-        </p:nvPicPr>
-        <p:blipFill>
-          <a:blip r:embed="rId9"/>
-          <a:stretch>
-            <a:fillRect/>
-          </a:stretch>
-        </p:blipFill>
-        <p:spPr>
-          <a:xfrm>
-            <a:off x="4633612" y="1048800"/>
-            <a:ext cx="838876" cy="1867109"/>
-          </a:xfrm>
-          <a:prstGeom prst="rect">
-            <a:avLst/>
-          </a:prstGeom>
-        </p:spPr>
-      </p:pic>
-      <p:pic>
-        <p:nvPicPr>
-          <p:cNvPr id="40" name="Immagine 39" descr="Immagine che contiene testo, schermata, grafica, logo&#10;&#10;Il contenuto generato dall'IA potrebbe non essere corretto.">
-            <a:extLst>
-              <a:ext uri="{FF2B5EF4-FFF2-40B4-BE49-F238E27FC236}">
-                <a16:creationId xmlns:a16="http://schemas.microsoft.com/office/drawing/2014/main" id="{5938B6A7-133E-B8E0-A180-2A475E9BADA9}"/>
-              </a:ext>
-            </a:extLst>
-          </p:cNvPr>
-          <p:cNvPicPr>
-            <a:picLocks noChangeAspect="1"/>
-          </p:cNvPicPr>
-          <p:nvPr/>
-        </p:nvPicPr>
-        <p:blipFill>
-          <a:blip r:embed="rId10"/>
-          <a:stretch>
-            <a:fillRect/>
-          </a:stretch>
-        </p:blipFill>
-        <p:spPr>
-          <a:xfrm>
-            <a:off x="7875587" y="1057344"/>
-            <a:ext cx="830803" cy="1849140"/>
-          </a:xfrm>
-          <a:prstGeom prst="rect">
-            <a:avLst/>
-          </a:prstGeom>
-        </p:spPr>
-      </p:pic>
-      <p:pic>
-        <p:nvPicPr>
-          <p:cNvPr id="42" name="Immagine 41" descr="Immagine che contiene testo, schermata, cerchio, Elementi grafici&#10;&#10;Il contenuto generato dall'IA potrebbe non essere corretto.">
-            <a:extLst>
-              <a:ext uri="{FF2B5EF4-FFF2-40B4-BE49-F238E27FC236}">
-                <a16:creationId xmlns:a16="http://schemas.microsoft.com/office/drawing/2014/main" id="{AC90764F-519C-F11F-4791-3F7545F71713}"/>
-              </a:ext>
-            </a:extLst>
-          </p:cNvPr>
-          <p:cNvPicPr>
-            <a:picLocks noChangeAspect="1"/>
-          </p:cNvPicPr>
-          <p:nvPr/>
-        </p:nvPicPr>
-        <p:blipFill>
-          <a:blip r:embed="rId11"/>
-          <a:stretch>
-            <a:fillRect/>
-          </a:stretch>
-        </p:blipFill>
-        <p:spPr>
-          <a:xfrm>
-            <a:off x="3528047" y="1039005"/>
-            <a:ext cx="890062" cy="1981036"/>
-          </a:xfrm>
-          <a:prstGeom prst="rect">
-            <a:avLst/>
-          </a:prstGeom>
-        </p:spPr>
-      </p:pic>
-      <p:pic>
-        <p:nvPicPr>
-          <p:cNvPr id="44" name="Immagine 43" descr="Immagine che contiene testo, schermata, Carattere, design&#10;&#10;Il contenuto generato dall'IA potrebbe non essere corretto.">
-            <a:extLst>
-              <a:ext uri="{FF2B5EF4-FFF2-40B4-BE49-F238E27FC236}">
-                <a16:creationId xmlns:a16="http://schemas.microsoft.com/office/drawing/2014/main" id="{D54A1AA3-F9D8-A2C5-A901-76D1109BB44B}"/>
-              </a:ext>
-            </a:extLst>
-          </p:cNvPr>
-          <p:cNvPicPr>
-            <a:picLocks noChangeAspect="1"/>
-          </p:cNvPicPr>
-          <p:nvPr/>
-        </p:nvPicPr>
-        <p:blipFill>
-          <a:blip r:embed="rId12"/>
-          <a:stretch>
-            <a:fillRect/>
-          </a:stretch>
-        </p:blipFill>
-        <p:spPr>
-          <a:xfrm>
-            <a:off x="6008393" y="3073460"/>
-            <a:ext cx="864552" cy="1924258"/>
-          </a:xfrm>
-          <a:prstGeom prst="rect">
-            <a:avLst/>
-          </a:prstGeom>
-        </p:spPr>
-      </p:pic>
-      <p:pic>
-        <p:nvPicPr>
-          <p:cNvPr id="46" name="Immagine 45" descr="Immagine che contiene testo, schermata, cerchio, design&#10;&#10;Il contenuto generato dall'IA potrebbe non essere corretto.">
-            <a:extLst>
-              <a:ext uri="{FF2B5EF4-FFF2-40B4-BE49-F238E27FC236}">
-                <a16:creationId xmlns:a16="http://schemas.microsoft.com/office/drawing/2014/main" id="{0BC4043E-2ACA-8C92-2EA6-1753C6C170A0}"/>
-              </a:ext>
-            </a:extLst>
-          </p:cNvPr>
-          <p:cNvPicPr>
-            <a:picLocks noChangeAspect="1"/>
-          </p:cNvPicPr>
-          <p:nvPr/>
-        </p:nvPicPr>
-        <p:blipFill>
-          <a:blip r:embed="rId13"/>
-          <a:stretch>
-            <a:fillRect/>
-          </a:stretch>
-        </p:blipFill>
-        <p:spPr>
-          <a:xfrm>
-            <a:off x="1524994" y="1035021"/>
-            <a:ext cx="864553" cy="1924261"/>
-          </a:xfrm>
-          <a:prstGeom prst="rect">
-            <a:avLst/>
-          </a:prstGeom>
-        </p:spPr>
-      </p:pic>
-    </p:spTree>
-    <p:extLst>
-      <p:ext uri="{BB962C8B-B14F-4D97-AF65-F5344CB8AC3E}">
-        <p14:creationId xmlns:p14="http://schemas.microsoft.com/office/powerpoint/2010/main" val="2210377371"/>
-      </p:ext>
-    </p:extLst>
-  </p:cSld>
-  <p:clrMapOvr>
-    <a:masterClrMapping/>
-  </p:clrMapOvr>
-  <p:timing>
-    <p:tnLst>
-      <p:par>
-        <p:cTn id="1" dur="indefinite" restart="never" nodeType="tmRoot">
-          <p:childTnLst>
-            <p:seq concurrent="1" nextAc="seek">
-              <p:cTn id="2" dur="indefinite" nodeType="mainSeq">
-                <p:childTnLst>
-                  <p:par>
-                    <p:cTn id="3" fill="hold">
-                      <p:stCondLst>
-                        <p:cond delay="indefinite"/>
-                      </p:stCondLst>
-                      <p:childTnLst>
-                        <p:par>
-                          <p:cTn id="4" fill="hold">
-                            <p:stCondLst>
-                              <p:cond delay="0"/>
-                            </p:stCondLst>
-                            <p:childTnLst>
-                              <p:par>
-                                <p:cTn id="5" presetID="2" presetClass="entr" presetSubtype="4" fill="hold" nodeType="clickEffect">
-                                  <p:stCondLst>
-                                    <p:cond delay="0"/>
-                                  </p:stCondLst>
-                                  <p:childTnLst>
-                                    <p:set>
-                                      <p:cBhvr>
-                                        <p:cTn id="6" dur="1" fill="hold">
-                                          <p:stCondLst>
-                                            <p:cond delay="0"/>
-                                          </p:stCondLst>
-                                        </p:cTn>
-                                        <p:tgtEl>
-                                          <p:spTgt spid="4"/>
-                                        </p:tgtEl>
-                                        <p:attrNameLst>
-                                          <p:attrName>style.visibility</p:attrName>
-                                        </p:attrNameLst>
-                                      </p:cBhvr>
-                                      <p:to>
-                                        <p:strVal val="visible"/>
-                                      </p:to>
-                                    </p:set>
-                                    <p:anim calcmode="lin" valueType="num">
-                                      <p:cBhvr additive="base">
-                                        <p:cTn id="7" dur="500" fill="hold"/>
-                                        <p:tgtEl>
-                                          <p:spTgt spid="4"/>
-                                        </p:tgtEl>
-                                        <p:attrNameLst>
-                                          <p:attrName>ppt_x</p:attrName>
-                                        </p:attrNameLst>
-                                      </p:cBhvr>
-                                      <p:tavLst>
-                                        <p:tav tm="0">
-                                          <p:val>
-                                            <p:strVal val="#ppt_x"/>
-                                          </p:val>
-                                        </p:tav>
-                                        <p:tav tm="100000">
-                                          <p:val>
-                                            <p:strVal val="#ppt_x"/>
-                                          </p:val>
-                                        </p:tav>
-                                      </p:tavLst>
-                                    </p:anim>
-                                    <p:anim calcmode="lin" valueType="num">
-                                      <p:cBhvr additive="base">
-                                        <p:cTn id="8" dur="500" fill="hold"/>
-                                        <p:tgtEl>
-                                          <p:spTgt spid="4"/>
-                                        </p:tgtEl>
-                                        <p:attrNameLst>
-                                          <p:attrName>ppt_y</p:attrName>
-                                        </p:attrNameLst>
-                                      </p:cBhvr>
-                                      <p:tavLst>
-                                        <p:tav tm="0">
-                                          <p:val>
-                                            <p:strVal val="1+#ppt_h/2"/>
-                                          </p:val>
-                                        </p:tav>
-                                        <p:tav tm="100000">
-                                          <p:val>
-                                            <p:strVal val="#ppt_y"/>
-                                          </p:val>
-                                        </p:tav>
-                                      </p:tavLst>
-                                    </p:anim>
-                                  </p:childTnLst>
-                                </p:cTn>
-                              </p:par>
-                              <p:par>
-                                <p:cTn id="9" presetID="2" presetClass="entr" presetSubtype="4" fill="hold" nodeType="withEffect">
-                                  <p:stCondLst>
-                                    <p:cond delay="0"/>
-                                  </p:stCondLst>
-                                  <p:childTnLst>
-                                    <p:set>
-                                      <p:cBhvr>
-                                        <p:cTn id="10" dur="1" fill="hold">
-                                          <p:stCondLst>
-                                            <p:cond delay="0"/>
-                                          </p:stCondLst>
-                                        </p:cTn>
-                                        <p:tgtEl>
-                                          <p:spTgt spid="46"/>
-                                        </p:tgtEl>
-                                        <p:attrNameLst>
-                                          <p:attrName>style.visibility</p:attrName>
-                                        </p:attrNameLst>
-                                      </p:cBhvr>
-                                      <p:to>
-                                        <p:strVal val="visible"/>
-                                      </p:to>
-                                    </p:set>
-                                    <p:anim calcmode="lin" valueType="num">
-                                      <p:cBhvr additive="base">
-                                        <p:cTn id="11" dur="500" fill="hold"/>
-                                        <p:tgtEl>
-                                          <p:spTgt spid="46"/>
-                                        </p:tgtEl>
-                                        <p:attrNameLst>
-                                          <p:attrName>ppt_x</p:attrName>
-                                        </p:attrNameLst>
-                                      </p:cBhvr>
-                                      <p:tavLst>
-                                        <p:tav tm="0">
-                                          <p:val>
-                                            <p:strVal val="#ppt_x"/>
-                                          </p:val>
-                                        </p:tav>
-                                        <p:tav tm="100000">
-                                          <p:val>
-                                            <p:strVal val="#ppt_x"/>
-                                          </p:val>
-                                        </p:tav>
-                                      </p:tavLst>
-                                    </p:anim>
-                                    <p:anim calcmode="lin" valueType="num">
-                                      <p:cBhvr additive="base">
-                                        <p:cTn id="12" dur="500" fill="hold"/>
-                                        <p:tgtEl>
-                                          <p:spTgt spid="46"/>
-                                        </p:tgtEl>
-                                        <p:attrNameLst>
-                                          <p:attrName>ppt_y</p:attrName>
-                                        </p:attrNameLst>
-                                      </p:cBhvr>
-                                      <p:tavLst>
-                                        <p:tav tm="0">
-                                          <p:val>
-                                            <p:strVal val="1+#ppt_h/2"/>
-                                          </p:val>
-                                        </p:tav>
-                                        <p:tav tm="100000">
-                                          <p:val>
-                                            <p:strVal val="#ppt_y"/>
-                                          </p:val>
-                                        </p:tav>
-                                      </p:tavLst>
-                                    </p:anim>
-                                  </p:childTnLst>
-                                </p:cTn>
-                              </p:par>
-                              <p:par>
-                                <p:cTn id="13" presetID="2" presetClass="entr" presetSubtype="4" fill="hold" nodeType="withEffect">
-                                  <p:stCondLst>
-                                    <p:cond delay="0"/>
-                                  </p:stCondLst>
-                                  <p:childTnLst>
-                                    <p:set>
-                                      <p:cBhvr>
-                                        <p:cTn id="14" dur="1" fill="hold">
-                                          <p:stCondLst>
-                                            <p:cond delay="0"/>
-                                          </p:stCondLst>
-                                        </p:cTn>
-                                        <p:tgtEl>
-                                          <p:spTgt spid="34"/>
-                                        </p:tgtEl>
-                                        <p:attrNameLst>
-                                          <p:attrName>style.visibility</p:attrName>
-                                        </p:attrNameLst>
-                                      </p:cBhvr>
-                                      <p:to>
-                                        <p:strVal val="visible"/>
-                                      </p:to>
-                                    </p:set>
-                                    <p:anim calcmode="lin" valueType="num">
-                                      <p:cBhvr additive="base">
-                                        <p:cTn id="15" dur="500" fill="hold"/>
-                                        <p:tgtEl>
-                                          <p:spTgt spid="34"/>
-                                        </p:tgtEl>
-                                        <p:attrNameLst>
-                                          <p:attrName>ppt_x</p:attrName>
-                                        </p:attrNameLst>
-                                      </p:cBhvr>
-                                      <p:tavLst>
-                                        <p:tav tm="0">
-                                          <p:val>
-                                            <p:strVal val="#ppt_x"/>
-                                          </p:val>
-                                        </p:tav>
-                                        <p:tav tm="100000">
-                                          <p:val>
-                                            <p:strVal val="#ppt_x"/>
-                                          </p:val>
-                                        </p:tav>
-                                      </p:tavLst>
-                                    </p:anim>
-                                    <p:anim calcmode="lin" valueType="num">
-                                      <p:cBhvr additive="base">
-                                        <p:cTn id="16" dur="500" fill="hold"/>
-                                        <p:tgtEl>
-                                          <p:spTgt spid="34"/>
-                                        </p:tgtEl>
-                                        <p:attrNameLst>
-                                          <p:attrName>ppt_y</p:attrName>
-                                        </p:attrNameLst>
-                                      </p:cBhvr>
-                                      <p:tavLst>
-                                        <p:tav tm="0">
-                                          <p:val>
-                                            <p:strVal val="1+#ppt_h/2"/>
-                                          </p:val>
-                                        </p:tav>
-                                        <p:tav tm="100000">
-                                          <p:val>
-                                            <p:strVal val="#ppt_y"/>
-                                          </p:val>
-                                        </p:tav>
-                                      </p:tavLst>
-                                    </p:anim>
-                                  </p:childTnLst>
-                                </p:cTn>
-                              </p:par>
-                              <p:par>
-                                <p:cTn id="17" presetID="2" presetClass="entr" presetSubtype="4" fill="hold" nodeType="withEffect">
-                                  <p:stCondLst>
-                                    <p:cond delay="0"/>
-                                  </p:stCondLst>
-                                  <p:childTnLst>
-                                    <p:set>
-                                      <p:cBhvr>
-                                        <p:cTn id="18" dur="1" fill="hold">
-                                          <p:stCondLst>
-                                            <p:cond delay="0"/>
-                                          </p:stCondLst>
-                                        </p:cTn>
-                                        <p:tgtEl>
-                                          <p:spTgt spid="42"/>
-                                        </p:tgtEl>
-                                        <p:attrNameLst>
-                                          <p:attrName>style.visibility</p:attrName>
-                                        </p:attrNameLst>
-                                      </p:cBhvr>
-                                      <p:to>
-                                        <p:strVal val="visible"/>
-                                      </p:to>
-                                    </p:set>
-                                    <p:anim calcmode="lin" valueType="num">
-                                      <p:cBhvr additive="base">
-                                        <p:cTn id="19" dur="500" fill="hold"/>
-                                        <p:tgtEl>
-                                          <p:spTgt spid="42"/>
-                                        </p:tgtEl>
-                                        <p:attrNameLst>
-                                          <p:attrName>ppt_x</p:attrName>
-                                        </p:attrNameLst>
-                                      </p:cBhvr>
-                                      <p:tavLst>
-                                        <p:tav tm="0">
-                                          <p:val>
-                                            <p:strVal val="#ppt_x"/>
-                                          </p:val>
-                                        </p:tav>
-                                        <p:tav tm="100000">
-                                          <p:val>
-                                            <p:strVal val="#ppt_x"/>
-                                          </p:val>
-                                        </p:tav>
-                                      </p:tavLst>
-                                    </p:anim>
-                                    <p:anim calcmode="lin" valueType="num">
-                                      <p:cBhvr additive="base">
-                                        <p:cTn id="20" dur="500" fill="hold"/>
-                                        <p:tgtEl>
-                                          <p:spTgt spid="42"/>
-                                        </p:tgtEl>
-                                        <p:attrNameLst>
-                                          <p:attrName>ppt_y</p:attrName>
-                                        </p:attrNameLst>
-                                      </p:cBhvr>
-                                      <p:tavLst>
-                                        <p:tav tm="0">
-                                          <p:val>
-                                            <p:strVal val="1+#ppt_h/2"/>
-                                          </p:val>
-                                        </p:tav>
-                                        <p:tav tm="100000">
-                                          <p:val>
-                                            <p:strVal val="#ppt_y"/>
-                                          </p:val>
-                                        </p:tav>
-                                      </p:tavLst>
-                                    </p:anim>
-                                  </p:childTnLst>
-                                </p:cTn>
-                              </p:par>
-                              <p:par>
-                                <p:cTn id="21" presetID="2" presetClass="entr" presetSubtype="4" fill="hold" nodeType="withEffect">
-                                  <p:stCondLst>
-                                    <p:cond delay="0"/>
-                                  </p:stCondLst>
-                                  <p:childTnLst>
-                                    <p:set>
-                                      <p:cBhvr>
-                                        <p:cTn id="22" dur="1" fill="hold">
-                                          <p:stCondLst>
-                                            <p:cond delay="0"/>
-                                          </p:stCondLst>
-                                        </p:cTn>
-                                        <p:tgtEl>
-                                          <p:spTgt spid="38"/>
-                                        </p:tgtEl>
-                                        <p:attrNameLst>
-                                          <p:attrName>style.visibility</p:attrName>
-                                        </p:attrNameLst>
-                                      </p:cBhvr>
-                                      <p:to>
-                                        <p:strVal val="visible"/>
-                                      </p:to>
-                                    </p:set>
-                                    <p:anim calcmode="lin" valueType="num">
-                                      <p:cBhvr additive="base">
-                                        <p:cTn id="23" dur="500" fill="hold"/>
-                                        <p:tgtEl>
-                                          <p:spTgt spid="38"/>
-                                        </p:tgtEl>
-                                        <p:attrNameLst>
-                                          <p:attrName>ppt_x</p:attrName>
-                                        </p:attrNameLst>
-                                      </p:cBhvr>
-                                      <p:tavLst>
-                                        <p:tav tm="0">
-                                          <p:val>
-                                            <p:strVal val="#ppt_x"/>
-                                          </p:val>
-                                        </p:tav>
-                                        <p:tav tm="100000">
-                                          <p:val>
-                                            <p:strVal val="#ppt_x"/>
-                                          </p:val>
-                                        </p:tav>
-                                      </p:tavLst>
-                                    </p:anim>
-                                    <p:anim calcmode="lin" valueType="num">
-                                      <p:cBhvr additive="base">
-                                        <p:cTn id="24" dur="500" fill="hold"/>
-                                        <p:tgtEl>
-                                          <p:spTgt spid="38"/>
-                                        </p:tgtEl>
-                                        <p:attrNameLst>
-                                          <p:attrName>ppt_y</p:attrName>
-                                        </p:attrNameLst>
-                                      </p:cBhvr>
-                                      <p:tavLst>
-                                        <p:tav tm="0">
-                                          <p:val>
-                                            <p:strVal val="1+#ppt_h/2"/>
-                                          </p:val>
-                                        </p:tav>
-                                        <p:tav tm="100000">
-                                          <p:val>
-                                            <p:strVal val="#ppt_y"/>
-                                          </p:val>
-                                        </p:tav>
-                                      </p:tavLst>
-                                    </p:anim>
-                                  </p:childTnLst>
-                                </p:cTn>
-                              </p:par>
-                              <p:par>
-                                <p:cTn id="25" presetID="2" presetClass="entr" presetSubtype="4" fill="hold" nodeType="withEffect">
-                                  <p:stCondLst>
-                                    <p:cond delay="0"/>
-                                  </p:stCondLst>
-                                  <p:childTnLst>
-                                    <p:set>
-                                      <p:cBhvr>
-                                        <p:cTn id="26" dur="1" fill="hold">
-                                          <p:stCondLst>
-                                            <p:cond delay="0"/>
-                                          </p:stCondLst>
-                                        </p:cTn>
-                                        <p:tgtEl>
-                                          <p:spTgt spid="28"/>
-                                        </p:tgtEl>
-                                        <p:attrNameLst>
-                                          <p:attrName>style.visibility</p:attrName>
-                                        </p:attrNameLst>
-                                      </p:cBhvr>
-                                      <p:to>
-                                        <p:strVal val="visible"/>
-                                      </p:to>
-                                    </p:set>
-                                    <p:anim calcmode="lin" valueType="num">
-                                      <p:cBhvr additive="base">
-                                        <p:cTn id="27" dur="500" fill="hold"/>
-                                        <p:tgtEl>
-                                          <p:spTgt spid="28"/>
-                                        </p:tgtEl>
-                                        <p:attrNameLst>
-                                          <p:attrName>ppt_x</p:attrName>
-                                        </p:attrNameLst>
-                                      </p:cBhvr>
-                                      <p:tavLst>
-                                        <p:tav tm="0">
-                                          <p:val>
-                                            <p:strVal val="#ppt_x"/>
-                                          </p:val>
-                                        </p:tav>
-                                        <p:tav tm="100000">
-                                          <p:val>
-                                            <p:strVal val="#ppt_x"/>
-                                          </p:val>
-                                        </p:tav>
-                                      </p:tavLst>
-                                    </p:anim>
-                                    <p:anim calcmode="lin" valueType="num">
-                                      <p:cBhvr additive="base">
-                                        <p:cTn id="28" dur="500" fill="hold"/>
-                                        <p:tgtEl>
-                                          <p:spTgt spid="28"/>
-                                        </p:tgtEl>
-                                        <p:attrNameLst>
-                                          <p:attrName>ppt_y</p:attrName>
-                                        </p:attrNameLst>
-                                      </p:cBhvr>
-                                      <p:tavLst>
-                                        <p:tav tm="0">
-                                          <p:val>
-                                            <p:strVal val="1+#ppt_h/2"/>
-                                          </p:val>
-                                        </p:tav>
-                                        <p:tav tm="100000">
-                                          <p:val>
-                                            <p:strVal val="#ppt_y"/>
-                                          </p:val>
-                                        </p:tav>
-                                      </p:tavLst>
-                                    </p:anim>
-                                  </p:childTnLst>
-                                </p:cTn>
-                              </p:par>
-                              <p:par>
-                                <p:cTn id="29" presetID="2" presetClass="entr" presetSubtype="4" fill="hold" nodeType="withEffect">
-                                  <p:stCondLst>
-                                    <p:cond delay="0"/>
-                                  </p:stCondLst>
-                                  <p:childTnLst>
-                                    <p:set>
-                                      <p:cBhvr>
-                                        <p:cTn id="30" dur="1" fill="hold">
-                                          <p:stCondLst>
-                                            <p:cond delay="0"/>
-                                          </p:stCondLst>
-                                        </p:cTn>
-                                        <p:tgtEl>
-                                          <p:spTgt spid="30"/>
-                                        </p:tgtEl>
-                                        <p:attrNameLst>
-                                          <p:attrName>style.visibility</p:attrName>
-                                        </p:attrNameLst>
-                                      </p:cBhvr>
-                                      <p:to>
-                                        <p:strVal val="visible"/>
-                                      </p:to>
-                                    </p:set>
-                                    <p:anim calcmode="lin" valueType="num">
-                                      <p:cBhvr additive="base">
-                                        <p:cTn id="31" dur="500" fill="hold"/>
-                                        <p:tgtEl>
-                                          <p:spTgt spid="30"/>
-                                        </p:tgtEl>
-                                        <p:attrNameLst>
-                                          <p:attrName>ppt_x</p:attrName>
-                                        </p:attrNameLst>
-                                      </p:cBhvr>
-                                      <p:tavLst>
-                                        <p:tav tm="0">
-                                          <p:val>
-                                            <p:strVal val="#ppt_x"/>
-                                          </p:val>
-                                        </p:tav>
-                                        <p:tav tm="100000">
-                                          <p:val>
-                                            <p:strVal val="#ppt_x"/>
-                                          </p:val>
-                                        </p:tav>
-                                      </p:tavLst>
-                                    </p:anim>
-                                    <p:anim calcmode="lin" valueType="num">
-                                      <p:cBhvr additive="base">
-                                        <p:cTn id="32" dur="500" fill="hold"/>
-                                        <p:tgtEl>
-                                          <p:spTgt spid="30"/>
-                                        </p:tgtEl>
-                                        <p:attrNameLst>
-                                          <p:attrName>ppt_y</p:attrName>
-                                        </p:attrNameLst>
-                                      </p:cBhvr>
-                                      <p:tavLst>
-                                        <p:tav tm="0">
-                                          <p:val>
-                                            <p:strVal val="1+#ppt_h/2"/>
-                                          </p:val>
-                                        </p:tav>
-                                        <p:tav tm="100000">
-                                          <p:val>
-                                            <p:strVal val="#ppt_y"/>
-                                          </p:val>
-                                        </p:tav>
-                                      </p:tavLst>
-                                    </p:anim>
-                                  </p:childTnLst>
-                                </p:cTn>
-                              </p:par>
-                              <p:par>
-                                <p:cTn id="33" presetID="2" presetClass="entr" presetSubtype="4" fill="hold" nodeType="withEffect">
-                                  <p:stCondLst>
-                                    <p:cond delay="0"/>
-                                  </p:stCondLst>
-                                  <p:childTnLst>
-                                    <p:set>
-                                      <p:cBhvr>
-                                        <p:cTn id="34" dur="1" fill="hold">
-                                          <p:stCondLst>
-                                            <p:cond delay="0"/>
-                                          </p:stCondLst>
-                                        </p:cTn>
-                                        <p:tgtEl>
-                                          <p:spTgt spid="40"/>
-                                        </p:tgtEl>
-                                        <p:attrNameLst>
-                                          <p:attrName>style.visibility</p:attrName>
-                                        </p:attrNameLst>
-                                      </p:cBhvr>
-                                      <p:to>
-                                        <p:strVal val="visible"/>
-                                      </p:to>
-                                    </p:set>
-                                    <p:anim calcmode="lin" valueType="num">
-                                      <p:cBhvr additive="base">
-                                        <p:cTn id="35" dur="500" fill="hold"/>
-                                        <p:tgtEl>
-                                          <p:spTgt spid="40"/>
-                                        </p:tgtEl>
-                                        <p:attrNameLst>
-                                          <p:attrName>ppt_x</p:attrName>
-                                        </p:attrNameLst>
-                                      </p:cBhvr>
-                                      <p:tavLst>
-                                        <p:tav tm="0">
-                                          <p:val>
-                                            <p:strVal val="#ppt_x"/>
-                                          </p:val>
-                                        </p:tav>
-                                        <p:tav tm="100000">
-                                          <p:val>
-                                            <p:strVal val="#ppt_x"/>
-                                          </p:val>
-                                        </p:tav>
-                                      </p:tavLst>
-                                    </p:anim>
-                                    <p:anim calcmode="lin" valueType="num">
-                                      <p:cBhvr additive="base">
-                                        <p:cTn id="36" dur="500" fill="hold"/>
-                                        <p:tgtEl>
-                                          <p:spTgt spid="40"/>
-                                        </p:tgtEl>
-                                        <p:attrNameLst>
-                                          <p:attrName>ppt_y</p:attrName>
-                                        </p:attrNameLst>
-                                      </p:cBhvr>
-                                      <p:tavLst>
-                                        <p:tav tm="0">
-                                          <p:val>
-                                            <p:strVal val="1+#ppt_h/2"/>
-                                          </p:val>
-                                        </p:tav>
-                                        <p:tav tm="100000">
-                                          <p:val>
-                                            <p:strVal val="#ppt_y"/>
-                                          </p:val>
-                                        </p:tav>
-                                      </p:tavLst>
-                                    </p:anim>
-                                  </p:childTnLst>
-                                </p:cTn>
-                              </p:par>
-                              <p:par>
-                                <p:cTn id="37" presetID="2" presetClass="entr" presetSubtype="4" fill="hold" nodeType="withEffect">
-                                  <p:stCondLst>
-                                    <p:cond delay="0"/>
-                                  </p:stCondLst>
-                                  <p:childTnLst>
-                                    <p:set>
-                                      <p:cBhvr>
-                                        <p:cTn id="38" dur="1" fill="hold">
-                                          <p:stCondLst>
-                                            <p:cond delay="0"/>
-                                          </p:stCondLst>
-                                        </p:cTn>
-                                        <p:tgtEl>
-                                          <p:spTgt spid="26"/>
-                                        </p:tgtEl>
-                                        <p:attrNameLst>
-                                          <p:attrName>style.visibility</p:attrName>
-                                        </p:attrNameLst>
-                                      </p:cBhvr>
-                                      <p:to>
-                                        <p:strVal val="visible"/>
-                                      </p:to>
-                                    </p:set>
-                                    <p:anim calcmode="lin" valueType="num">
-                                      <p:cBhvr additive="base">
-                                        <p:cTn id="39" dur="500" fill="hold"/>
-                                        <p:tgtEl>
-                                          <p:spTgt spid="26"/>
-                                        </p:tgtEl>
-                                        <p:attrNameLst>
-                                          <p:attrName>ppt_x</p:attrName>
-                                        </p:attrNameLst>
-                                      </p:cBhvr>
-                                      <p:tavLst>
-                                        <p:tav tm="0">
-                                          <p:val>
-                                            <p:strVal val="#ppt_x"/>
-                                          </p:val>
-                                        </p:tav>
-                                        <p:tav tm="100000">
-                                          <p:val>
-                                            <p:strVal val="#ppt_x"/>
-                                          </p:val>
-                                        </p:tav>
-                                      </p:tavLst>
-                                    </p:anim>
-                                    <p:anim calcmode="lin" valueType="num">
-                                      <p:cBhvr additive="base">
-                                        <p:cTn id="40" dur="500" fill="hold"/>
-                                        <p:tgtEl>
-                                          <p:spTgt spid="26"/>
-                                        </p:tgtEl>
-                                        <p:attrNameLst>
-                                          <p:attrName>ppt_y</p:attrName>
-                                        </p:attrNameLst>
-                                      </p:cBhvr>
-                                      <p:tavLst>
-                                        <p:tav tm="0">
-                                          <p:val>
-                                            <p:strVal val="1+#ppt_h/2"/>
-                                          </p:val>
-                                        </p:tav>
-                                        <p:tav tm="100000">
-                                          <p:val>
-                                            <p:strVal val="#ppt_y"/>
-                                          </p:val>
-                                        </p:tav>
-                                      </p:tavLst>
-                                    </p:anim>
-                                  </p:childTnLst>
-                                </p:cTn>
-                              </p:par>
-                              <p:par>
-                                <p:cTn id="41" presetID="2" presetClass="entr" presetSubtype="4" fill="hold" nodeType="withEffect">
-                                  <p:stCondLst>
-                                    <p:cond delay="0"/>
-                                  </p:stCondLst>
-                                  <p:childTnLst>
-                                    <p:set>
-                                      <p:cBhvr>
-                                        <p:cTn id="42" dur="1" fill="hold">
-                                          <p:stCondLst>
-                                            <p:cond delay="0"/>
-                                          </p:stCondLst>
-                                        </p:cTn>
-                                        <p:tgtEl>
-                                          <p:spTgt spid="36"/>
-                                        </p:tgtEl>
-                                        <p:attrNameLst>
-                                          <p:attrName>style.visibility</p:attrName>
-                                        </p:attrNameLst>
-                                      </p:cBhvr>
-                                      <p:to>
-                                        <p:strVal val="visible"/>
-                                      </p:to>
-                                    </p:set>
-                                    <p:anim calcmode="lin" valueType="num">
-                                      <p:cBhvr additive="base">
-                                        <p:cTn id="43" dur="500" fill="hold"/>
-                                        <p:tgtEl>
-                                          <p:spTgt spid="36"/>
-                                        </p:tgtEl>
-                                        <p:attrNameLst>
-                                          <p:attrName>ppt_x</p:attrName>
-                                        </p:attrNameLst>
-                                      </p:cBhvr>
-                                      <p:tavLst>
-                                        <p:tav tm="0">
-                                          <p:val>
-                                            <p:strVal val="#ppt_x"/>
-                                          </p:val>
-                                        </p:tav>
-                                        <p:tav tm="100000">
-                                          <p:val>
-                                            <p:strVal val="#ppt_x"/>
-                                          </p:val>
-                                        </p:tav>
-                                      </p:tavLst>
-                                    </p:anim>
-                                    <p:anim calcmode="lin" valueType="num">
-                                      <p:cBhvr additive="base">
-                                        <p:cTn id="44" dur="500" fill="hold"/>
-                                        <p:tgtEl>
-                                          <p:spTgt spid="36"/>
-                                        </p:tgtEl>
-                                        <p:attrNameLst>
-                                          <p:attrName>ppt_y</p:attrName>
-                                        </p:attrNameLst>
-                                      </p:cBhvr>
-                                      <p:tavLst>
-                                        <p:tav tm="0">
-                                          <p:val>
-                                            <p:strVal val="1+#ppt_h/2"/>
-                                          </p:val>
-                                        </p:tav>
-                                        <p:tav tm="100000">
-                                          <p:val>
-                                            <p:strVal val="#ppt_y"/>
-                                          </p:val>
-                                        </p:tav>
-                                      </p:tavLst>
-                                    </p:anim>
-                                  </p:childTnLst>
-                                </p:cTn>
-                              </p:par>
-                              <p:par>
-                                <p:cTn id="45" presetID="2" presetClass="entr" presetSubtype="4" fill="hold" nodeType="withEffect">
-                                  <p:stCondLst>
-                                    <p:cond delay="0"/>
-                                  </p:stCondLst>
-                                  <p:childTnLst>
-                                    <p:set>
-                                      <p:cBhvr>
-                                        <p:cTn id="46" dur="1" fill="hold">
-                                          <p:stCondLst>
-                                            <p:cond delay="0"/>
-                                          </p:stCondLst>
-                                        </p:cTn>
-                                        <p:tgtEl>
-                                          <p:spTgt spid="32"/>
-                                        </p:tgtEl>
-                                        <p:attrNameLst>
-                                          <p:attrName>style.visibility</p:attrName>
-                                        </p:attrNameLst>
-                                      </p:cBhvr>
-                                      <p:to>
-                                        <p:strVal val="visible"/>
-                                      </p:to>
-                                    </p:set>
-                                    <p:anim calcmode="lin" valueType="num">
-                                      <p:cBhvr additive="base">
-                                        <p:cTn id="47" dur="500" fill="hold"/>
-                                        <p:tgtEl>
-                                          <p:spTgt spid="32"/>
-                                        </p:tgtEl>
-                                        <p:attrNameLst>
-                                          <p:attrName>ppt_x</p:attrName>
-                                        </p:attrNameLst>
-                                      </p:cBhvr>
-                                      <p:tavLst>
-                                        <p:tav tm="0">
-                                          <p:val>
-                                            <p:strVal val="#ppt_x"/>
-                                          </p:val>
-                                        </p:tav>
-                                        <p:tav tm="100000">
-                                          <p:val>
-                                            <p:strVal val="#ppt_x"/>
-                                          </p:val>
-                                        </p:tav>
-                                      </p:tavLst>
-                                    </p:anim>
-                                    <p:anim calcmode="lin" valueType="num">
-                                      <p:cBhvr additive="base">
-                                        <p:cTn id="48" dur="500" fill="hold"/>
-                                        <p:tgtEl>
-                                          <p:spTgt spid="32"/>
-                                        </p:tgtEl>
-                                        <p:attrNameLst>
-                                          <p:attrName>ppt_y</p:attrName>
-                                        </p:attrNameLst>
-                                      </p:cBhvr>
-                                      <p:tavLst>
-                                        <p:tav tm="0">
-                                          <p:val>
-                                            <p:strVal val="1+#ppt_h/2"/>
-                                          </p:val>
-                                        </p:tav>
-                                        <p:tav tm="100000">
-                                          <p:val>
-                                            <p:strVal val="#ppt_y"/>
-                                          </p:val>
-                                        </p:tav>
-                                      </p:tavLst>
-                                    </p:anim>
-                                  </p:childTnLst>
-                                </p:cTn>
-                              </p:par>
-                              <p:par>
-                                <p:cTn id="49" presetID="2" presetClass="entr" presetSubtype="4" fill="hold" nodeType="withEffect">
-                                  <p:stCondLst>
-                                    <p:cond delay="0"/>
-                                  </p:stCondLst>
-                                  <p:childTnLst>
-                                    <p:set>
-                                      <p:cBhvr>
-                                        <p:cTn id="50" dur="1" fill="hold">
-                                          <p:stCondLst>
-                                            <p:cond delay="0"/>
-                                          </p:stCondLst>
-                                        </p:cTn>
-                                        <p:tgtEl>
-                                          <p:spTgt spid="44"/>
-                                        </p:tgtEl>
-                                        <p:attrNameLst>
-                                          <p:attrName>style.visibility</p:attrName>
-                                        </p:attrNameLst>
-                                      </p:cBhvr>
-                                      <p:to>
-                                        <p:strVal val="visible"/>
-                                      </p:to>
-                                    </p:set>
-                                    <p:anim calcmode="lin" valueType="num">
-                                      <p:cBhvr additive="base">
-                                        <p:cTn id="51" dur="500" fill="hold"/>
-                                        <p:tgtEl>
-                                          <p:spTgt spid="44"/>
-                                        </p:tgtEl>
-                                        <p:attrNameLst>
-                                          <p:attrName>ppt_x</p:attrName>
-                                        </p:attrNameLst>
-                                      </p:cBhvr>
-                                      <p:tavLst>
-                                        <p:tav tm="0">
-                                          <p:val>
-                                            <p:strVal val="#ppt_x"/>
-                                          </p:val>
-                                        </p:tav>
-                                        <p:tav tm="100000">
-                                          <p:val>
-                                            <p:strVal val="#ppt_x"/>
-                                          </p:val>
-                                        </p:tav>
-                                      </p:tavLst>
-                                    </p:anim>
-                                    <p:anim calcmode="lin" valueType="num">
-                                      <p:cBhvr additive="base">
-                                        <p:cTn id="52" dur="500" fill="hold"/>
-                                        <p:tgtEl>
-                                          <p:spTgt spid="44"/>
-                                        </p:tgtEl>
-                                        <p:attrNameLst>
-                                          <p:attrName>ppt_y</p:attrName>
-                                        </p:attrNameLst>
-                                      </p:cBhvr>
-                                      <p:tavLst>
-                                        <p:tav tm="0">
-                                          <p:val>
-                                            <p:strVal val="1+#ppt_h/2"/>
-                                          </p:val>
-                                        </p:tav>
-                                        <p:tav tm="100000">
-                                          <p:val>
-                                            <p:strVal val="#ppt_y"/>
-                                          </p:val>
-                                        </p:tav>
-                                      </p:tavLst>
-                                    </p:anim>
-                                  </p:childTnLst>
-                                </p:cTn>
-                              </p:par>
-                            </p:childTnLst>
-                          </p:cTn>
-                        </p:par>
-                      </p:childTnLst>
-                    </p:cTn>
-                  </p:par>
-                </p:childTnLst>
-              </p:cTn>
-              <p:prevCondLst>
-                <p:cond evt="onPrev" delay="0">
-                  <p:tgtEl>
-                    <p:sldTgt/>
-                  </p:tgtEl>
-                </p:cond>
-              </p:prevCondLst>
-              <p:nextCondLst>
-                <p:cond evt="onNext" delay="0">
-                  <p:tgtEl>
-                    <p:sldTgt/>
-                  </p:tgtEl>
-                </p:cond>
-              </p:nextCondLst>
-            </p:seq>
-          </p:childTnLst>
-        </p:cTn>
-      </p:par>
-    </p:tnLst>
-  </p:timing>
 </p:sld>
 </file>
 

</xml_diff>